<commit_message>
Plainer wording for the science/curatorial split
"How a drought or a flood should feel is decided in one place, so it can change without touching the science" was hard to follow. Now: the science layer measures what happened; the curatorial layer decides what a drought or flood should feel like (how alarming, how heavy); they are kept separate so the feeling can be redesigned without changing any measurement. Updated on slide 4, its speaker notes, and the README summary.

Co-Authored-By: Claude Sonnet 5.5 <noreply@anthropic.com>
</commit_message>
<xml_diff>
--- a/docs/noea-introduction.pptx
+++ b/docs/noea-introduction.pptx
@@ -718,7 +718,7 @@
           <a:lstStyle/>
           <a:p>
             <a:r>
-              <a:t>There are two layers, kept deliberately apart. The first is plain science: for Hong Kong, over a century of daily rainfall from the Observatory; for the Rhine and its alpine tributaries, eight stations of discharge. The second layer is curatorial. How a drought or a flood should feel is decided in one place, so it can change without touching the science.</a:t>
+              <a:t>There are two layers, kept deliberately apart. The first is plain science: it measures what happened. For Hong Kong, over a century of daily rainfall from the Observatory; for the Rhine and its alpine tributaries, eight stations of discharge. The second layer is curatorial: it decides what a drought or a flood should feel like, how alarming or how heavy. It is kept separate from the measurements, so the feeling can be redesigned without changing any of the science.</a:t>
             </a:r>
           </a:p>
         </p:txBody>
@@ -5793,7 +5793,7 @@
                 </a:solidFill>
                 <a:latin typeface="Helvetica Neue"/>
               </a:rPr>
-              <a:t>Never changes for artistic reasons.</a:t>
+              <a:t>Measures what happened. The measurements are never adjusted for artistic reasons.</a:t>
             </a:r>
           </a:p>
         </p:txBody>
@@ -5951,7 +5951,7 @@
                 </a:solidFill>
                 <a:latin typeface="Helvetica Neue"/>
               </a:rPr>
-              <a:t>How a drought or a flood should feel.</a:t>
+              <a:t>Decides what a drought or a flood should feel like: how alarming, how heavy.</a:t>
             </a:r>
           </a:p>
           <a:p>
@@ -5970,7 +5970,7 @@
                 </a:solidFill>
                 <a:latin typeface="Helvetica Neue"/>
               </a:rPr>
-              <a:t>Decided in one place, so it can change without touching the science.</a:t>
+              <a:t>Kept separate from the measurements, so the feeling can be redesigned without changing any of the science.</a:t>
             </a:r>
           </a:p>
           <a:p>

</xml_diff>

<commit_message>
Redesign the intro deck: Athelas and Frutiger, minimalist, logo on every slide
Restyled to the studio's identity: Athelas for headings, Frutiger for text, a white page, thin rules instead of shaded boxes, and a palette taken from the logo itself (deep blue, teal, ice). The Meeting of Waters logo sits bottom-left on every slide. Both figures were redrawn in the same palette and typeface.

The closing slide is reframed from a limitations list to the human question, since the end result of an unsupervised model is how people respond to it: do they perceive what is intended, do they understand what a flag (or a missing flag) means, does it help them decide. "It misses droughts" becomes a trust question inside that frame: a drought looks like an ordinary dry year to the learned model.

README gains a short paragraph stating the human side is untested.

Co-Authored-By: Claude Sonnet 5.5 <noreply@anthropic.com>
</commit_message>
<xml_diff>
--- a/docs/noea-introduction.pptx
+++ b/docs/noea-introduction.pptx
@@ -928,7 +928,7 @@
           <a:lstStyle/>
           <a:p>
             <a:r>
-              <a:t>What it doesn't do yet: it misses droughts. And most importantly, nobody has tested whether people feel what the system intends. That is the research: learning the mapping from human responses, and testing it with the people who have to decide.</a:t>
+              <a:t>The model's output is a score, not a feeling. What a flagged year should feel like, and whether people actually feel it, comes from people, not from the model. So the real result is how people respond: whether they perceive what the system intends, whether they understand what a flag, or a missing flag, means, and whether it helps the people who have to decide. That is the research, and nobody has tested it yet.</a:t>
             </a:r>
           </a:p>
         </p:txBody>
@@ -3930,7 +3930,7 @@
     <p:bg>
       <p:bgPr>
         <a:solidFill>
-          <a:srgbClr val="F6F9FB"/>
+          <a:srgbClr val="FFFFFF"/>
         </a:solidFill>
         <a:effectLst/>
       </p:bgPr>
@@ -3950,8 +3950,8 @@
         </p:nvSpPr>
         <p:spPr>
           <a:xfrm>
-            <a:off x="731520" y="868680"/>
-            <a:ext cx="10058400" cy="1554480"/>
+            <a:off x="914400" y="594360"/>
+            <a:ext cx="8229600" cy="1828800"/>
           </a:xfrm>
           <a:prstGeom prst="rect">
             <a:avLst/>
@@ -3966,11 +3966,11 @@
           <a:p>
             <a:pPr algn="l"/>
             <a:r>
-              <a:rPr sz="9600" b="1" i="0">
-                <a:solidFill>
-                  <a:srgbClr val="0B2545"/>
-                </a:solidFill>
-                <a:latin typeface="Georgia"/>
+              <a:rPr sz="11200" b="0" i="0">
+                <a:solidFill>
+                  <a:srgbClr val="111A20"/>
+                </a:solidFill>
+                <a:latin typeface="Athelas"/>
               </a:rPr>
               <a:t>Noéa</a:t>
             </a:r>
@@ -3985,8 +3985,8 @@
         </p:nvSpPr>
         <p:spPr>
           <a:xfrm>
-            <a:off x="731520" y="2514600"/>
-            <a:ext cx="10515600" cy="640080"/>
+            <a:off x="914400" y="2377440"/>
+            <a:ext cx="10362895" cy="640080"/>
           </a:xfrm>
           <a:prstGeom prst="rect">
             <a:avLst/>
@@ -4001,11 +4001,11 @@
           <a:p>
             <a:pPr algn="l"/>
             <a:r>
-              <a:rPr sz="3200" b="0" i="0">
-                <a:solidFill>
-                  <a:srgbClr val="2E6F9E"/>
-                </a:solidFill>
-                <a:latin typeface="Helvetica Neue"/>
+              <a:rPr sz="3000" b="0" i="1">
+                <a:solidFill>
+                  <a:srgbClr val="00526F"/>
+                </a:solidFill>
+                <a:latin typeface="Athelas"/>
               </a:rPr>
               <a:t>Reading water as rhythm, memory and mood</a:t>
             </a:r>
@@ -4020,8 +4020,8 @@
         </p:nvSpPr>
         <p:spPr>
           <a:xfrm>
-            <a:off x="731520" y="3246120"/>
-            <a:ext cx="10515600" cy="365760"/>
+            <a:off x="914400" y="3017520"/>
+            <a:ext cx="10362895" cy="365760"/>
           </a:xfrm>
           <a:prstGeom prst="rect">
             <a:avLst/>
@@ -4036,20 +4036,20 @@
           <a:p>
             <a:pPr algn="l"/>
             <a:r>
-              <a:rPr sz="1700" b="0" i="0">
-                <a:solidFill>
-                  <a:srgbClr val="5C6F7B"/>
-                </a:solidFill>
-                <a:latin typeface="Helvetica Neue"/>
+              <a:rPr sz="1600" b="0" i="0">
+                <a:solidFill>
+                  <a:srgbClr val="5F6F78"/>
+                </a:solidFill>
+                <a:latin typeface="Frutiger"/>
               </a:rPr>
-              <a:t>Affective computing for water systems  ·  Meeting of Waters, Geneva</a:t>
+              <a:t>Affective computing for water systems</a:t>
             </a:r>
           </a:p>
         </p:txBody>
       </p:sp>
       <p:pic>
         <p:nvPicPr>
-          <p:cNvPr id="5" name="Picture 4" descr="cover_pulse.png"/>
+          <p:cNvPr id="5" name="Picture 4" descr="cover_pulse2.png"/>
           <p:cNvPicPr>
             <a:picLocks noChangeAspect="1"/>
           </p:cNvPicPr>
@@ -4063,8 +4063,8 @@
         </p:blipFill>
         <p:spPr>
           <a:xfrm>
-            <a:off x="0" y="3703320"/>
-            <a:ext cx="12191695" cy="2377975"/>
+            <a:off x="914400" y="3520440"/>
+            <a:ext cx="10362895" cy="2012697"/>
           </a:xfrm>
           <a:prstGeom prst="rect">
             <a:avLst/>
@@ -4079,8 +4079,8 @@
         </p:nvSpPr>
         <p:spPr>
           <a:xfrm>
-            <a:off x="731520" y="6291072"/>
-            <a:ext cx="10789920" cy="365760"/>
+            <a:off x="914400" y="5577840"/>
+            <a:ext cx="10362895" cy="365760"/>
           </a:xfrm>
           <a:prstGeom prst="rect">
             <a:avLst/>
@@ -4095,17 +4095,41 @@
           <a:p>
             <a:pPr algn="l"/>
             <a:r>
-              <a:rPr sz="1200" b="0" i="0">
-                <a:solidFill>
-                  <a:srgbClr val="5C6F7B"/>
-                </a:solidFill>
-                <a:latin typeface="Helvetica Neue"/>
+              <a:rPr sz="1100" b="0" i="0">
+                <a:solidFill>
+                  <a:srgbClr val="5F6F78"/>
+                </a:solidFill>
+                <a:latin typeface="Frutiger"/>
               </a:rPr>
               <a:t>Annual peak daily rainfall, Hong Kong, 1884–2025, drawn as a pulse. The flat stretch is 1940–46, missing from the record.</a:t>
             </a:r>
           </a:p>
         </p:txBody>
       </p:sp>
+      <p:pic>
+        <p:nvPicPr>
+          <p:cNvPr id="7" name="Picture 6" descr="logo.png"/>
+          <p:cNvPicPr>
+            <a:picLocks noChangeAspect="1"/>
+          </p:cNvPicPr>
+          <p:nvPr/>
+        </p:nvPicPr>
+        <p:blipFill>
+          <a:blip r:embed="rId4"/>
+          <a:stretch>
+            <a:fillRect/>
+          </a:stretch>
+        </p:blipFill>
+        <p:spPr>
+          <a:xfrm>
+            <a:off x="914400" y="6236208"/>
+            <a:ext cx="2120348" cy="292608"/>
+          </a:xfrm>
+          <a:prstGeom prst="rect">
+            <a:avLst/>
+          </a:prstGeom>
+        </p:spPr>
+      </p:pic>
     </p:spTree>
   </p:cSld>
   <p:clrMapOvr>
@@ -4120,7 +4144,7 @@
     <p:bg>
       <p:bgPr>
         <a:solidFill>
-          <a:srgbClr val="F6F9FB"/>
+          <a:srgbClr val="FFFFFF"/>
         </a:solidFill>
         <a:effectLst/>
       </p:bgPr>
@@ -4140,8 +4164,8 @@
         </p:nvSpPr>
         <p:spPr>
           <a:xfrm>
-            <a:off x="731520" y="640080"/>
-            <a:ext cx="10698480" cy="1463040"/>
+            <a:off x="914400" y="685800"/>
+            <a:ext cx="10362895" cy="1371600"/>
           </a:xfrm>
           <a:prstGeom prst="rect">
             <a:avLst/>
@@ -4160,63 +4184,52 @@
               </a:lnSpc>
             </a:pPr>
             <a:r>
-              <a:rPr sz="3800" b="1" i="0">
-                <a:solidFill>
-                  <a:srgbClr val="0B2545"/>
-                </a:solidFill>
-                <a:latin typeface="Georgia"/>
+              <a:rPr sz="4000" b="0" i="0">
+                <a:solidFill>
+                  <a:srgbClr val="111A20"/>
+                </a:solidFill>
+                <a:latin typeface="Athelas"/>
               </a:rPr>
               <a:t>Data can show that a river is changing. It rarely makes anyone feel it.</a:t>
             </a:r>
           </a:p>
         </p:txBody>
       </p:sp>
-      <p:sp>
-        <p:nvSpPr>
-          <p:cNvPr id="3" name="Rounded Rectangle 2"/>
-          <p:cNvSpPr/>
-          <p:nvPr/>
-        </p:nvSpPr>
-        <p:spPr>
-          <a:xfrm>
-            <a:off x="731520" y="2926080"/>
-            <a:ext cx="3017520" cy="2377440"/>
-          </a:xfrm>
-          <a:prstGeom prst="roundRect">
-            <a:avLst>
-              <a:gd name="adj" fmla="val 5000"/>
-            </a:avLst>
-          </a:prstGeom>
-          <a:solidFill>
-            <a:srgbClr val="EAF1F6"/>
-          </a:solidFill>
-          <a:ln>
-            <a:noFill/>
+      <p:cxnSp>
+        <p:nvCxnSpPr>
+          <p:cNvPr id="3" name="Connector 2"/>
+          <p:cNvCxnSpPr/>
+          <p:nvPr/>
+        </p:nvCxnSpPr>
+        <p:spPr>
+          <a:xfrm>
+            <a:off x="914400" y="3246120"/>
+            <a:ext cx="3200400" cy="0"/>
+          </a:xfrm>
+          <a:prstGeom prst="line">
+            <a:avLst/>
+          </a:prstGeom>
+          <a:ln w="15875">
+            <a:solidFill>
+              <a:srgbClr val="D3DDE2"/>
+            </a:solidFill>
           </a:ln>
-          <a:effectLst/>
         </p:spPr>
         <p:style>
-          <a:lnRef idx="1">
+          <a:lnRef idx="2">
             <a:schemeClr val="accent1"/>
           </a:lnRef>
-          <a:fillRef idx="3">
+          <a:fillRef idx="0">
             <a:schemeClr val="accent1"/>
           </a:fillRef>
-          <a:effectRef idx="2">
+          <a:effectRef idx="1">
             <a:schemeClr val="accent1"/>
           </a:effectRef>
           <a:fontRef idx="minor">
-            <a:schemeClr val="lt1"/>
+            <a:schemeClr val="tx1"/>
           </a:fontRef>
         </p:style>
-        <p:txBody>
-          <a:bodyPr rtlCol="0" anchor="ctr"/>
-          <a:lstStyle/>
-          <a:p>
-            <a:pPr algn="ctr"/>
-          </a:p>
-        </p:txBody>
-      </p:sp>
+      </p:cxnSp>
       <p:sp>
         <p:nvSpPr>
           <p:cNvPr id="4" name="TextBox 3"/>
@@ -4225,8 +4238,8 @@
         </p:nvSpPr>
         <p:spPr>
           <a:xfrm>
-            <a:off x="1005840" y="3200400"/>
-            <a:ext cx="2468880" cy="457200"/>
+            <a:off x="914400" y="3520439"/>
+            <a:ext cx="3200400" cy="274320"/>
           </a:xfrm>
           <a:prstGeom prst="rect">
             <a:avLst/>
@@ -4241,13 +4254,13 @@
           <a:p>
             <a:pPr algn="l"/>
             <a:r>
-              <a:rPr sz="2600" b="1" i="0">
-                <a:solidFill>
-                  <a:srgbClr val="0B2545"/>
-                </a:solidFill>
-                <a:latin typeface="Georgia"/>
+              <a:rPr sz="1200" b="1" i="0" spc="140">
+                <a:solidFill>
+                  <a:srgbClr val="5F6F78"/>
+                </a:solidFill>
+                <a:latin typeface="Frutiger"/>
               </a:rPr>
-              <a:t>Detect</a:t>
+              <a:t>DETECT</a:t>
             </a:r>
           </a:p>
         </p:txBody>
@@ -4260,8 +4273,8 @@
         </p:nvSpPr>
         <p:spPr>
           <a:xfrm>
-            <a:off x="1005840" y="3840480"/>
-            <a:ext cx="2468880" cy="1371600"/>
+            <a:off x="914400" y="4023359"/>
+            <a:ext cx="3017520" cy="1463040"/>
           </a:xfrm>
           <a:prstGeom prst="rect">
             <a:avLst/>
@@ -4276,121 +4289,175 @@
           <a:p>
             <a:pPr algn="l">
               <a:lnSpc>
-                <a:spcPct val="110000"/>
+                <a:spcPct val="112000"/>
               </a:lnSpc>
             </a:pPr>
             <a:r>
-              <a:rPr sz="1900" b="0" i="0">
-                <a:solidFill>
-                  <a:srgbClr val="0B2545"/>
-                </a:solidFill>
-                <a:latin typeface="Helvetica Neue"/>
+              <a:rPr sz="2400" b="0" i="0">
+                <a:solidFill>
+                  <a:srgbClr val="111A20"/>
+                </a:solidFill>
+                <a:latin typeface="Athelas"/>
               </a:rPr>
               <a:t>Stations now measure rainfall, rivers and glaciers at scale.</a:t>
             </a:r>
           </a:p>
         </p:txBody>
       </p:sp>
-      <p:sp>
-        <p:nvSpPr>
-          <p:cNvPr id="6" name="Right Arrow 5"/>
-          <p:cNvSpPr/>
-          <p:nvPr/>
-        </p:nvSpPr>
-        <p:spPr>
-          <a:xfrm>
-            <a:off x="3813048" y="3931920"/>
-            <a:ext cx="411480" cy="365760"/>
-          </a:xfrm>
-          <a:prstGeom prst="rightArrow">
-            <a:avLst/>
-          </a:prstGeom>
-          <a:solidFill>
-            <a:srgbClr val="C9D8E3"/>
-          </a:solidFill>
-          <a:ln>
-            <a:noFill/>
+      <p:cxnSp>
+        <p:nvCxnSpPr>
+          <p:cNvPr id="6" name="Connector 5"/>
+          <p:cNvCxnSpPr/>
+          <p:nvPr/>
+        </p:nvCxnSpPr>
+        <p:spPr>
+          <a:xfrm>
+            <a:off x="4494276" y="3246120"/>
+            <a:ext cx="3200399" cy="0"/>
+          </a:xfrm>
+          <a:prstGeom prst="line">
+            <a:avLst/>
+          </a:prstGeom>
+          <a:ln w="38100">
+            <a:solidFill>
+              <a:srgbClr val="00526F"/>
+            </a:solidFill>
           </a:ln>
-          <a:effectLst/>
         </p:spPr>
         <p:style>
-          <a:lnRef idx="1">
+          <a:lnRef idx="2">
             <a:schemeClr val="accent1"/>
           </a:lnRef>
-          <a:fillRef idx="3">
+          <a:fillRef idx="0">
             <a:schemeClr val="accent1"/>
           </a:fillRef>
-          <a:effectRef idx="2">
+          <a:effectRef idx="1">
             <a:schemeClr val="accent1"/>
           </a:effectRef>
           <a:fontRef idx="minor">
-            <a:schemeClr val="lt1"/>
+            <a:schemeClr val="tx1"/>
           </a:fontRef>
         </p:style>
-        <p:txBody>
-          <a:bodyPr rtlCol="0" anchor="ctr"/>
-          <a:lstStyle/>
-          <a:p>
-            <a:pPr algn="ctr"/>
-          </a:p>
-        </p:txBody>
-      </p:sp>
-      <p:sp>
-        <p:nvSpPr>
-          <p:cNvPr id="7" name="Rounded Rectangle 6"/>
-          <p:cNvSpPr/>
-          <p:nvPr/>
-        </p:nvSpPr>
-        <p:spPr>
-          <a:xfrm>
-            <a:off x="4315968" y="2926080"/>
-            <a:ext cx="3703320" cy="2377440"/>
-          </a:xfrm>
-          <a:prstGeom prst="roundRect">
-            <a:avLst>
-              <a:gd name="adj" fmla="val 5000"/>
-            </a:avLst>
-          </a:prstGeom>
-          <a:solidFill>
-            <a:srgbClr val="0B2545"/>
-          </a:solidFill>
-          <a:ln>
-            <a:noFill/>
+      </p:cxnSp>
+      <p:sp>
+        <p:nvSpPr>
+          <p:cNvPr id="7" name="TextBox 6"/>
+          <p:cNvSpPr txBox="1"/>
+          <p:nvPr/>
+        </p:nvSpPr>
+        <p:spPr>
+          <a:xfrm>
+            <a:off x="4494276" y="3520439"/>
+            <a:ext cx="3200400" cy="274320"/>
+          </a:xfrm>
+          <a:prstGeom prst="rect">
+            <a:avLst/>
+          </a:prstGeom>
+          <a:noFill/>
+        </p:spPr>
+        <p:txBody>
+          <a:bodyPr wrap="square" lIns="0" rIns="0" tIns="0" bIns="0" anchor="t">
+            <a:noAutofit/>
+          </a:bodyPr>
+          <a:lstStyle/>
+          <a:p>
+            <a:pPr algn="l"/>
+            <a:r>
+              <a:rPr sz="1200" b="1" i="0" spc="140">
+                <a:solidFill>
+                  <a:srgbClr val="00526F"/>
+                </a:solidFill>
+                <a:latin typeface="Frutiger"/>
+              </a:rPr>
+              <a:t>THE MISSING LAYER</a:t>
+            </a:r>
+          </a:p>
+        </p:txBody>
+      </p:sp>
+      <p:sp>
+        <p:nvSpPr>
+          <p:cNvPr id="8" name="TextBox 7"/>
+          <p:cNvSpPr txBox="1"/>
+          <p:nvPr/>
+        </p:nvSpPr>
+        <p:spPr>
+          <a:xfrm>
+            <a:off x="4494276" y="4023359"/>
+            <a:ext cx="3017520" cy="1463040"/>
+          </a:xfrm>
+          <a:prstGeom prst="rect">
+            <a:avLst/>
+          </a:prstGeom>
+          <a:noFill/>
+        </p:spPr>
+        <p:txBody>
+          <a:bodyPr wrap="square" lIns="0" rIns="0" tIns="0" bIns="0" anchor="t">
+            <a:noAutofit/>
+          </a:bodyPr>
+          <a:lstStyle/>
+          <a:p>
+            <a:pPr algn="l">
+              <a:lnSpc>
+                <a:spcPct val="112000"/>
+              </a:lnSpc>
+            </a:pPr>
+            <a:r>
+              <a:rPr sz="2400" b="0" i="0">
+                <a:solidFill>
+                  <a:srgbClr val="111A20"/>
+                </a:solidFill>
+                <a:latin typeface="Athelas"/>
+              </a:rPr>
+              <a:t>Turning measurement into meaning people can experience.</a:t>
+            </a:r>
+          </a:p>
+        </p:txBody>
+      </p:sp>
+      <p:cxnSp>
+        <p:nvCxnSpPr>
+          <p:cNvPr id="9" name="Connector 8"/>
+          <p:cNvCxnSpPr/>
+          <p:nvPr/>
+        </p:nvCxnSpPr>
+        <p:spPr>
+          <a:xfrm>
+            <a:off x="8074152" y="3246120"/>
+            <a:ext cx="3200400" cy="0"/>
+          </a:xfrm>
+          <a:prstGeom prst="line">
+            <a:avLst/>
+          </a:prstGeom>
+          <a:ln w="15875">
+            <a:solidFill>
+              <a:srgbClr val="D3DDE2"/>
+            </a:solidFill>
           </a:ln>
-          <a:effectLst/>
         </p:spPr>
         <p:style>
-          <a:lnRef idx="1">
+          <a:lnRef idx="2">
             <a:schemeClr val="accent1"/>
           </a:lnRef>
-          <a:fillRef idx="3">
+          <a:fillRef idx="0">
             <a:schemeClr val="accent1"/>
           </a:fillRef>
-          <a:effectRef idx="2">
+          <a:effectRef idx="1">
             <a:schemeClr val="accent1"/>
           </a:effectRef>
           <a:fontRef idx="minor">
-            <a:schemeClr val="lt1"/>
+            <a:schemeClr val="tx1"/>
           </a:fontRef>
         </p:style>
-        <p:txBody>
-          <a:bodyPr rtlCol="0" anchor="ctr"/>
-          <a:lstStyle/>
-          <a:p>
-            <a:pPr algn="ctr"/>
-          </a:p>
-        </p:txBody>
-      </p:sp>
-      <p:sp>
-        <p:nvSpPr>
-          <p:cNvPr id="8" name="TextBox 7"/>
+      </p:cxnSp>
+      <p:sp>
+        <p:nvSpPr>
+          <p:cNvPr id="10" name="TextBox 9"/>
           <p:cNvSpPr txBox="1"/>
           <p:nvPr/>
         </p:nvSpPr>
         <p:spPr>
           <a:xfrm>
-            <a:off x="4617720" y="3200400"/>
-            <a:ext cx="3154680" cy="457200"/>
+            <a:off x="8074152" y="3520439"/>
+            <a:ext cx="3200400" cy="274320"/>
           </a:xfrm>
           <a:prstGeom prst="rect">
             <a:avLst/>
@@ -4405,27 +4472,27 @@
           <a:p>
             <a:pPr algn="l"/>
             <a:r>
-              <a:rPr sz="2600" b="1" i="0">
-                <a:solidFill>
-                  <a:srgbClr val="FFFFFF"/>
-                </a:solidFill>
-                <a:latin typeface="Georgia"/>
+              <a:rPr sz="1200" b="1" i="0" spc="140">
+                <a:solidFill>
+                  <a:srgbClr val="5F6F78"/>
+                </a:solidFill>
+                <a:latin typeface="Frutiger"/>
               </a:rPr>
-              <a:t>The missing layer</a:t>
-            </a:r>
-          </a:p>
-        </p:txBody>
-      </p:sp>
-      <p:sp>
-        <p:nvSpPr>
-          <p:cNvPr id="9" name="TextBox 8"/>
+              <a:t>RESPOND</a:t>
+            </a:r>
+          </a:p>
+        </p:txBody>
+      </p:sp>
+      <p:sp>
+        <p:nvSpPr>
+          <p:cNvPr id="11" name="TextBox 10"/>
           <p:cNvSpPr txBox="1"/>
           <p:nvPr/>
         </p:nvSpPr>
         <p:spPr>
           <a:xfrm>
-            <a:off x="4617720" y="3840480"/>
-            <a:ext cx="3154680" cy="1371600"/>
+            <a:off x="8074152" y="4023359"/>
+            <a:ext cx="3017520" cy="1463040"/>
           </a:xfrm>
           <a:prstGeom prst="rect">
             <a:avLst/>
@@ -4440,108 +4507,18 @@
           <a:p>
             <a:pPr algn="l">
               <a:lnSpc>
-                <a:spcPct val="110000"/>
+                <a:spcPct val="112000"/>
               </a:lnSpc>
             </a:pPr>
             <a:r>
-              <a:rPr sz="1900" b="0" i="0">
-                <a:solidFill>
-                  <a:srgbClr val="FFFFFF"/>
-                </a:solidFill>
-                <a:latin typeface="Helvetica Neue"/>
+              <a:rPr sz="2400" b="0" i="0">
+                <a:solidFill>
+                  <a:srgbClr val="111A20"/>
+                </a:solidFill>
+                <a:latin typeface="Athelas"/>
               </a:rPr>
-              <a:t>Turning measurement into meaning people can experience.</a:t>
-            </a:r>
-          </a:p>
-        </p:txBody>
-      </p:sp>
-      <p:sp>
-        <p:nvSpPr>
-          <p:cNvPr id="10" name="Right Arrow 9"/>
-          <p:cNvSpPr/>
-          <p:nvPr/>
-        </p:nvSpPr>
-        <p:spPr>
-          <a:xfrm>
-            <a:off x="8083296" y="3931920"/>
-            <a:ext cx="411480" cy="365760"/>
-          </a:xfrm>
-          <a:prstGeom prst="rightArrow">
-            <a:avLst/>
-          </a:prstGeom>
-          <a:solidFill>
-            <a:srgbClr val="C9D8E3"/>
-          </a:solidFill>
-          <a:ln>
-            <a:noFill/>
-          </a:ln>
-          <a:effectLst/>
-        </p:spPr>
-        <p:style>
-          <a:lnRef idx="1">
-            <a:schemeClr val="accent1"/>
-          </a:lnRef>
-          <a:fillRef idx="3">
-            <a:schemeClr val="accent1"/>
-          </a:fillRef>
-          <a:effectRef idx="2">
-            <a:schemeClr val="accent1"/>
-          </a:effectRef>
-          <a:fontRef idx="minor">
-            <a:schemeClr val="lt1"/>
-          </a:fontRef>
-        </p:style>
-        <p:txBody>
-          <a:bodyPr rtlCol="0" anchor="ctr"/>
-          <a:lstStyle/>
-          <a:p>
-            <a:pPr algn="ctr"/>
-          </a:p>
-        </p:txBody>
-      </p:sp>
-      <p:sp>
-        <p:nvSpPr>
-          <p:cNvPr id="11" name="Rounded Rectangle 10"/>
-          <p:cNvSpPr/>
-          <p:nvPr/>
-        </p:nvSpPr>
-        <p:spPr>
-          <a:xfrm>
-            <a:off x="8595360" y="2926080"/>
-            <a:ext cx="2880360" cy="2377440"/>
-          </a:xfrm>
-          <a:prstGeom prst="roundRect">
-            <a:avLst>
-              <a:gd name="adj" fmla="val 5000"/>
-            </a:avLst>
-          </a:prstGeom>
-          <a:solidFill>
-            <a:srgbClr val="EAF1F6"/>
-          </a:solidFill>
-          <a:ln>
-            <a:noFill/>
-          </a:ln>
-          <a:effectLst/>
-        </p:spPr>
-        <p:style>
-          <a:lnRef idx="1">
-            <a:schemeClr val="accent1"/>
-          </a:lnRef>
-          <a:fillRef idx="3">
-            <a:schemeClr val="accent1"/>
-          </a:fillRef>
-          <a:effectRef idx="2">
-            <a:schemeClr val="accent1"/>
-          </a:effectRef>
-          <a:fontRef idx="minor">
-            <a:schemeClr val="lt1"/>
-          </a:fontRef>
-        </p:style>
-        <p:txBody>
-          <a:bodyPr rtlCol="0" anchor="ctr"/>
-          <a:lstStyle/>
-          <a:p>
-            <a:pPr algn="ctr"/>
+              <a:t>Decisions stall between knowing and acting.</a:t>
+            </a:r>
           </a:p>
         </p:txBody>
       </p:sp>
@@ -4553,8 +4530,8 @@
         </p:nvSpPr>
         <p:spPr>
           <a:xfrm>
-            <a:off x="8869680" y="3200400"/>
-            <a:ext cx="2377440" cy="457200"/>
+            <a:off x="4494276" y="5349240"/>
+            <a:ext cx="3200400" cy="365760"/>
           </a:xfrm>
           <a:prstGeom prst="rect">
             <a:avLst/>
@@ -4569,27 +4546,51 @@
           <a:p>
             <a:pPr algn="l"/>
             <a:r>
-              <a:rPr sz="2600" b="1" i="0">
-                <a:solidFill>
-                  <a:srgbClr val="0B2545"/>
-                </a:solidFill>
-                <a:latin typeface="Georgia"/>
+              <a:rPr sz="1600" b="1" i="0">
+                <a:solidFill>
+                  <a:srgbClr val="00526F"/>
+                </a:solidFill>
+                <a:latin typeface="Frutiger"/>
               </a:rPr>
-              <a:t>Respond</a:t>
-            </a:r>
-          </a:p>
-        </p:txBody>
-      </p:sp>
-      <p:sp>
-        <p:nvSpPr>
-          <p:cNvPr id="13" name="TextBox 12"/>
+              <a:t>Noéa works in the middle.</a:t>
+            </a:r>
+          </a:p>
+        </p:txBody>
+      </p:sp>
+      <p:pic>
+        <p:nvPicPr>
+          <p:cNvPr id="13" name="Picture 12" descr="logo.png"/>
+          <p:cNvPicPr>
+            <a:picLocks noChangeAspect="1"/>
+          </p:cNvPicPr>
+          <p:nvPr/>
+        </p:nvPicPr>
+        <p:blipFill>
+          <a:blip r:embed="rId3"/>
+          <a:stretch>
+            <a:fillRect/>
+          </a:stretch>
+        </p:blipFill>
+        <p:spPr>
+          <a:xfrm>
+            <a:off x="914400" y="6236208"/>
+            <a:ext cx="2120348" cy="292608"/>
+          </a:xfrm>
+          <a:prstGeom prst="rect">
+            <a:avLst/>
+          </a:prstGeom>
+        </p:spPr>
+      </p:pic>
+      <p:sp>
+        <p:nvSpPr>
+          <p:cNvPr id="14" name="TextBox 13"/>
           <p:cNvSpPr txBox="1"/>
           <p:nvPr/>
         </p:nvSpPr>
         <p:spPr>
           <a:xfrm>
-            <a:off x="8869680" y="3840480"/>
-            <a:ext cx="2377440" cy="1371600"/>
+            <a:off x="10637215" y="6309360"/>
+            <a:ext cx="640080" cy="274320"/>
           </a:xfrm>
           <a:prstGeom prst="rect">
             <a:avLst/>
@@ -4602,122 +4603,13 @@
           </a:bodyPr>
           <a:lstStyle/>
           <a:p>
-            <a:pPr algn="l">
-              <a:lnSpc>
-                <a:spcPct val="110000"/>
-              </a:lnSpc>
-            </a:pPr>
-            <a:r>
-              <a:rPr sz="1900" b="0" i="0">
-                <a:solidFill>
-                  <a:srgbClr val="0B2545"/>
-                </a:solidFill>
-                <a:latin typeface="Helvetica Neue"/>
-              </a:rPr>
-              <a:t>Decisions stall between knowing and acting.</a:t>
-            </a:r>
-          </a:p>
-        </p:txBody>
-      </p:sp>
-      <p:sp>
-        <p:nvSpPr>
-          <p:cNvPr id="14" name="TextBox 13"/>
-          <p:cNvSpPr txBox="1"/>
-          <p:nvPr/>
-        </p:nvSpPr>
-        <p:spPr>
-          <a:xfrm>
-            <a:off x="731520" y="5577840"/>
-            <a:ext cx="10698480" cy="457200"/>
-          </a:xfrm>
-          <a:prstGeom prst="rect">
-            <a:avLst/>
-          </a:prstGeom>
-          <a:noFill/>
-        </p:spPr>
-        <p:txBody>
-          <a:bodyPr wrap="square" lIns="0" rIns="0" tIns="0" bIns="0" anchor="t">
-            <a:noAutofit/>
-          </a:bodyPr>
-          <a:lstStyle/>
-          <a:p>
-            <a:pPr algn="l"/>
-            <a:r>
-              <a:rPr sz="2000" b="1" i="0">
-                <a:solidFill>
-                  <a:srgbClr val="2E6F9E"/>
-                </a:solidFill>
-                <a:latin typeface="Helvetica Neue"/>
-              </a:rPr>
-              <a:t>Noéa works in the middle.</a:t>
-            </a:r>
-          </a:p>
-        </p:txBody>
-      </p:sp>
-      <p:sp>
-        <p:nvSpPr>
-          <p:cNvPr id="15" name="TextBox 14"/>
-          <p:cNvSpPr txBox="1"/>
-          <p:nvPr/>
-        </p:nvSpPr>
-        <p:spPr>
-          <a:xfrm>
-            <a:off x="731520" y="6419088"/>
-            <a:ext cx="7315200" cy="274320"/>
-          </a:xfrm>
-          <a:prstGeom prst="rect">
-            <a:avLst/>
-          </a:prstGeom>
-          <a:noFill/>
-        </p:spPr>
-        <p:txBody>
-          <a:bodyPr wrap="square" lIns="0" rIns="0" tIns="0" bIns="0" anchor="t">
-            <a:noAutofit/>
-          </a:bodyPr>
-          <a:lstStyle/>
-          <a:p>
-            <a:pPr algn="l"/>
+            <a:pPr algn="r"/>
             <a:r>
               <a:rPr sz="1100" b="0" i="0">
                 <a:solidFill>
-                  <a:srgbClr val="5C6F7B"/>
-                </a:solidFill>
-                <a:latin typeface="Helvetica Neue"/>
-              </a:rPr>
-              <a:t>Noéa  ·  Meeting of Waters, Geneva</a:t>
-            </a:r>
-          </a:p>
-        </p:txBody>
-      </p:sp>
-      <p:sp>
-        <p:nvSpPr>
-          <p:cNvPr id="16" name="TextBox 15"/>
-          <p:cNvSpPr txBox="1"/>
-          <p:nvPr/>
-        </p:nvSpPr>
-        <p:spPr>
-          <a:xfrm>
-            <a:off x="10881360" y="6419088"/>
-            <a:ext cx="594360" cy="274320"/>
-          </a:xfrm>
-          <a:prstGeom prst="rect">
-            <a:avLst/>
-          </a:prstGeom>
-          <a:noFill/>
-        </p:spPr>
-        <p:txBody>
-          <a:bodyPr wrap="square" lIns="0" rIns="0" tIns="0" bIns="0" anchor="t">
-            <a:noAutofit/>
-          </a:bodyPr>
-          <a:lstStyle/>
-          <a:p>
-            <a:pPr algn="r"/>
-            <a:r>
-              <a:rPr sz="1100" b="0" i="0">
-                <a:solidFill>
-                  <a:srgbClr val="5C6F7B"/>
-                </a:solidFill>
-                <a:latin typeface="Helvetica Neue"/>
+                  <a:srgbClr val="5F6F78"/>
+                </a:solidFill>
+                <a:latin typeface="Frutiger"/>
               </a:rPr>
               <a:t>2</a:t>
             </a:r>
@@ -4738,7 +4630,7 @@
     <p:bg>
       <p:bgPr>
         <a:solidFill>
-          <a:srgbClr val="F6F9FB"/>
+          <a:srgbClr val="FFFFFF"/>
         </a:solidFill>
         <a:effectLst/>
       </p:bgPr>
@@ -4758,8 +4650,8 @@
         </p:nvSpPr>
         <p:spPr>
           <a:xfrm>
-            <a:off x="731520" y="640080"/>
-            <a:ext cx="10698480" cy="1463040"/>
+            <a:off x="914400" y="685800"/>
+            <a:ext cx="10362895" cy="1371600"/>
           </a:xfrm>
           <a:prstGeom prst="rect">
             <a:avLst/>
@@ -4778,63 +4670,52 @@
               </a:lnSpc>
             </a:pPr>
             <a:r>
-              <a:rPr sz="3800" b="1" i="0">
-                <a:solidFill>
-                  <a:srgbClr val="0B2545"/>
-                </a:solidFill>
-                <a:latin typeface="Georgia"/>
+              <a:rPr sz="3600" b="0" i="0">
+                <a:solidFill>
+                  <a:srgbClr val="111A20"/>
+                </a:solidFill>
+                <a:latin typeface="Athelas"/>
               </a:rPr>
               <a:t>It reads a record the way a cardiologist reads an ECG</a:t>
             </a:r>
           </a:p>
         </p:txBody>
       </p:sp>
-      <p:sp>
-        <p:nvSpPr>
-          <p:cNvPr id="3" name="Rounded Rectangle 2"/>
-          <p:cNvSpPr/>
-          <p:nvPr/>
-        </p:nvSpPr>
-        <p:spPr>
-          <a:xfrm>
-            <a:off x="731520" y="2606040"/>
-            <a:ext cx="2331720" cy="3200400"/>
-          </a:xfrm>
-          <a:prstGeom prst="roundRect">
-            <a:avLst>
-              <a:gd name="adj" fmla="val 5000"/>
-            </a:avLst>
-          </a:prstGeom>
-          <a:solidFill>
-            <a:srgbClr val="EAF1F6"/>
-          </a:solidFill>
-          <a:ln>
-            <a:noFill/>
+      <p:cxnSp>
+        <p:nvCxnSpPr>
+          <p:cNvPr id="3" name="Connector 2"/>
+          <p:cNvCxnSpPr/>
+          <p:nvPr/>
+        </p:nvCxnSpPr>
+        <p:spPr>
+          <a:xfrm>
+            <a:off x="914400" y="2514600"/>
+            <a:ext cx="2377440" cy="0"/>
+          </a:xfrm>
+          <a:prstGeom prst="line">
+            <a:avLst/>
+          </a:prstGeom>
+          <a:ln w="15875">
+            <a:solidFill>
+              <a:srgbClr val="D3DDE2"/>
+            </a:solidFill>
           </a:ln>
-          <a:effectLst/>
         </p:spPr>
         <p:style>
-          <a:lnRef idx="1">
+          <a:lnRef idx="2">
             <a:schemeClr val="accent1"/>
           </a:lnRef>
-          <a:fillRef idx="3">
+          <a:fillRef idx="0">
             <a:schemeClr val="accent1"/>
           </a:fillRef>
-          <a:effectRef idx="2">
+          <a:effectRef idx="1">
             <a:schemeClr val="accent1"/>
           </a:effectRef>
           <a:fontRef idx="minor">
-            <a:schemeClr val="lt1"/>
+            <a:schemeClr val="tx1"/>
           </a:fontRef>
         </p:style>
-        <p:txBody>
-          <a:bodyPr rtlCol="0" anchor="ctr"/>
-          <a:lstStyle/>
-          <a:p>
-            <a:pPr algn="ctr"/>
-          </a:p>
-        </p:txBody>
-      </p:sp>
+      </p:cxnSp>
       <p:sp>
         <p:nvSpPr>
           <p:cNvPr id="4" name="TextBox 3"/>
@@ -4843,8 +4724,43 @@
         </p:nvSpPr>
         <p:spPr>
           <a:xfrm>
-            <a:off x="960120" y="2862072"/>
-            <a:ext cx="1874519" cy="822960"/>
+            <a:off x="914400" y="2743200"/>
+            <a:ext cx="2377440" cy="274320"/>
+          </a:xfrm>
+          <a:prstGeom prst="rect">
+            <a:avLst/>
+          </a:prstGeom>
+          <a:noFill/>
+        </p:spPr>
+        <p:txBody>
+          <a:bodyPr wrap="square" lIns="0" rIns="0" tIns="0" bIns="0" anchor="t">
+            <a:noAutofit/>
+          </a:bodyPr>
+          <a:lstStyle/>
+          <a:p>
+            <a:pPr algn="l"/>
+            <a:r>
+              <a:rPr sz="1300" b="1" i="0" spc="100">
+                <a:solidFill>
+                  <a:srgbClr val="5390A2"/>
+                </a:solidFill>
+                <a:latin typeface="Frutiger"/>
+              </a:rPr>
+              <a:t>01</a:t>
+            </a:r>
+          </a:p>
+        </p:txBody>
+      </p:sp>
+      <p:sp>
+        <p:nvSpPr>
+          <p:cNvPr id="5" name="TextBox 4"/>
+          <p:cNvSpPr txBox="1"/>
+          <p:nvPr/>
+        </p:nvSpPr>
+        <p:spPr>
+          <a:xfrm>
+            <a:off x="914400" y="3154680"/>
+            <a:ext cx="2377440" cy="822960"/>
           </a:xfrm>
           <a:prstGeom prst="rect">
             <a:avLst/>
@@ -4863,11 +4779,11 @@
               </a:lnSpc>
             </a:pPr>
             <a:r>
-              <a:rPr sz="2100" b="1" i="0">
-                <a:solidFill>
-                  <a:srgbClr val="0B2545"/>
-                </a:solidFill>
-                <a:latin typeface="Georgia"/>
+              <a:rPr sz="2300" b="0" i="0">
+                <a:solidFill>
+                  <a:srgbClr val="111A20"/>
+                </a:solidFill>
+                <a:latin typeface="Athelas"/>
               </a:rPr>
               <a:t>A long record</a:t>
             </a:r>
@@ -4876,14 +4792,14 @@
       </p:sp>
       <p:sp>
         <p:nvSpPr>
-          <p:cNvPr id="5" name="TextBox 4"/>
+          <p:cNvPr id="6" name="TextBox 5"/>
           <p:cNvSpPr txBox="1"/>
           <p:nvPr/>
         </p:nvSpPr>
         <p:spPr>
           <a:xfrm>
-            <a:off x="960120" y="3749039"/>
-            <a:ext cx="1874519" cy="1920240"/>
+            <a:off x="914400" y="3931920"/>
+            <a:ext cx="2331720" cy="2011680"/>
           </a:xfrm>
           <a:prstGeom prst="rect">
             <a:avLst/>
@@ -4898,114 +4814,59 @@
           <a:p>
             <a:pPr algn="l">
               <a:lnSpc>
-                <a:spcPct val="108000"/>
+                <a:spcPct val="112000"/>
               </a:lnSpc>
               <a:spcAft>
                 <a:spcPts val="700"/>
               </a:spcAft>
             </a:pPr>
             <a:r>
-              <a:rPr sz="1550" b="0" i="0">
-                <a:solidFill>
-                  <a:srgbClr val="0B2545"/>
-                </a:solidFill>
-                <a:latin typeface="Helvetica Neue"/>
+              <a:rPr sz="1450" b="0" i="0">
+                <a:solidFill>
+                  <a:srgbClr val="5F6F78"/>
+                </a:solidFill>
+                <a:latin typeface="Frutiger"/>
               </a:rPr>
               <a:t>Daily rainfall or river discharge, covering decades to centuries.</a:t>
             </a:r>
           </a:p>
         </p:txBody>
       </p:sp>
-      <p:sp>
-        <p:nvSpPr>
-          <p:cNvPr id="6" name="Right Arrow 5"/>
-          <p:cNvSpPr/>
-          <p:nvPr/>
-        </p:nvSpPr>
-        <p:spPr>
-          <a:xfrm>
-            <a:off x="3081527" y="4023359"/>
-            <a:ext cx="420624" cy="365760"/>
-          </a:xfrm>
-          <a:prstGeom prst="rightArrow">
-            <a:avLst/>
-          </a:prstGeom>
-          <a:solidFill>
-            <a:srgbClr val="C9D8E3"/>
-          </a:solidFill>
-          <a:ln>
-            <a:noFill/>
+      <p:cxnSp>
+        <p:nvCxnSpPr>
+          <p:cNvPr id="7" name="Connector 6"/>
+          <p:cNvCxnSpPr/>
+          <p:nvPr/>
+        </p:nvCxnSpPr>
+        <p:spPr>
+          <a:xfrm>
+            <a:off x="3575304" y="2514600"/>
+            <a:ext cx="2377440" cy="0"/>
+          </a:xfrm>
+          <a:prstGeom prst="line">
+            <a:avLst/>
+          </a:prstGeom>
+          <a:ln w="15875">
+            <a:solidFill>
+              <a:srgbClr val="D3DDE2"/>
+            </a:solidFill>
           </a:ln>
-          <a:effectLst/>
         </p:spPr>
         <p:style>
-          <a:lnRef idx="1">
+          <a:lnRef idx="2">
             <a:schemeClr val="accent1"/>
           </a:lnRef>
-          <a:fillRef idx="3">
+          <a:fillRef idx="0">
             <a:schemeClr val="accent1"/>
           </a:fillRef>
-          <a:effectRef idx="2">
+          <a:effectRef idx="1">
             <a:schemeClr val="accent1"/>
           </a:effectRef>
           <a:fontRef idx="minor">
-            <a:schemeClr val="lt1"/>
+            <a:schemeClr val="tx1"/>
           </a:fontRef>
         </p:style>
-        <p:txBody>
-          <a:bodyPr rtlCol="0" anchor="ctr"/>
-          <a:lstStyle/>
-          <a:p>
-            <a:pPr algn="ctr"/>
-          </a:p>
-        </p:txBody>
-      </p:sp>
-      <p:sp>
-        <p:nvSpPr>
-          <p:cNvPr id="7" name="Rounded Rectangle 6"/>
-          <p:cNvSpPr/>
-          <p:nvPr/>
-        </p:nvSpPr>
-        <p:spPr>
-          <a:xfrm>
-            <a:off x="3520439" y="2606040"/>
-            <a:ext cx="2331720" cy="3200400"/>
-          </a:xfrm>
-          <a:prstGeom prst="roundRect">
-            <a:avLst>
-              <a:gd name="adj" fmla="val 5000"/>
-            </a:avLst>
-          </a:prstGeom>
-          <a:solidFill>
-            <a:srgbClr val="EAF1F6"/>
-          </a:solidFill>
-          <a:ln>
-            <a:noFill/>
-          </a:ln>
-          <a:effectLst/>
-        </p:spPr>
-        <p:style>
-          <a:lnRef idx="1">
-            <a:schemeClr val="accent1"/>
-          </a:lnRef>
-          <a:fillRef idx="3">
-            <a:schemeClr val="accent1"/>
-          </a:fillRef>
-          <a:effectRef idx="2">
-            <a:schemeClr val="accent1"/>
-          </a:effectRef>
-          <a:fontRef idx="minor">
-            <a:schemeClr val="lt1"/>
-          </a:fontRef>
-        </p:style>
-        <p:txBody>
-          <a:bodyPr rtlCol="0" anchor="ctr"/>
-          <a:lstStyle/>
-          <a:p>
-            <a:pPr algn="ctr"/>
-          </a:p>
-        </p:txBody>
-      </p:sp>
+      </p:cxnSp>
       <p:sp>
         <p:nvSpPr>
           <p:cNvPr id="8" name="TextBox 7"/>
@@ -5014,8 +4875,43 @@
         </p:nvSpPr>
         <p:spPr>
           <a:xfrm>
-            <a:off x="3749039" y="2862072"/>
-            <a:ext cx="1874519" cy="822960"/>
+            <a:off x="3575304" y="2743200"/>
+            <a:ext cx="2377440" cy="274320"/>
+          </a:xfrm>
+          <a:prstGeom prst="rect">
+            <a:avLst/>
+          </a:prstGeom>
+          <a:noFill/>
+        </p:spPr>
+        <p:txBody>
+          <a:bodyPr wrap="square" lIns="0" rIns="0" tIns="0" bIns="0" anchor="t">
+            <a:noAutofit/>
+          </a:bodyPr>
+          <a:lstStyle/>
+          <a:p>
+            <a:pPr algn="l"/>
+            <a:r>
+              <a:rPr sz="1300" b="1" i="0" spc="100">
+                <a:solidFill>
+                  <a:srgbClr val="5390A2"/>
+                </a:solidFill>
+                <a:latin typeface="Frutiger"/>
+              </a:rPr>
+              <a:t>02</a:t>
+            </a:r>
+          </a:p>
+        </p:txBody>
+      </p:sp>
+      <p:sp>
+        <p:nvSpPr>
+          <p:cNvPr id="9" name="TextBox 8"/>
+          <p:cNvSpPr txBox="1"/>
+          <p:nvPr/>
+        </p:nvSpPr>
+        <p:spPr>
+          <a:xfrm>
+            <a:off x="3575304" y="3154680"/>
+            <a:ext cx="2377440" cy="822960"/>
           </a:xfrm>
           <a:prstGeom prst="rect">
             <a:avLst/>
@@ -5034,11 +4930,11 @@
               </a:lnSpc>
             </a:pPr>
             <a:r>
-              <a:rPr sz="2100" b="1" i="0">
-                <a:solidFill>
-                  <a:srgbClr val="0B2545"/>
-                </a:solidFill>
-                <a:latin typeface="Georgia"/>
+              <a:rPr sz="2300" b="0" i="0">
+                <a:solidFill>
+                  <a:srgbClr val="111A20"/>
+                </a:solidFill>
+                <a:latin typeface="Athelas"/>
               </a:rPr>
               <a:t>Diagnostics</a:t>
             </a:r>
@@ -5047,14 +4943,14 @@
       </p:sp>
       <p:sp>
         <p:nvSpPr>
-          <p:cNvPr id="9" name="TextBox 8"/>
+          <p:cNvPr id="10" name="TextBox 9"/>
           <p:cNvSpPr txBox="1"/>
           <p:nvPr/>
         </p:nvSpPr>
         <p:spPr>
           <a:xfrm>
-            <a:off x="3749039" y="3749039"/>
-            <a:ext cx="1874519" cy="1920240"/>
+            <a:off x="3575304" y="3931920"/>
+            <a:ext cx="2331720" cy="2011680"/>
           </a:xfrm>
           <a:prstGeom prst="rect">
             <a:avLst/>
@@ -5069,114 +4965,59 @@
           <a:p>
             <a:pPr algn="l">
               <a:lnSpc>
-                <a:spcPct val="108000"/>
+                <a:spcPct val="112000"/>
               </a:lnSpc>
               <a:spcAft>
                 <a:spcPts val="700"/>
               </a:spcAft>
             </a:pPr>
             <a:r>
-              <a:rPr sz="1550" b="0" i="0">
-                <a:solidFill>
-                  <a:srgbClr val="0B2545"/>
-                </a:solidFill>
-                <a:latin typeface="Helvetica Neue"/>
+              <a:rPr sz="1450" b="0" i="0">
+                <a:solidFill>
+                  <a:srgbClr val="5F6F78"/>
+                </a:solidFill>
+                <a:latin typeface="Frutiger"/>
               </a:rPr>
               <a:t>Peaks and the gaps between them, return periods, flow duration, recession, the seasonal cycle.</a:t>
             </a:r>
           </a:p>
         </p:txBody>
       </p:sp>
-      <p:sp>
-        <p:nvSpPr>
-          <p:cNvPr id="10" name="Right Arrow 9"/>
-          <p:cNvSpPr/>
-          <p:nvPr/>
-        </p:nvSpPr>
-        <p:spPr>
-          <a:xfrm>
-            <a:off x="5870447" y="4023359"/>
-            <a:ext cx="420624" cy="365760"/>
-          </a:xfrm>
-          <a:prstGeom prst="rightArrow">
-            <a:avLst/>
-          </a:prstGeom>
-          <a:solidFill>
-            <a:srgbClr val="C9D8E3"/>
-          </a:solidFill>
-          <a:ln>
-            <a:noFill/>
+      <p:cxnSp>
+        <p:nvCxnSpPr>
+          <p:cNvPr id="11" name="Connector 10"/>
+          <p:cNvCxnSpPr/>
+          <p:nvPr/>
+        </p:nvCxnSpPr>
+        <p:spPr>
+          <a:xfrm>
+            <a:off x="6236208" y="2514600"/>
+            <a:ext cx="2377440" cy="0"/>
+          </a:xfrm>
+          <a:prstGeom prst="line">
+            <a:avLst/>
+          </a:prstGeom>
+          <a:ln w="38100">
+            <a:solidFill>
+              <a:srgbClr val="00526F"/>
+            </a:solidFill>
           </a:ln>
-          <a:effectLst/>
         </p:spPr>
         <p:style>
-          <a:lnRef idx="1">
+          <a:lnRef idx="2">
             <a:schemeClr val="accent1"/>
           </a:lnRef>
-          <a:fillRef idx="3">
+          <a:fillRef idx="0">
             <a:schemeClr val="accent1"/>
           </a:fillRef>
-          <a:effectRef idx="2">
+          <a:effectRef idx="1">
             <a:schemeClr val="accent1"/>
           </a:effectRef>
           <a:fontRef idx="minor">
-            <a:schemeClr val="lt1"/>
+            <a:schemeClr val="tx1"/>
           </a:fontRef>
         </p:style>
-        <p:txBody>
-          <a:bodyPr rtlCol="0" anchor="ctr"/>
-          <a:lstStyle/>
-          <a:p>
-            <a:pPr algn="ctr"/>
-          </a:p>
-        </p:txBody>
-      </p:sp>
-      <p:sp>
-        <p:nvSpPr>
-          <p:cNvPr id="11" name="Rounded Rectangle 10"/>
-          <p:cNvSpPr/>
-          <p:nvPr/>
-        </p:nvSpPr>
-        <p:spPr>
-          <a:xfrm>
-            <a:off x="6309359" y="2606040"/>
-            <a:ext cx="2331720" cy="3200400"/>
-          </a:xfrm>
-          <a:prstGeom prst="roundRect">
-            <a:avLst>
-              <a:gd name="adj" fmla="val 5000"/>
-            </a:avLst>
-          </a:prstGeom>
-          <a:solidFill>
-            <a:srgbClr val="0B2545"/>
-          </a:solidFill>
-          <a:ln>
-            <a:noFill/>
-          </a:ln>
-          <a:effectLst/>
-        </p:spPr>
-        <p:style>
-          <a:lnRef idx="1">
-            <a:schemeClr val="accent1"/>
-          </a:lnRef>
-          <a:fillRef idx="3">
-            <a:schemeClr val="accent1"/>
-          </a:fillRef>
-          <a:effectRef idx="2">
-            <a:schemeClr val="accent1"/>
-          </a:effectRef>
-          <a:fontRef idx="minor">
-            <a:schemeClr val="lt1"/>
-          </a:fontRef>
-        </p:style>
-        <p:txBody>
-          <a:bodyPr rtlCol="0" anchor="ctr"/>
-          <a:lstStyle/>
-          <a:p>
-            <a:pPr algn="ctr"/>
-          </a:p>
-        </p:txBody>
-      </p:sp>
+      </p:cxnSp>
       <p:sp>
         <p:nvSpPr>
           <p:cNvPr id="12" name="TextBox 11"/>
@@ -5185,8 +5026,43 @@
         </p:nvSpPr>
         <p:spPr>
           <a:xfrm>
-            <a:off x="6537959" y="2862072"/>
-            <a:ext cx="1874519" cy="822960"/>
+            <a:off x="6236208" y="2743200"/>
+            <a:ext cx="2377440" cy="274320"/>
+          </a:xfrm>
+          <a:prstGeom prst="rect">
+            <a:avLst/>
+          </a:prstGeom>
+          <a:noFill/>
+        </p:spPr>
+        <p:txBody>
+          <a:bodyPr wrap="square" lIns="0" rIns="0" tIns="0" bIns="0" anchor="t">
+            <a:noAutofit/>
+          </a:bodyPr>
+          <a:lstStyle/>
+          <a:p>
+            <a:pPr algn="l"/>
+            <a:r>
+              <a:rPr sz="1300" b="1" i="0" spc="100">
+                <a:solidFill>
+                  <a:srgbClr val="00526F"/>
+                </a:solidFill>
+                <a:latin typeface="Frutiger"/>
+              </a:rPr>
+              <a:t>03</a:t>
+            </a:r>
+          </a:p>
+        </p:txBody>
+      </p:sp>
+      <p:sp>
+        <p:nvSpPr>
+          <p:cNvPr id="13" name="TextBox 12"/>
+          <p:cNvSpPr txBox="1"/>
+          <p:nvPr/>
+        </p:nvSpPr>
+        <p:spPr>
+          <a:xfrm>
+            <a:off x="6236208" y="3154680"/>
+            <a:ext cx="2377440" cy="822960"/>
           </a:xfrm>
           <a:prstGeom prst="rect">
             <a:avLst/>
@@ -5205,11 +5081,11 @@
               </a:lnSpc>
             </a:pPr>
             <a:r>
-              <a:rPr sz="2100" b="1" i="0">
-                <a:solidFill>
-                  <a:srgbClr val="FFFFFF"/>
-                </a:solidFill>
-                <a:latin typeface="Georgia"/>
+              <a:rPr sz="2300" b="0" i="0">
+                <a:solidFill>
+                  <a:srgbClr val="111A20"/>
+                </a:solidFill>
+                <a:latin typeface="Athelas"/>
               </a:rPr>
               <a:t>Two affective values</a:t>
             </a:r>
@@ -5218,14 +5094,14 @@
       </p:sp>
       <p:sp>
         <p:nvSpPr>
-          <p:cNvPr id="13" name="TextBox 12"/>
+          <p:cNvPr id="14" name="TextBox 13"/>
           <p:cNvSpPr txBox="1"/>
           <p:nvPr/>
         </p:nvSpPr>
         <p:spPr>
           <a:xfrm>
-            <a:off x="6537959" y="3749039"/>
-            <a:ext cx="1874519" cy="1920240"/>
+            <a:off x="6236208" y="3931920"/>
+            <a:ext cx="2331720" cy="2011680"/>
           </a:xfrm>
           <a:prstGeom prst="rect">
             <a:avLst/>
@@ -5240,152 +5116,97 @@
           <a:p>
             <a:pPr algn="l">
               <a:lnSpc>
-                <a:spcPct val="108000"/>
+                <a:spcPct val="112000"/>
               </a:lnSpc>
               <a:spcAft>
                 <a:spcPts val="700"/>
               </a:spcAft>
             </a:pPr>
             <a:r>
-              <a:rPr sz="1550" b="0" i="0">
-                <a:solidFill>
-                  <a:srgbClr val="FFFFFF"/>
-                </a:solidFill>
-                <a:latin typeface="Helvetica Neue"/>
+              <a:rPr sz="1450" b="0" i="0">
+                <a:solidFill>
+                  <a:srgbClr val="111A20"/>
+                </a:solidFill>
+                <a:latin typeface="Frutiger"/>
               </a:rPr>
-              <a:t>Valence: pleasant ↔ distressing.</a:t>
+              <a:t>Valence: pleasant to distressing.</a:t>
             </a:r>
           </a:p>
           <a:p>
             <a:pPr algn="l">
               <a:lnSpc>
-                <a:spcPct val="108000"/>
+                <a:spcPct val="112000"/>
               </a:lnSpc>
               <a:spcAft>
                 <a:spcPts val="700"/>
               </a:spcAft>
             </a:pPr>
             <a:r>
-              <a:rPr sz="1550" b="0" i="0">
-                <a:solidFill>
-                  <a:srgbClr val="FFFFFF"/>
-                </a:solidFill>
-                <a:latin typeface="Helvetica Neue"/>
+              <a:rPr sz="1450" b="0" i="0">
+                <a:solidFill>
+                  <a:srgbClr val="111A20"/>
+                </a:solidFill>
+                <a:latin typeface="Frutiger"/>
               </a:rPr>
-              <a:t>Arousal: calm ↔ activated.</a:t>
+              <a:t>Arousal: calm to activated.</a:t>
             </a:r>
           </a:p>
           <a:p>
             <a:pPr algn="l">
               <a:lnSpc>
-                <a:spcPct val="108000"/>
+                <a:spcPct val="112000"/>
               </a:lnSpc>
               <a:spcAft>
                 <a:spcPts val="700"/>
               </a:spcAft>
             </a:pPr>
             <a:r>
-              <a:rPr sz="1550" b="0" i="0">
-                <a:solidFill>
-                  <a:srgbClr val="FFFFFF"/>
-                </a:solidFill>
-                <a:latin typeface="Helvetica Neue"/>
+              <a:rPr sz="1450" b="0" i="0">
+                <a:solidFill>
+                  <a:srgbClr val="111A20"/>
+                </a:solidFill>
+                <a:latin typeface="Frutiger"/>
               </a:rPr>
-              <a:t>Plus four physical readouts: size, glow, texture, tempo.</a:t>
-            </a:r>
-          </a:p>
-        </p:txBody>
-      </p:sp>
-      <p:sp>
-        <p:nvSpPr>
-          <p:cNvPr id="14" name="Right Arrow 13"/>
-          <p:cNvSpPr/>
-          <p:nvPr/>
-        </p:nvSpPr>
-        <p:spPr>
-          <a:xfrm>
-            <a:off x="8659367" y="4023359"/>
-            <a:ext cx="420624" cy="365760"/>
-          </a:xfrm>
-          <a:prstGeom prst="rightArrow">
-            <a:avLst/>
-          </a:prstGeom>
-          <a:solidFill>
-            <a:srgbClr val="C9D8E3"/>
-          </a:solidFill>
-          <a:ln>
-            <a:noFill/>
+              <a:t>Alongside four physical readouts: size, glow, texture, tempo.</a:t>
+            </a:r>
+          </a:p>
+        </p:txBody>
+      </p:sp>
+      <p:cxnSp>
+        <p:nvCxnSpPr>
+          <p:cNvPr id="15" name="Connector 14"/>
+          <p:cNvCxnSpPr/>
+          <p:nvPr/>
+        </p:nvCxnSpPr>
+        <p:spPr>
+          <a:xfrm>
+            <a:off x="8897112" y="2514600"/>
+            <a:ext cx="2377440" cy="0"/>
+          </a:xfrm>
+          <a:prstGeom prst="line">
+            <a:avLst/>
+          </a:prstGeom>
+          <a:ln w="15875">
+            <a:solidFill>
+              <a:srgbClr val="D3DDE2"/>
+            </a:solidFill>
           </a:ln>
-          <a:effectLst/>
         </p:spPr>
         <p:style>
-          <a:lnRef idx="1">
+          <a:lnRef idx="2">
             <a:schemeClr val="accent1"/>
           </a:lnRef>
-          <a:fillRef idx="3">
+          <a:fillRef idx="0">
             <a:schemeClr val="accent1"/>
           </a:fillRef>
-          <a:effectRef idx="2">
+          <a:effectRef idx="1">
             <a:schemeClr val="accent1"/>
           </a:effectRef>
           <a:fontRef idx="minor">
-            <a:schemeClr val="lt1"/>
+            <a:schemeClr val="tx1"/>
           </a:fontRef>
         </p:style>
-        <p:txBody>
-          <a:bodyPr rtlCol="0" anchor="ctr"/>
-          <a:lstStyle/>
-          <a:p>
-            <a:pPr algn="ctr"/>
-          </a:p>
-        </p:txBody>
-      </p:sp>
-      <p:sp>
-        <p:nvSpPr>
-          <p:cNvPr id="15" name="Rounded Rectangle 14"/>
-          <p:cNvSpPr/>
-          <p:nvPr/>
-        </p:nvSpPr>
-        <p:spPr>
-          <a:xfrm>
-            <a:off x="9098280" y="2606040"/>
-            <a:ext cx="2331720" cy="3200400"/>
-          </a:xfrm>
-          <a:prstGeom prst="roundRect">
-            <a:avLst>
-              <a:gd name="adj" fmla="val 5000"/>
-            </a:avLst>
-          </a:prstGeom>
-          <a:solidFill>
-            <a:srgbClr val="EAF1F6"/>
-          </a:solidFill>
-          <a:ln>
-            <a:noFill/>
-          </a:ln>
-          <a:effectLst/>
-        </p:spPr>
-        <p:style>
-          <a:lnRef idx="1">
-            <a:schemeClr val="accent1"/>
-          </a:lnRef>
-          <a:fillRef idx="3">
-            <a:schemeClr val="accent1"/>
-          </a:fillRef>
-          <a:effectRef idx="2">
-            <a:schemeClr val="accent1"/>
-          </a:effectRef>
-          <a:fontRef idx="minor">
-            <a:schemeClr val="lt1"/>
-          </a:fontRef>
-        </p:style>
-        <p:txBody>
-          <a:bodyPr rtlCol="0" anchor="ctr"/>
-          <a:lstStyle/>
-          <a:p>
-            <a:pPr algn="ctr"/>
-          </a:p>
-        </p:txBody>
-      </p:sp>
+      </p:cxnSp>
       <p:sp>
         <p:nvSpPr>
           <p:cNvPr id="16" name="TextBox 15"/>
@@ -5394,8 +5215,43 @@
         </p:nvSpPr>
         <p:spPr>
           <a:xfrm>
-            <a:off x="9326880" y="2862072"/>
-            <a:ext cx="1874519" cy="822960"/>
+            <a:off x="8897112" y="2743200"/>
+            <a:ext cx="2377440" cy="274320"/>
+          </a:xfrm>
+          <a:prstGeom prst="rect">
+            <a:avLst/>
+          </a:prstGeom>
+          <a:noFill/>
+        </p:spPr>
+        <p:txBody>
+          <a:bodyPr wrap="square" lIns="0" rIns="0" tIns="0" bIns="0" anchor="t">
+            <a:noAutofit/>
+          </a:bodyPr>
+          <a:lstStyle/>
+          <a:p>
+            <a:pPr algn="l"/>
+            <a:r>
+              <a:rPr sz="1300" b="1" i="0" spc="100">
+                <a:solidFill>
+                  <a:srgbClr val="5390A2"/>
+                </a:solidFill>
+                <a:latin typeface="Frutiger"/>
+              </a:rPr>
+              <a:t>04</a:t>
+            </a:r>
+          </a:p>
+        </p:txBody>
+      </p:sp>
+      <p:sp>
+        <p:nvSpPr>
+          <p:cNvPr id="17" name="TextBox 16"/>
+          <p:cNvSpPr txBox="1"/>
+          <p:nvPr/>
+        </p:nvSpPr>
+        <p:spPr>
+          <a:xfrm>
+            <a:off x="8897112" y="3154680"/>
+            <a:ext cx="2377440" cy="822960"/>
           </a:xfrm>
           <a:prstGeom prst="rect">
             <a:avLst/>
@@ -5414,11 +5270,11 @@
               </a:lnSpc>
             </a:pPr>
             <a:r>
-              <a:rPr sz="2100" b="1" i="0">
-                <a:solidFill>
-                  <a:srgbClr val="0B2545"/>
-                </a:solidFill>
-                <a:latin typeface="Georgia"/>
+              <a:rPr sz="2300" b="0" i="0">
+                <a:solidFill>
+                  <a:srgbClr val="111A20"/>
+                </a:solidFill>
+                <a:latin typeface="Athelas"/>
               </a:rPr>
               <a:t>XR and sound</a:t>
             </a:r>
@@ -5427,14 +5283,14 @@
       </p:sp>
       <p:sp>
         <p:nvSpPr>
-          <p:cNvPr id="17" name="TextBox 16"/>
+          <p:cNvPr id="18" name="TextBox 17"/>
           <p:cNvSpPr txBox="1"/>
           <p:nvPr/>
         </p:nvSpPr>
         <p:spPr>
           <a:xfrm>
-            <a:off x="9326880" y="3749039"/>
-            <a:ext cx="1874519" cy="1920240"/>
+            <a:off x="8897112" y="3931920"/>
+            <a:ext cx="2331720" cy="2011680"/>
           </a:xfrm>
           <a:prstGeom prst="rect">
             <a:avLst/>
@@ -5449,34 +5305,58 @@
           <a:p>
             <a:pPr algn="l">
               <a:lnSpc>
-                <a:spcPct val="108000"/>
+                <a:spcPct val="112000"/>
               </a:lnSpc>
               <a:spcAft>
                 <a:spcPts val="700"/>
               </a:spcAft>
             </a:pPr>
             <a:r>
-              <a:rPr sz="1550" b="0" i="0">
-                <a:solidFill>
-                  <a:srgbClr val="0B2545"/>
-                </a:solidFill>
-                <a:latin typeface="Helvetica Neue"/>
+              <a:rPr sz="1450" b="0" i="0">
+                <a:solidFill>
+                  <a:srgbClr val="5F6F78"/>
+                </a:solidFill>
+                <a:latin typeface="Frutiger"/>
               </a:rPr>
               <a:t>Designed to feed immersive and sonic experiences. The output format is still provisional.</a:t>
             </a:r>
           </a:p>
         </p:txBody>
       </p:sp>
-      <p:sp>
-        <p:nvSpPr>
-          <p:cNvPr id="18" name="TextBox 17"/>
+      <p:pic>
+        <p:nvPicPr>
+          <p:cNvPr id="19" name="Picture 18" descr="logo.png"/>
+          <p:cNvPicPr>
+            <a:picLocks noChangeAspect="1"/>
+          </p:cNvPicPr>
+          <p:nvPr/>
+        </p:nvPicPr>
+        <p:blipFill>
+          <a:blip r:embed="rId3"/>
+          <a:stretch>
+            <a:fillRect/>
+          </a:stretch>
+        </p:blipFill>
+        <p:spPr>
+          <a:xfrm>
+            <a:off x="914400" y="6236208"/>
+            <a:ext cx="2120348" cy="292608"/>
+          </a:xfrm>
+          <a:prstGeom prst="rect">
+            <a:avLst/>
+          </a:prstGeom>
+        </p:spPr>
+      </p:pic>
+      <p:sp>
+        <p:nvSpPr>
+          <p:cNvPr id="20" name="TextBox 19"/>
           <p:cNvSpPr txBox="1"/>
           <p:nvPr/>
         </p:nvSpPr>
         <p:spPr>
           <a:xfrm>
-            <a:off x="731520" y="6419088"/>
-            <a:ext cx="7315200" cy="274320"/>
+            <a:off x="10637215" y="6309360"/>
+            <a:ext cx="640080" cy="274320"/>
           </a:xfrm>
           <a:prstGeom prst="rect">
             <a:avLst/>
@@ -5489,48 +5369,13 @@
           </a:bodyPr>
           <a:lstStyle/>
           <a:p>
-            <a:pPr algn="l"/>
+            <a:pPr algn="r"/>
             <a:r>
               <a:rPr sz="1100" b="0" i="0">
                 <a:solidFill>
-                  <a:srgbClr val="5C6F7B"/>
-                </a:solidFill>
-                <a:latin typeface="Helvetica Neue"/>
-              </a:rPr>
-              <a:t>Noéa  ·  Meeting of Waters, Geneva</a:t>
-            </a:r>
-          </a:p>
-        </p:txBody>
-      </p:sp>
-      <p:sp>
-        <p:nvSpPr>
-          <p:cNvPr id="19" name="TextBox 18"/>
-          <p:cNvSpPr txBox="1"/>
-          <p:nvPr/>
-        </p:nvSpPr>
-        <p:spPr>
-          <a:xfrm>
-            <a:off x="10881360" y="6419088"/>
-            <a:ext cx="594360" cy="274320"/>
-          </a:xfrm>
-          <a:prstGeom prst="rect">
-            <a:avLst/>
-          </a:prstGeom>
-          <a:noFill/>
-        </p:spPr>
-        <p:txBody>
-          <a:bodyPr wrap="square" lIns="0" rIns="0" tIns="0" bIns="0" anchor="t">
-            <a:noAutofit/>
-          </a:bodyPr>
-          <a:lstStyle/>
-          <a:p>
-            <a:pPr algn="r"/>
-            <a:r>
-              <a:rPr sz="1100" b="0" i="0">
-                <a:solidFill>
-                  <a:srgbClr val="5C6F7B"/>
-                </a:solidFill>
-                <a:latin typeface="Helvetica Neue"/>
+                  <a:srgbClr val="5F6F78"/>
+                </a:solidFill>
+                <a:latin typeface="Frutiger"/>
               </a:rPr>
               <a:t>3</a:t>
             </a:r>
@@ -5551,7 +5396,7 @@
     <p:bg>
       <p:bgPr>
         <a:solidFill>
-          <a:srgbClr val="F6F9FB"/>
+          <a:srgbClr val="FFFFFF"/>
         </a:solidFill>
         <a:effectLst/>
       </p:bgPr>
@@ -5571,8 +5416,8 @@
         </p:nvSpPr>
         <p:spPr>
           <a:xfrm>
-            <a:off x="731520" y="640080"/>
-            <a:ext cx="10698480" cy="1463040"/>
+            <a:off x="914400" y="685800"/>
+            <a:ext cx="10362895" cy="1371600"/>
           </a:xfrm>
           <a:prstGeom prst="rect">
             <a:avLst/>
@@ -5591,11 +5436,11 @@
               </a:lnSpc>
             </a:pPr>
             <a:r>
-              <a:rPr sz="3800" b="1" i="0">
-                <a:solidFill>
-                  <a:srgbClr val="0B2545"/>
-                </a:solidFill>
-                <a:latin typeface="Georgia"/>
+              <a:rPr sz="4000" b="0" i="0">
+                <a:solidFill>
+                  <a:srgbClr val="111A20"/>
+                </a:solidFill>
+                <a:latin typeface="Athelas"/>
               </a:rPr>
               <a:t>Two layers, kept deliberately apart</a:t>
             </a:r>
@@ -5604,60 +5449,199 @@
       </p:sp>
       <p:sp>
         <p:nvSpPr>
-          <p:cNvPr id="3" name="Rounded Rectangle 2"/>
-          <p:cNvSpPr/>
-          <p:nvPr/>
-        </p:nvSpPr>
-        <p:spPr>
-          <a:xfrm>
-            <a:off x="731520" y="2148840"/>
-            <a:ext cx="5257800" cy="3611880"/>
-          </a:xfrm>
-          <a:prstGeom prst="roundRect">
-            <a:avLst>
-              <a:gd name="adj" fmla="val 5000"/>
-            </a:avLst>
-          </a:prstGeom>
-          <a:solidFill>
-            <a:srgbClr val="EAF1F6"/>
-          </a:solidFill>
-          <a:ln>
-            <a:noFill/>
+          <p:cNvPr id="3" name="TextBox 2"/>
+          <p:cNvSpPr txBox="1"/>
+          <p:nvPr/>
+        </p:nvSpPr>
+        <p:spPr>
+          <a:xfrm>
+            <a:off x="914400" y="2331720"/>
+            <a:ext cx="4754880" cy="548640"/>
+          </a:xfrm>
+          <a:prstGeom prst="rect">
+            <a:avLst/>
+          </a:prstGeom>
+          <a:noFill/>
+        </p:spPr>
+        <p:txBody>
+          <a:bodyPr wrap="square" lIns="0" rIns="0" tIns="0" bIns="0" anchor="t">
+            <a:noAutofit/>
+          </a:bodyPr>
+          <a:lstStyle/>
+          <a:p>
+            <a:pPr algn="l"/>
+            <a:r>
+              <a:rPr sz="3200" b="0" i="0">
+                <a:solidFill>
+                  <a:srgbClr val="111A20"/>
+                </a:solidFill>
+                <a:latin typeface="Athelas"/>
+              </a:rPr>
+              <a:t>Science layer</a:t>
+            </a:r>
+          </a:p>
+        </p:txBody>
+      </p:sp>
+      <p:sp>
+        <p:nvSpPr>
+          <p:cNvPr id="4" name="TextBox 3"/>
+          <p:cNvSpPr txBox="1"/>
+          <p:nvPr/>
+        </p:nvSpPr>
+        <p:spPr>
+          <a:xfrm>
+            <a:off x="914400" y="2926080"/>
+            <a:ext cx="4754880" cy="274320"/>
+          </a:xfrm>
+          <a:prstGeom prst="rect">
+            <a:avLst/>
+          </a:prstGeom>
+          <a:noFill/>
+        </p:spPr>
+        <p:txBody>
+          <a:bodyPr wrap="square" lIns="0" rIns="0" tIns="0" bIns="0" anchor="t">
+            <a:noAutofit/>
+          </a:bodyPr>
+          <a:lstStyle/>
+          <a:p>
+            <a:pPr algn="l"/>
+            <a:r>
+              <a:rPr sz="1200" b="1" i="0" spc="140">
+                <a:solidFill>
+                  <a:srgbClr val="5F6F78"/>
+                </a:solidFill>
+                <a:latin typeface="Frutiger"/>
+              </a:rPr>
+              <a:t>OBJECTIVE</a:t>
+            </a:r>
+          </a:p>
+        </p:txBody>
+      </p:sp>
+      <p:sp>
+        <p:nvSpPr>
+          <p:cNvPr id="5" name="TextBox 4"/>
+          <p:cNvSpPr txBox="1"/>
+          <p:nvPr/>
+        </p:nvSpPr>
+        <p:spPr>
+          <a:xfrm>
+            <a:off x="914400" y="3474720"/>
+            <a:ext cx="4754880" cy="2560320"/>
+          </a:xfrm>
+          <a:prstGeom prst="rect">
+            <a:avLst/>
+          </a:prstGeom>
+          <a:noFill/>
+        </p:spPr>
+        <p:txBody>
+          <a:bodyPr wrap="square" lIns="0" rIns="0" tIns="0" bIns="0" anchor="t">
+            <a:noAutofit/>
+          </a:bodyPr>
+          <a:lstStyle/>
+          <a:p>
+            <a:pPr algn="l">
+              <a:lnSpc>
+                <a:spcPct val="112000"/>
+              </a:lnSpc>
+              <a:spcAft>
+                <a:spcPts val="1200"/>
+              </a:spcAft>
+            </a:pPr>
+            <a:r>
+              <a:rPr sz="1650" b="0" i="0">
+                <a:solidFill>
+                  <a:srgbClr val="111A20"/>
+                </a:solidFill>
+                <a:latin typeface="Frutiger"/>
+              </a:rPr>
+              <a:t>Hong Kong rainfall, 1884–2025: annual peaks, the gaps between them, return periods.</a:t>
+            </a:r>
+          </a:p>
+          <a:p>
+            <a:pPr algn="l">
+              <a:lnSpc>
+                <a:spcPct val="112000"/>
+              </a:lnSpc>
+              <a:spcAft>
+                <a:spcPts val="1200"/>
+              </a:spcAft>
+            </a:pPr>
+            <a:r>
+              <a:rPr sz="1650" b="0" i="0">
+                <a:solidFill>
+                  <a:srgbClr val="111A20"/>
+                </a:solidFill>
+                <a:latin typeface="Frutiger"/>
+              </a:rPr>
+              <a:t>Rhine and alpine rivers, 8 stations: flow duration, recession, the seasonal cycle.</a:t>
+            </a:r>
+          </a:p>
+          <a:p>
+            <a:pPr algn="l">
+              <a:lnSpc>
+                <a:spcPct val="112000"/>
+              </a:lnSpc>
+              <a:spcAft>
+                <a:spcPts val="1200"/>
+              </a:spcAft>
+            </a:pPr>
+            <a:r>
+              <a:rPr sz="1650" b="0" i="0">
+                <a:solidFill>
+                  <a:srgbClr val="111A20"/>
+                </a:solidFill>
+                <a:latin typeface="Frutiger"/>
+              </a:rPr>
+              <a:t>Measures what happened. The measurements are never adjusted for artistic reasons.</a:t>
+            </a:r>
+          </a:p>
+        </p:txBody>
+      </p:sp>
+      <p:cxnSp>
+        <p:nvCxnSpPr>
+          <p:cNvPr id="6" name="Connector 5"/>
+          <p:cNvCxnSpPr/>
+          <p:nvPr/>
+        </p:nvCxnSpPr>
+        <p:spPr>
+          <a:xfrm>
+            <a:off x="6096304" y="2377440"/>
+            <a:ext cx="0" cy="3566160"/>
+          </a:xfrm>
+          <a:prstGeom prst="line">
+            <a:avLst/>
+          </a:prstGeom>
+          <a:ln w="12700">
+            <a:solidFill>
+              <a:srgbClr val="D3DDE2"/>
+            </a:solidFill>
           </a:ln>
-          <a:effectLst/>
         </p:spPr>
         <p:style>
-          <a:lnRef idx="1">
+          <a:lnRef idx="2">
             <a:schemeClr val="accent1"/>
           </a:lnRef>
-          <a:fillRef idx="3">
+          <a:fillRef idx="0">
             <a:schemeClr val="accent1"/>
           </a:fillRef>
-          <a:effectRef idx="2">
+          <a:effectRef idx="1">
             <a:schemeClr val="accent1"/>
           </a:effectRef>
           <a:fontRef idx="minor">
-            <a:schemeClr val="lt1"/>
+            <a:schemeClr val="tx1"/>
           </a:fontRef>
         </p:style>
-        <p:txBody>
-          <a:bodyPr rtlCol="0" anchor="ctr"/>
-          <a:lstStyle/>
-          <a:p>
-            <a:pPr algn="ctr"/>
-          </a:p>
-        </p:txBody>
-      </p:sp>
-      <p:sp>
-        <p:nvSpPr>
-          <p:cNvPr id="4" name="TextBox 3"/>
+      </p:cxnSp>
+      <p:sp>
+        <p:nvSpPr>
+          <p:cNvPr id="7" name="TextBox 6"/>
           <p:cNvSpPr txBox="1"/>
           <p:nvPr/>
         </p:nvSpPr>
         <p:spPr>
           <a:xfrm>
-            <a:off x="1097280" y="2423160"/>
-            <a:ext cx="4572000" cy="457200"/>
+            <a:off x="6522415" y="2331720"/>
+            <a:ext cx="4754880" cy="548640"/>
           </a:xfrm>
           <a:prstGeom prst="rect">
             <a:avLst/>
@@ -5672,27 +5656,27 @@
           <a:p>
             <a:pPr algn="l"/>
             <a:r>
-              <a:rPr sz="2800" b="1" i="0">
-                <a:solidFill>
-                  <a:srgbClr val="0B2545"/>
-                </a:solidFill>
-                <a:latin typeface="Georgia"/>
+              <a:rPr sz="3200" b="0" i="0">
+                <a:solidFill>
+                  <a:srgbClr val="111A20"/>
+                </a:solidFill>
+                <a:latin typeface="Athelas"/>
               </a:rPr>
-              <a:t>Science layer</a:t>
-            </a:r>
-          </a:p>
-        </p:txBody>
-      </p:sp>
-      <p:sp>
-        <p:nvSpPr>
-          <p:cNvPr id="5" name="TextBox 4"/>
+              <a:t>Curatorial layer</a:t>
+            </a:r>
+          </a:p>
+        </p:txBody>
+      </p:sp>
+      <p:sp>
+        <p:nvSpPr>
+          <p:cNvPr id="8" name="TextBox 7"/>
           <p:cNvSpPr txBox="1"/>
           <p:nvPr/>
         </p:nvSpPr>
         <p:spPr>
           <a:xfrm>
-            <a:off x="1097280" y="2971800"/>
-            <a:ext cx="4572000" cy="365760"/>
+            <a:off x="6522415" y="2926080"/>
+            <a:ext cx="4754880" cy="274320"/>
           </a:xfrm>
           <a:prstGeom prst="rect">
             <a:avLst/>
@@ -5707,27 +5691,27 @@
           <a:p>
             <a:pPr algn="l"/>
             <a:r>
-              <a:rPr sz="1500" b="1" i="0">
-                <a:solidFill>
-                  <a:srgbClr val="2E6F9E"/>
-                </a:solidFill>
-                <a:latin typeface="Helvetica Neue"/>
+              <a:rPr sz="1200" b="1" i="0" spc="140">
+                <a:solidFill>
+                  <a:srgbClr val="00526F"/>
+                </a:solidFill>
+                <a:latin typeface="Frutiger"/>
               </a:rPr>
-              <a:t>OBJECTIVE</a:t>
-            </a:r>
-          </a:p>
-        </p:txBody>
-      </p:sp>
-      <p:sp>
-        <p:nvSpPr>
-          <p:cNvPr id="6" name="TextBox 5"/>
+              <a:t>DESIGNED</a:t>
+            </a:r>
+          </a:p>
+        </p:txBody>
+      </p:sp>
+      <p:sp>
+        <p:nvSpPr>
+          <p:cNvPr id="9" name="TextBox 8"/>
           <p:cNvSpPr txBox="1"/>
           <p:nvPr/>
         </p:nvSpPr>
         <p:spPr>
           <a:xfrm>
-            <a:off x="1097280" y="3520440"/>
-            <a:ext cx="4572000" cy="2468880"/>
+            <a:off x="6522415" y="3474720"/>
+            <a:ext cx="4754880" cy="2560320"/>
           </a:xfrm>
           <a:prstGeom prst="rect">
             <a:avLst/>
@@ -5742,118 +5726,96 @@
           <a:p>
             <a:pPr algn="l">
               <a:lnSpc>
-                <a:spcPct val="110000"/>
+                <a:spcPct val="112000"/>
               </a:lnSpc>
               <a:spcAft>
-                <a:spcPts val="1100"/>
+                <a:spcPts val="1200"/>
               </a:spcAft>
             </a:pPr>
             <a:r>
-              <a:rPr sz="1700" b="0" i="0">
-                <a:solidFill>
-                  <a:srgbClr val="0B2545"/>
-                </a:solidFill>
-                <a:latin typeface="Helvetica Neue"/>
+              <a:rPr sz="1650" b="0" i="0">
+                <a:solidFill>
+                  <a:srgbClr val="111A20"/>
+                </a:solidFill>
+                <a:latin typeface="Frutiger"/>
               </a:rPr>
-              <a:t>Hong Kong rainfall, 1884–2025: annual peaks, the gaps between them, return periods.</a:t>
+              <a:t>Decides what a drought or a flood should feel like: how alarming, how heavy.</a:t>
             </a:r>
           </a:p>
           <a:p>
             <a:pPr algn="l">
               <a:lnSpc>
-                <a:spcPct val="110000"/>
+                <a:spcPct val="112000"/>
               </a:lnSpc>
               <a:spcAft>
-                <a:spcPts val="1100"/>
+                <a:spcPts val="1200"/>
               </a:spcAft>
             </a:pPr>
             <a:r>
-              <a:rPr sz="1700" b="0" i="0">
-                <a:solidFill>
-                  <a:srgbClr val="0B2545"/>
-                </a:solidFill>
-                <a:latin typeface="Helvetica Neue"/>
+              <a:rPr sz="1650" b="0" i="0">
+                <a:solidFill>
+                  <a:srgbClr val="111A20"/>
+                </a:solidFill>
+                <a:latin typeface="Frutiger"/>
               </a:rPr>
-              <a:t>Rhine and alpine rivers, 8 stations: flow duration, recession, the seasonal cycle.</a:t>
+              <a:t>Kept separate from the measurements, so the feeling can be redesigned without changing any of the science.</a:t>
             </a:r>
           </a:p>
           <a:p>
             <a:pPr algn="l">
               <a:lnSpc>
-                <a:spcPct val="110000"/>
+                <a:spcPct val="112000"/>
               </a:lnSpc>
               <a:spcAft>
-                <a:spcPts val="1100"/>
+                <a:spcPts val="1200"/>
               </a:spcAft>
             </a:pPr>
             <a:r>
-              <a:rPr sz="1700" b="0" i="0">
-                <a:solidFill>
-                  <a:srgbClr val="0B2545"/>
-                </a:solidFill>
-                <a:latin typeface="Helvetica Neue"/>
+              <a:rPr sz="1650" b="0" i="0">
+                <a:solidFill>
+                  <a:srgbClr val="111A20"/>
+                </a:solidFill>
+                <a:latin typeface="Frutiger"/>
               </a:rPr>
-              <a:t>Measures what happened. The measurements are never adjusted for artistic reasons.</a:t>
-            </a:r>
-          </a:p>
-        </p:txBody>
-      </p:sp>
-      <p:sp>
-        <p:nvSpPr>
-          <p:cNvPr id="7" name="Rounded Rectangle 6"/>
-          <p:cNvSpPr/>
-          <p:nvPr/>
-        </p:nvSpPr>
-        <p:spPr>
-          <a:xfrm>
-            <a:off x="6199632" y="2148840"/>
-            <a:ext cx="5257800" cy="3611880"/>
-          </a:xfrm>
-          <a:prstGeom prst="roundRect">
-            <a:avLst>
-              <a:gd name="adj" fmla="val 5000"/>
-            </a:avLst>
-          </a:prstGeom>
-          <a:solidFill>
-            <a:srgbClr val="0B2545"/>
-          </a:solidFill>
-          <a:ln>
-            <a:noFill/>
-          </a:ln>
-          <a:effectLst/>
-        </p:spPr>
-        <p:style>
-          <a:lnRef idx="1">
-            <a:schemeClr val="accent1"/>
-          </a:lnRef>
-          <a:fillRef idx="3">
-            <a:schemeClr val="accent1"/>
-          </a:fillRef>
-          <a:effectRef idx="2">
-            <a:schemeClr val="accent1"/>
-          </a:effectRef>
-          <a:fontRef idx="minor">
-            <a:schemeClr val="lt1"/>
-          </a:fontRef>
-        </p:style>
-        <p:txBody>
-          <a:bodyPr rtlCol="0" anchor="ctr"/>
-          <a:lstStyle/>
-          <a:p>
-            <a:pPr algn="ctr"/>
-          </a:p>
-        </p:txBody>
-      </p:sp>
-      <p:sp>
-        <p:nvSpPr>
-          <p:cNvPr id="8" name="TextBox 7"/>
+              <a:t>Its output: valence and arousal.</a:t>
+            </a:r>
+          </a:p>
+        </p:txBody>
+      </p:sp>
+      <p:pic>
+        <p:nvPicPr>
+          <p:cNvPr id="10" name="Picture 9" descr="logo.png"/>
+          <p:cNvPicPr>
+            <a:picLocks noChangeAspect="1"/>
+          </p:cNvPicPr>
+          <p:nvPr/>
+        </p:nvPicPr>
+        <p:blipFill>
+          <a:blip r:embed="rId3"/>
+          <a:stretch>
+            <a:fillRect/>
+          </a:stretch>
+        </p:blipFill>
+        <p:spPr>
+          <a:xfrm>
+            <a:off x="914400" y="6236208"/>
+            <a:ext cx="2120348" cy="292608"/>
+          </a:xfrm>
+          <a:prstGeom prst="rect">
+            <a:avLst/>
+          </a:prstGeom>
+        </p:spPr>
+      </p:pic>
+      <p:sp>
+        <p:nvSpPr>
+          <p:cNvPr id="11" name="TextBox 10"/>
           <p:cNvSpPr txBox="1"/>
           <p:nvPr/>
         </p:nvSpPr>
         <p:spPr>
           <a:xfrm>
-            <a:off x="6565392" y="2423160"/>
-            <a:ext cx="4572000" cy="457200"/>
+            <a:off x="10637215" y="6309360"/>
+            <a:ext cx="640080" cy="274320"/>
           </a:xfrm>
           <a:prstGeom prst="rect">
             <a:avLst/>
@@ -5866,198 +5828,13 @@
           </a:bodyPr>
           <a:lstStyle/>
           <a:p>
-            <a:pPr algn="l"/>
-            <a:r>
-              <a:rPr sz="2800" b="1" i="0">
-                <a:solidFill>
-                  <a:srgbClr val="FFFFFF"/>
-                </a:solidFill>
-                <a:latin typeface="Georgia"/>
-              </a:rPr>
-              <a:t>Curatorial layer</a:t>
-            </a:r>
-          </a:p>
-        </p:txBody>
-      </p:sp>
-      <p:sp>
-        <p:nvSpPr>
-          <p:cNvPr id="9" name="TextBox 8"/>
-          <p:cNvSpPr txBox="1"/>
-          <p:nvPr/>
-        </p:nvSpPr>
-        <p:spPr>
-          <a:xfrm>
-            <a:off x="6565392" y="2971800"/>
-            <a:ext cx="4572000" cy="365760"/>
-          </a:xfrm>
-          <a:prstGeom prst="rect">
-            <a:avLst/>
-          </a:prstGeom>
-          <a:noFill/>
-        </p:spPr>
-        <p:txBody>
-          <a:bodyPr wrap="square" lIns="0" rIns="0" tIns="0" bIns="0" anchor="t">
-            <a:noAutofit/>
-          </a:bodyPr>
-          <a:lstStyle/>
-          <a:p>
-            <a:pPr algn="l"/>
-            <a:r>
-              <a:rPr sz="1500" b="1" i="0">
-                <a:solidFill>
-                  <a:srgbClr val="C9D8E3"/>
-                </a:solidFill>
-                <a:latin typeface="Helvetica Neue"/>
-              </a:rPr>
-              <a:t>DESIGNED</a:t>
-            </a:r>
-          </a:p>
-        </p:txBody>
-      </p:sp>
-      <p:sp>
-        <p:nvSpPr>
-          <p:cNvPr id="10" name="TextBox 9"/>
-          <p:cNvSpPr txBox="1"/>
-          <p:nvPr/>
-        </p:nvSpPr>
-        <p:spPr>
-          <a:xfrm>
-            <a:off x="6565392" y="3520440"/>
-            <a:ext cx="4572000" cy="2468880"/>
-          </a:xfrm>
-          <a:prstGeom prst="rect">
-            <a:avLst/>
-          </a:prstGeom>
-          <a:noFill/>
-        </p:spPr>
-        <p:txBody>
-          <a:bodyPr wrap="square" lIns="0" rIns="0" tIns="0" bIns="0" anchor="t">
-            <a:noAutofit/>
-          </a:bodyPr>
-          <a:lstStyle/>
-          <a:p>
-            <a:pPr algn="l">
-              <a:lnSpc>
-                <a:spcPct val="110000"/>
-              </a:lnSpc>
-              <a:spcAft>
-                <a:spcPts val="1100"/>
-              </a:spcAft>
-            </a:pPr>
-            <a:r>
-              <a:rPr sz="1700" b="0" i="0">
-                <a:solidFill>
-                  <a:srgbClr val="FFFFFF"/>
-                </a:solidFill>
-                <a:latin typeface="Helvetica Neue"/>
-              </a:rPr>
-              <a:t>Decides what a drought or a flood should feel like: how alarming, how heavy.</a:t>
-            </a:r>
-          </a:p>
-          <a:p>
-            <a:pPr algn="l">
-              <a:lnSpc>
-                <a:spcPct val="110000"/>
-              </a:lnSpc>
-              <a:spcAft>
-                <a:spcPts val="1100"/>
-              </a:spcAft>
-            </a:pPr>
-            <a:r>
-              <a:rPr sz="1700" b="0" i="0">
-                <a:solidFill>
-                  <a:srgbClr val="FFFFFF"/>
-                </a:solidFill>
-                <a:latin typeface="Helvetica Neue"/>
-              </a:rPr>
-              <a:t>Kept separate from the measurements, so the feeling can be redesigned without changing any of the science.</a:t>
-            </a:r>
-          </a:p>
-          <a:p>
-            <a:pPr algn="l">
-              <a:lnSpc>
-                <a:spcPct val="110000"/>
-              </a:lnSpc>
-              <a:spcAft>
-                <a:spcPts val="1100"/>
-              </a:spcAft>
-            </a:pPr>
-            <a:r>
-              <a:rPr sz="1700" b="0" i="0">
-                <a:solidFill>
-                  <a:srgbClr val="FFFFFF"/>
-                </a:solidFill>
-                <a:latin typeface="Helvetica Neue"/>
-              </a:rPr>
-              <a:t>Its output: valence and arousal.</a:t>
-            </a:r>
-          </a:p>
-        </p:txBody>
-      </p:sp>
-      <p:sp>
-        <p:nvSpPr>
-          <p:cNvPr id="11" name="TextBox 10"/>
-          <p:cNvSpPr txBox="1"/>
-          <p:nvPr/>
-        </p:nvSpPr>
-        <p:spPr>
-          <a:xfrm>
-            <a:off x="731520" y="6419088"/>
-            <a:ext cx="7315200" cy="274320"/>
-          </a:xfrm>
-          <a:prstGeom prst="rect">
-            <a:avLst/>
-          </a:prstGeom>
-          <a:noFill/>
-        </p:spPr>
-        <p:txBody>
-          <a:bodyPr wrap="square" lIns="0" rIns="0" tIns="0" bIns="0" anchor="t">
-            <a:noAutofit/>
-          </a:bodyPr>
-          <a:lstStyle/>
-          <a:p>
-            <a:pPr algn="l"/>
+            <a:pPr algn="r"/>
             <a:r>
               <a:rPr sz="1100" b="0" i="0">
                 <a:solidFill>
-                  <a:srgbClr val="5C6F7B"/>
-                </a:solidFill>
-                <a:latin typeface="Helvetica Neue"/>
-              </a:rPr>
-              <a:t>Noéa  ·  Meeting of Waters, Geneva</a:t>
-            </a:r>
-          </a:p>
-        </p:txBody>
-      </p:sp>
-      <p:sp>
-        <p:nvSpPr>
-          <p:cNvPr id="12" name="TextBox 11"/>
-          <p:cNvSpPr txBox="1"/>
-          <p:nvPr/>
-        </p:nvSpPr>
-        <p:spPr>
-          <a:xfrm>
-            <a:off x="10881360" y="6419088"/>
-            <a:ext cx="594360" cy="274320"/>
-          </a:xfrm>
-          <a:prstGeom prst="rect">
-            <a:avLst/>
-          </a:prstGeom>
-          <a:noFill/>
-        </p:spPr>
-        <p:txBody>
-          <a:bodyPr wrap="square" lIns="0" rIns="0" tIns="0" bIns="0" anchor="t">
-            <a:noAutofit/>
-          </a:bodyPr>
-          <a:lstStyle/>
-          <a:p>
-            <a:pPr algn="r"/>
-            <a:r>
-              <a:rPr sz="1100" b="0" i="0">
-                <a:solidFill>
-                  <a:srgbClr val="5C6F7B"/>
-                </a:solidFill>
-                <a:latin typeface="Helvetica Neue"/>
+                  <a:srgbClr val="5F6F78"/>
+                </a:solidFill>
+                <a:latin typeface="Frutiger"/>
               </a:rPr>
               <a:t>4</a:t>
             </a:r>
@@ -6078,7 +5855,7 @@
     <p:bg>
       <p:bgPr>
         <a:solidFill>
-          <a:srgbClr val="F6F9FB"/>
+          <a:srgbClr val="FFFFFF"/>
         </a:solidFill>
         <a:effectLst/>
       </p:bgPr>
@@ -6098,8 +5875,8 @@
         </p:nvSpPr>
         <p:spPr>
           <a:xfrm>
-            <a:off x="731520" y="640080"/>
-            <a:ext cx="10698480" cy="1463040"/>
+            <a:off x="914400" y="685800"/>
+            <a:ext cx="10362895" cy="1371600"/>
           </a:xfrm>
           <a:prstGeom prst="rect">
             <a:avLst/>
@@ -6118,11 +5895,11 @@
               </a:lnSpc>
             </a:pPr>
             <a:r>
-              <a:rPr sz="3800" b="1" i="0">
-                <a:solidFill>
-                  <a:srgbClr val="0B2545"/>
-                </a:solidFill>
-                <a:latin typeface="Georgia"/>
+              <a:rPr sz="4000" b="0" i="0">
+                <a:solidFill>
+                  <a:srgbClr val="111A20"/>
+                </a:solidFill>
+                <a:latin typeface="Athelas"/>
               </a:rPr>
               <a:t>Machine learning finds unusual years</a:t>
             </a:r>
@@ -6137,8 +5914,8 @@
         </p:nvSpPr>
         <p:spPr>
           <a:xfrm>
-            <a:off x="731520" y="1417320"/>
-            <a:ext cx="10698480" cy="822960"/>
+            <a:off x="914400" y="1417320"/>
+            <a:ext cx="10362895" cy="731520"/>
           </a:xfrm>
           <a:prstGeom prst="rect">
             <a:avLst/>
@@ -6153,15 +5930,15 @@
           <a:p>
             <a:pPr algn="l">
               <a:lnSpc>
-                <a:spcPct val="110000"/>
+                <a:spcPct val="112000"/>
               </a:lnSpc>
             </a:pPr>
             <a:r>
-              <a:rPr sz="1800" b="0" i="0">
-                <a:solidFill>
-                  <a:srgbClr val="5C6F7B"/>
-                </a:solidFill>
-                <a:latin typeface="Helvetica Neue"/>
+              <a:rPr sz="1600" b="0" i="0">
+                <a:solidFill>
+                  <a:srgbClr val="5F6F78"/>
+                </a:solidFill>
+                <a:latin typeface="Frutiger"/>
               </a:rPr>
               <a:t>Its one job so far: for each record, an unsupervised model learns what a typical year looks like, then scores how badly each year fails to fit.</a:t>
             </a:r>
@@ -6170,7 +5947,7 @@
       </p:sp>
       <p:pic>
         <p:nvPicPr>
-          <p:cNvPr id="4" name="Picture 3" descr="anomaly_floods.png"/>
+          <p:cNvPr id="4" name="Picture 3" descr="anomaly_floods2.png"/>
           <p:cNvPicPr>
             <a:picLocks noChangeAspect="1"/>
           </p:cNvPicPr>
@@ -6184,8 +5961,8 @@
         </p:blipFill>
         <p:spPr>
           <a:xfrm>
-            <a:off x="457200" y="2240280"/>
-            <a:ext cx="11274552" cy="3182333"/>
+            <a:off x="914400" y="2148840"/>
+            <a:ext cx="10362895" cy="3019046"/>
           </a:xfrm>
           <a:prstGeom prst="rect">
             <a:avLst/>
@@ -6200,8 +5977,8 @@
         </p:nvSpPr>
         <p:spPr>
           <a:xfrm>
-            <a:off x="731520" y="5532120"/>
-            <a:ext cx="10698480" cy="365760"/>
+            <a:off x="914400" y="5230368"/>
+            <a:ext cx="10362895" cy="365760"/>
           </a:xfrm>
           <a:prstGeom prst="rect">
             <a:avLst/>
@@ -6216,20 +5993,20 @@
           <a:p>
             <a:pPr algn="l"/>
             <a:r>
-              <a:rPr sz="1700" b="1" i="0">
-                <a:solidFill>
-                  <a:srgbClr val="0B2545"/>
-                </a:solidFill>
-                <a:latin typeface="Helvetica Neue"/>
+              <a:rPr sz="1500" b="1" i="0">
+                <a:solidFill>
+                  <a:srgbClr val="111A20"/>
+                </a:solidFill>
+                <a:latin typeface="Frutiger"/>
               </a:rPr>
               <a:t>The highlighted bar is each station's highest-scoring year. </a:t>
             </a:r>
             <a:r>
-              <a:rPr sz="1700" b="0" i="0">
-                <a:solidFill>
-                  <a:srgbClr val="0B2545"/>
-                </a:solidFill>
-                <a:latin typeface="Helvetica Neue"/>
+              <a:rPr sz="1500" b="0" i="0">
+                <a:solidFill>
+                  <a:srgbClr val="111A20"/>
+                </a:solidFill>
+                <a:latin typeface="Frutiger"/>
               </a:rPr>
               <a:t>The model was never told these events existed.</a:t>
             </a:r>
@@ -6244,8 +6021,8 @@
         </p:nvSpPr>
         <p:spPr>
           <a:xfrm>
-            <a:off x="731520" y="5943600"/>
-            <a:ext cx="10789920" cy="457200"/>
+            <a:off x="914400" y="5623560"/>
+            <a:ext cx="10362895" cy="457200"/>
           </a:xfrm>
           <a:prstGeom prst="rect">
             <a:avLst/>
@@ -6260,31 +6037,55 @@
           <a:p>
             <a:pPr algn="l">
               <a:lnSpc>
-                <a:spcPct val="105000"/>
+                <a:spcPct val="108000"/>
               </a:lnSpc>
             </a:pPr>
             <a:r>
-              <a:rPr sz="1100" b="0" i="0">
-                <a:solidFill>
-                  <a:srgbClr val="5C6F7B"/>
-                </a:solidFill>
-                <a:latin typeface="Helvetica Neue"/>
+              <a:rPr sz="1000" b="0" i="0">
+                <a:solidFill>
+                  <a:srgbClr val="5F6F78"/>
+                </a:solidFill>
+                <a:latin typeface="Frutiger"/>
               </a:rPr>
               <a:t>Method: PCA reconstruction error, fit separately per station on its own years. Events: Aug 2005 Alpine floods (22–23 Aug), May 1999 Swiss floods (Thun, 15 May), Christmas 1993 Rhine flood (Köln, 24 Dec).</a:t>
             </a:r>
           </a:p>
         </p:txBody>
       </p:sp>
-      <p:sp>
-        <p:nvSpPr>
-          <p:cNvPr id="7" name="TextBox 6"/>
+      <p:pic>
+        <p:nvPicPr>
+          <p:cNvPr id="7" name="Picture 6" descr="logo.png"/>
+          <p:cNvPicPr>
+            <a:picLocks noChangeAspect="1"/>
+          </p:cNvPicPr>
+          <p:nvPr/>
+        </p:nvPicPr>
+        <p:blipFill>
+          <a:blip r:embed="rId4"/>
+          <a:stretch>
+            <a:fillRect/>
+          </a:stretch>
+        </p:blipFill>
+        <p:spPr>
+          <a:xfrm>
+            <a:off x="914400" y="6236208"/>
+            <a:ext cx="2120348" cy="292608"/>
+          </a:xfrm>
+          <a:prstGeom prst="rect">
+            <a:avLst/>
+          </a:prstGeom>
+        </p:spPr>
+      </p:pic>
+      <p:sp>
+        <p:nvSpPr>
+          <p:cNvPr id="8" name="TextBox 7"/>
           <p:cNvSpPr txBox="1"/>
           <p:nvPr/>
         </p:nvSpPr>
         <p:spPr>
           <a:xfrm>
-            <a:off x="731520" y="6419088"/>
-            <a:ext cx="7315200" cy="274320"/>
+            <a:off x="10637215" y="6309360"/>
+            <a:ext cx="640080" cy="274320"/>
           </a:xfrm>
           <a:prstGeom prst="rect">
             <a:avLst/>
@@ -6297,48 +6098,13 @@
           </a:bodyPr>
           <a:lstStyle/>
           <a:p>
-            <a:pPr algn="l"/>
+            <a:pPr algn="r"/>
             <a:r>
               <a:rPr sz="1100" b="0" i="0">
                 <a:solidFill>
-                  <a:srgbClr val="5C6F7B"/>
-                </a:solidFill>
-                <a:latin typeface="Helvetica Neue"/>
-              </a:rPr>
-              <a:t>Noéa  ·  Meeting of Waters, Geneva</a:t>
-            </a:r>
-          </a:p>
-        </p:txBody>
-      </p:sp>
-      <p:sp>
-        <p:nvSpPr>
-          <p:cNvPr id="8" name="TextBox 7"/>
-          <p:cNvSpPr txBox="1"/>
-          <p:nvPr/>
-        </p:nvSpPr>
-        <p:spPr>
-          <a:xfrm>
-            <a:off x="10881360" y="6419088"/>
-            <a:ext cx="594360" cy="274320"/>
-          </a:xfrm>
-          <a:prstGeom prst="rect">
-            <a:avLst/>
-          </a:prstGeom>
-          <a:noFill/>
-        </p:spPr>
-        <p:txBody>
-          <a:bodyPr wrap="square" lIns="0" rIns="0" tIns="0" bIns="0" anchor="t">
-            <a:noAutofit/>
-          </a:bodyPr>
-          <a:lstStyle/>
-          <a:p>
-            <a:pPr algn="r"/>
-            <a:r>
-              <a:rPr sz="1100" b="0" i="0">
-                <a:solidFill>
-                  <a:srgbClr val="5C6F7B"/>
-                </a:solidFill>
-                <a:latin typeface="Helvetica Neue"/>
+                  <a:srgbClr val="5F6F78"/>
+                </a:solidFill>
+                <a:latin typeface="Frutiger"/>
               </a:rPr>
               <a:t>5</a:t>
             </a:r>
@@ -6359,7 +6125,7 @@
     <p:bg>
       <p:bgPr>
         <a:solidFill>
-          <a:srgbClr val="F6F9FB"/>
+          <a:srgbClr val="FFFFFF"/>
         </a:solidFill>
         <a:effectLst/>
       </p:bgPr>
@@ -6379,8 +6145,8 @@
         </p:nvSpPr>
         <p:spPr>
           <a:xfrm>
-            <a:off x="731520" y="640080"/>
-            <a:ext cx="10698480" cy="1463040"/>
+            <a:off x="914400" y="685800"/>
+            <a:ext cx="10362895" cy="1371600"/>
           </a:xfrm>
           <a:prstGeom prst="rect">
             <a:avLst/>
@@ -6399,11 +6165,11 @@
               </a:lnSpc>
             </a:pPr>
             <a:r>
-              <a:rPr sz="3800" b="1" i="0">
-                <a:solidFill>
-                  <a:srgbClr val="0B2545"/>
-                </a:solidFill>
-                <a:latin typeface="Georgia"/>
+              <a:rPr sz="4000" b="0" i="0">
+                <a:solidFill>
+                  <a:srgbClr val="111A20"/>
+                </a:solidFill>
+                <a:latin typeface="Athelas"/>
               </a:rPr>
               <a:t>Built to travel</a:t>
             </a:r>
@@ -6418,8 +6184,8 @@
         </p:nvSpPr>
         <p:spPr>
           <a:xfrm>
-            <a:off x="731520" y="1417320"/>
-            <a:ext cx="10698480" cy="822960"/>
+            <a:off x="914400" y="1417320"/>
+            <a:ext cx="10362895" cy="731520"/>
           </a:xfrm>
           <a:prstGeom prst="rect">
             <a:avLst/>
@@ -6434,67 +6200,56 @@
           <a:p>
             <a:pPr algn="l">
               <a:lnSpc>
-                <a:spcPct val="110000"/>
+                <a:spcPct val="112000"/>
               </a:lnSpc>
             </a:pPr>
             <a:r>
-              <a:rPr sz="2000" b="0" i="0">
-                <a:solidFill>
-                  <a:srgbClr val="5C6F7B"/>
-                </a:solidFill>
-                <a:latin typeface="Helvetica Neue"/>
+              <a:rPr sz="1700" b="0" i="0">
+                <a:solidFill>
+                  <a:srgbClr val="5F6F78"/>
+                </a:solidFill>
+                <a:latin typeface="Frutiger"/>
               </a:rPr>
               <a:t>Each record fits its own model on its own history. Another rainfall or river record can go through the same pipeline.</a:t>
             </a:r>
           </a:p>
         </p:txBody>
       </p:sp>
-      <p:sp>
-        <p:nvSpPr>
-          <p:cNvPr id="4" name="Rounded Rectangle 3"/>
-          <p:cNvSpPr/>
-          <p:nvPr/>
-        </p:nvSpPr>
-        <p:spPr>
-          <a:xfrm>
-            <a:off x="731520" y="2514600"/>
-            <a:ext cx="3429000" cy="2880360"/>
-          </a:xfrm>
-          <a:prstGeom prst="roundRect">
-            <a:avLst>
-              <a:gd name="adj" fmla="val 5000"/>
-            </a:avLst>
-          </a:prstGeom>
-          <a:solidFill>
-            <a:srgbClr val="EAF1F6"/>
-          </a:solidFill>
-          <a:ln>
-            <a:noFill/>
+      <p:cxnSp>
+        <p:nvCxnSpPr>
+          <p:cNvPr id="4" name="Connector 3"/>
+          <p:cNvCxnSpPr/>
+          <p:nvPr/>
+        </p:nvCxnSpPr>
+        <p:spPr>
+          <a:xfrm>
+            <a:off x="914400" y="2926080"/>
+            <a:ext cx="3200400" cy="0"/>
+          </a:xfrm>
+          <a:prstGeom prst="line">
+            <a:avLst/>
+          </a:prstGeom>
+          <a:ln w="38100">
+            <a:solidFill>
+              <a:srgbClr val="00526F"/>
+            </a:solidFill>
           </a:ln>
-          <a:effectLst/>
         </p:spPr>
         <p:style>
-          <a:lnRef idx="1">
+          <a:lnRef idx="2">
             <a:schemeClr val="accent1"/>
           </a:lnRef>
-          <a:fillRef idx="3">
+          <a:fillRef idx="0">
             <a:schemeClr val="accent1"/>
           </a:fillRef>
-          <a:effectRef idx="2">
+          <a:effectRef idx="1">
             <a:schemeClr val="accent1"/>
           </a:effectRef>
           <a:fontRef idx="minor">
-            <a:schemeClr val="lt1"/>
+            <a:schemeClr val="tx1"/>
           </a:fontRef>
         </p:style>
-        <p:txBody>
-          <a:bodyPr rtlCol="0" anchor="ctr"/>
-          <a:lstStyle/>
-          <a:p>
-            <a:pPr algn="ctr"/>
-          </a:p>
-        </p:txBody>
-      </p:sp>
+      </p:cxnSp>
       <p:sp>
         <p:nvSpPr>
           <p:cNvPr id="5" name="TextBox 4"/>
@@ -6503,8 +6258,43 @@
         </p:nvSpPr>
         <p:spPr>
           <a:xfrm>
-            <a:off x="1051560" y="2788920"/>
-            <a:ext cx="2834640" cy="822960"/>
+            <a:off x="914400" y="3200400"/>
+            <a:ext cx="3200400" cy="274320"/>
+          </a:xfrm>
+          <a:prstGeom prst="rect">
+            <a:avLst/>
+          </a:prstGeom>
+          <a:noFill/>
+        </p:spPr>
+        <p:txBody>
+          <a:bodyPr wrap="square" lIns="0" rIns="0" tIns="0" bIns="0" anchor="t">
+            <a:noAutofit/>
+          </a:bodyPr>
+          <a:lstStyle/>
+          <a:p>
+            <a:pPr algn="l"/>
+            <a:r>
+              <a:rPr sz="1200" b="1" i="0" spc="140">
+                <a:solidFill>
+                  <a:srgbClr val="00526F"/>
+                </a:solidFill>
+                <a:latin typeface="Frutiger"/>
+              </a:rPr>
+              <a:t>HONG KONG OBSERVATORY</a:t>
+            </a:r>
+          </a:p>
+        </p:txBody>
+      </p:sp>
+      <p:sp>
+        <p:nvSpPr>
+          <p:cNvPr id="6" name="TextBox 5"/>
+          <p:cNvSpPr txBox="1"/>
+          <p:nvPr/>
+        </p:nvSpPr>
+        <p:spPr>
+          <a:xfrm>
+            <a:off x="914400" y="3657600"/>
+            <a:ext cx="3108960" cy="914400"/>
           </a:xfrm>
           <a:prstGeom prst="rect">
             <a:avLst/>
@@ -6523,11 +6313,11 @@
               </a:lnSpc>
             </a:pPr>
             <a:r>
-              <a:rPr sz="2400" b="1" i="0">
-                <a:solidFill>
-                  <a:srgbClr val="0B2545"/>
-                </a:solidFill>
-                <a:latin typeface="Georgia"/>
+              <a:rPr sz="2600" b="0" i="0">
+                <a:solidFill>
+                  <a:srgbClr val="111A20"/>
+                </a:solidFill>
+                <a:latin typeface="Athelas"/>
               </a:rPr>
               <a:t>Hong Kong rainfall</a:t>
             </a:r>
@@ -6536,14 +6326,14 @@
       </p:sp>
       <p:sp>
         <p:nvSpPr>
-          <p:cNvPr id="6" name="TextBox 5"/>
+          <p:cNvPr id="7" name="TextBox 6"/>
           <p:cNvSpPr txBox="1"/>
           <p:nvPr/>
         </p:nvSpPr>
         <p:spPr>
           <a:xfrm>
-            <a:off x="1051560" y="3657600"/>
-            <a:ext cx="2834640" cy="365760"/>
+            <a:off x="914400" y="4709160"/>
+            <a:ext cx="3108960" cy="1463040"/>
           </a:xfrm>
           <a:prstGeom prst="rect">
             <a:avLst/>
@@ -6556,29 +6346,90 @@
           </a:bodyPr>
           <a:lstStyle/>
           <a:p>
-            <a:pPr algn="l"/>
-            <a:r>
-              <a:rPr sz="1400" b="1" i="0">
-                <a:solidFill>
-                  <a:srgbClr val="2E6F9E"/>
-                </a:solidFill>
-                <a:latin typeface="Helvetica Neue"/>
+            <a:pPr algn="l">
+              <a:lnSpc>
+                <a:spcPct val="112000"/>
+              </a:lnSpc>
+              <a:spcAft>
+                <a:spcPts val="700"/>
+              </a:spcAft>
+            </a:pPr>
+            <a:r>
+              <a:rPr sz="1550" b="0" i="0">
+                <a:solidFill>
+                  <a:srgbClr val="111A20"/>
+                </a:solidFill>
+                <a:latin typeface="Frutiger"/>
               </a:rPr>
-              <a:t>HONG KONG OBSERVATORY</a:t>
-            </a:r>
-          </a:p>
-        </p:txBody>
-      </p:sp>
-      <p:sp>
-        <p:nvSpPr>
-          <p:cNvPr id="7" name="TextBox 6"/>
+              <a:t>Daily, 1884–2025</a:t>
+            </a:r>
+          </a:p>
+          <a:p>
+            <a:pPr algn="l">
+              <a:lnSpc>
+                <a:spcPct val="112000"/>
+              </a:lnSpc>
+              <a:spcAft>
+                <a:spcPts val="700"/>
+              </a:spcAft>
+            </a:pPr>
+            <a:r>
+              <a:rPr sz="1550" b="0" i="0">
+                <a:solidFill>
+                  <a:srgbClr val="111A20"/>
+                </a:solidFill>
+                <a:latin typeface="Frutiger"/>
+              </a:rPr>
+              <a:t>One model, fit on 134 years</a:t>
+            </a:r>
+          </a:p>
+        </p:txBody>
+      </p:sp>
+      <p:cxnSp>
+        <p:nvCxnSpPr>
+          <p:cNvPr id="8" name="Connector 7"/>
+          <p:cNvCxnSpPr/>
+          <p:nvPr/>
+        </p:nvCxnSpPr>
+        <p:spPr>
+          <a:xfrm>
+            <a:off x="4494276" y="2926080"/>
+            <a:ext cx="3200399" cy="0"/>
+          </a:xfrm>
+          <a:prstGeom prst="line">
+            <a:avLst/>
+          </a:prstGeom>
+          <a:ln w="38100">
+            <a:solidFill>
+              <a:srgbClr val="00526F"/>
+            </a:solidFill>
+          </a:ln>
+        </p:spPr>
+        <p:style>
+          <a:lnRef idx="2">
+            <a:schemeClr val="accent1"/>
+          </a:lnRef>
+          <a:fillRef idx="0">
+            <a:schemeClr val="accent1"/>
+          </a:fillRef>
+          <a:effectRef idx="1">
+            <a:schemeClr val="accent1"/>
+          </a:effectRef>
+          <a:fontRef idx="minor">
+            <a:schemeClr val="tx1"/>
+          </a:fontRef>
+        </p:style>
+      </p:cxnSp>
+      <p:sp>
+        <p:nvSpPr>
+          <p:cNvPr id="9" name="TextBox 8"/>
           <p:cNvSpPr txBox="1"/>
           <p:nvPr/>
         </p:nvSpPr>
         <p:spPr>
           <a:xfrm>
-            <a:off x="1051560" y="4160520"/>
-            <a:ext cx="2834640" cy="1463040"/>
+            <a:off x="4494276" y="3200400"/>
+            <a:ext cx="3200400" cy="274320"/>
           </a:xfrm>
           <a:prstGeom prst="rect">
             <a:avLst/>
@@ -6591,101 +6442,29 @@
           </a:bodyPr>
           <a:lstStyle/>
           <a:p>
-            <a:pPr algn="l">
-              <a:lnSpc>
-                <a:spcPct val="110000"/>
-              </a:lnSpc>
-              <a:spcAft>
-                <a:spcPts val="600"/>
-              </a:spcAft>
-            </a:pPr>
-            <a:r>
-              <a:rPr sz="1600" b="0" i="0">
-                <a:solidFill>
-                  <a:srgbClr val="0B2545"/>
-                </a:solidFill>
-                <a:latin typeface="Helvetica Neue"/>
+            <a:pPr algn="l"/>
+            <a:r>
+              <a:rPr sz="1200" b="1" i="0" spc="140">
+                <a:solidFill>
+                  <a:srgbClr val="00526F"/>
+                </a:solidFill>
+                <a:latin typeface="Frutiger"/>
               </a:rPr>
-              <a:t>Daily, 1884–2025</a:t>
-            </a:r>
-          </a:p>
-          <a:p>
-            <a:pPr algn="l">
-              <a:lnSpc>
-                <a:spcPct val="110000"/>
-              </a:lnSpc>
-              <a:spcAft>
-                <a:spcPts val="600"/>
-              </a:spcAft>
-            </a:pPr>
-            <a:r>
-              <a:rPr sz="1600" b="0" i="0">
-                <a:solidFill>
-                  <a:srgbClr val="0B2545"/>
-                </a:solidFill>
-                <a:latin typeface="Helvetica Neue"/>
-              </a:rPr>
-              <a:t>One model, fit on 134 years</a:t>
-            </a:r>
-          </a:p>
-        </p:txBody>
-      </p:sp>
-      <p:sp>
-        <p:nvSpPr>
-          <p:cNvPr id="8" name="Rounded Rectangle 7"/>
-          <p:cNvSpPr/>
-          <p:nvPr/>
-        </p:nvSpPr>
-        <p:spPr>
-          <a:xfrm>
-            <a:off x="4379976" y="2514600"/>
-            <a:ext cx="3429000" cy="2880360"/>
-          </a:xfrm>
-          <a:prstGeom prst="roundRect">
-            <a:avLst>
-              <a:gd name="adj" fmla="val 5000"/>
-            </a:avLst>
-          </a:prstGeom>
-          <a:solidFill>
-            <a:srgbClr val="EAF1F6"/>
-          </a:solidFill>
-          <a:ln>
-            <a:noFill/>
-          </a:ln>
-          <a:effectLst/>
-        </p:spPr>
-        <p:style>
-          <a:lnRef idx="1">
-            <a:schemeClr val="accent1"/>
-          </a:lnRef>
-          <a:fillRef idx="3">
-            <a:schemeClr val="accent1"/>
-          </a:fillRef>
-          <a:effectRef idx="2">
-            <a:schemeClr val="accent1"/>
-          </a:effectRef>
-          <a:fontRef idx="minor">
-            <a:schemeClr val="lt1"/>
-          </a:fontRef>
-        </p:style>
-        <p:txBody>
-          <a:bodyPr rtlCol="0" anchor="ctr"/>
-          <a:lstStyle/>
-          <a:p>
-            <a:pPr algn="ctr"/>
-          </a:p>
-        </p:txBody>
-      </p:sp>
-      <p:sp>
-        <p:nvSpPr>
-          <p:cNvPr id="9" name="TextBox 8"/>
+              <a:t>GRDC, FOEN</a:t>
+            </a:r>
+          </a:p>
+        </p:txBody>
+      </p:sp>
+      <p:sp>
+        <p:nvSpPr>
+          <p:cNvPr id="10" name="TextBox 9"/>
           <p:cNvSpPr txBox="1"/>
           <p:nvPr/>
         </p:nvSpPr>
         <p:spPr>
           <a:xfrm>
-            <a:off x="4700016" y="2788920"/>
-            <a:ext cx="2834640" cy="822960"/>
+            <a:off x="4494276" y="3657600"/>
+            <a:ext cx="3108960" cy="914400"/>
           </a:xfrm>
           <a:prstGeom prst="rect">
             <a:avLst/>
@@ -6704,11 +6483,11 @@
               </a:lnSpc>
             </a:pPr>
             <a:r>
-              <a:rPr sz="2400" b="1" i="0">
-                <a:solidFill>
-                  <a:srgbClr val="0B2545"/>
-                </a:solidFill>
-                <a:latin typeface="Georgia"/>
+              <a:rPr sz="2600" b="0" i="0">
+                <a:solidFill>
+                  <a:srgbClr val="111A20"/>
+                </a:solidFill>
+                <a:latin typeface="Athelas"/>
               </a:rPr>
               <a:t>Rhine and alpine rivers</a:t>
             </a:r>
@@ -6717,14 +6496,14 @@
       </p:sp>
       <p:sp>
         <p:nvSpPr>
-          <p:cNvPr id="10" name="TextBox 9"/>
+          <p:cNvPr id="11" name="TextBox 10"/>
           <p:cNvSpPr txBox="1"/>
           <p:nvPr/>
         </p:nvSpPr>
         <p:spPr>
           <a:xfrm>
-            <a:off x="4700016" y="3657600"/>
-            <a:ext cx="2834640" cy="365760"/>
+            <a:off x="4494276" y="4709160"/>
+            <a:ext cx="3108960" cy="1463040"/>
           </a:xfrm>
           <a:prstGeom prst="rect">
             <a:avLst/>
@@ -6737,29 +6516,91 @@
           </a:bodyPr>
           <a:lstStyle/>
           <a:p>
-            <a:pPr algn="l"/>
-            <a:r>
-              <a:rPr sz="1400" b="1" i="0">
-                <a:solidFill>
-                  <a:srgbClr val="2E6F9E"/>
-                </a:solidFill>
-                <a:latin typeface="Helvetica Neue"/>
+            <a:pPr algn="l">
+              <a:lnSpc>
+                <a:spcPct val="112000"/>
+              </a:lnSpc>
+              <a:spcAft>
+                <a:spcPts val="700"/>
+              </a:spcAft>
+            </a:pPr>
+            <a:r>
+              <a:rPr sz="1550" b="0" i="0">
+                <a:solidFill>
+                  <a:srgbClr val="111A20"/>
+                </a:solidFill>
+                <a:latin typeface="Frutiger"/>
               </a:rPr>
-              <a:t>GRDC  ·  FOEN</a:t>
-            </a:r>
-          </a:p>
-        </p:txBody>
-      </p:sp>
-      <p:sp>
-        <p:nvSpPr>
-          <p:cNvPr id="11" name="TextBox 10"/>
+              <a:t>Daily, 8 stations</a:t>
+            </a:r>
+          </a:p>
+          <a:p>
+            <a:pPr algn="l">
+              <a:lnSpc>
+                <a:spcPct val="112000"/>
+              </a:lnSpc>
+              <a:spcAft>
+                <a:spcPts val="700"/>
+              </a:spcAft>
+            </a:pPr>
+            <a:r>
+              <a:rPr sz="1550" b="0" i="0">
+                <a:solidFill>
+                  <a:srgbClr val="111A20"/>
+                </a:solidFill>
+                <a:latin typeface="Frutiger"/>
+              </a:rPr>
+              <a:t>One model per station, 62–208 years</a:t>
+            </a:r>
+          </a:p>
+        </p:txBody>
+      </p:sp>
+      <p:cxnSp>
+        <p:nvCxnSpPr>
+          <p:cNvPr id="12" name="Connector 11"/>
+          <p:cNvCxnSpPr/>
+          <p:nvPr/>
+        </p:nvCxnSpPr>
+        <p:spPr>
+          <a:xfrm>
+            <a:off x="8074152" y="2926080"/>
+            <a:ext cx="3200400" cy="0"/>
+          </a:xfrm>
+          <a:prstGeom prst="line">
+            <a:avLst/>
+          </a:prstGeom>
+          <a:ln w="22225">
+            <a:solidFill>
+              <a:srgbClr val="5390A2"/>
+            </a:solidFill>
+            <a:prstDash val="dash"/>
+          </a:ln>
+        </p:spPr>
+        <p:style>
+          <a:lnRef idx="2">
+            <a:schemeClr val="accent1"/>
+          </a:lnRef>
+          <a:fillRef idx="0">
+            <a:schemeClr val="accent1"/>
+          </a:fillRef>
+          <a:effectRef idx="1">
+            <a:schemeClr val="accent1"/>
+          </a:effectRef>
+          <a:fontRef idx="minor">
+            <a:schemeClr val="tx1"/>
+          </a:fontRef>
+        </p:style>
+      </p:cxnSp>
+      <p:sp>
+        <p:nvSpPr>
+          <p:cNvPr id="13" name="TextBox 12"/>
           <p:cNvSpPr txBox="1"/>
           <p:nvPr/>
         </p:nvSpPr>
         <p:spPr>
           <a:xfrm>
-            <a:off x="4700016" y="4160520"/>
-            <a:ext cx="2834640" cy="1463040"/>
+            <a:off x="8074152" y="3200400"/>
+            <a:ext cx="3200400" cy="274320"/>
           </a:xfrm>
           <a:prstGeom prst="rect">
             <a:avLst/>
@@ -6772,102 +6613,29 @@
           </a:bodyPr>
           <a:lstStyle/>
           <a:p>
-            <a:pPr algn="l">
-              <a:lnSpc>
-                <a:spcPct val="110000"/>
-              </a:lnSpc>
-              <a:spcAft>
-                <a:spcPts val="600"/>
-              </a:spcAft>
-            </a:pPr>
-            <a:r>
-              <a:rPr sz="1600" b="0" i="0">
-                <a:solidFill>
-                  <a:srgbClr val="0B2545"/>
-                </a:solidFill>
-                <a:latin typeface="Helvetica Neue"/>
+            <a:pPr algn="l"/>
+            <a:r>
+              <a:rPr sz="1200" b="1" i="0" spc="140">
+                <a:solidFill>
+                  <a:srgbClr val="5F6F78"/>
+                </a:solidFill>
+                <a:latin typeface="Frutiger"/>
               </a:rPr>
-              <a:t>Daily, 8 stations</a:t>
-            </a:r>
-          </a:p>
-          <a:p>
-            <a:pPr algn="l">
-              <a:lnSpc>
-                <a:spcPct val="110000"/>
-              </a:lnSpc>
-              <a:spcAft>
-                <a:spcPts val="600"/>
-              </a:spcAft>
-            </a:pPr>
-            <a:r>
-              <a:rPr sz="1600" b="0" i="0">
-                <a:solidFill>
-                  <a:srgbClr val="0B2545"/>
-                </a:solidFill>
-                <a:latin typeface="Helvetica Neue"/>
-              </a:rPr>
-              <a:t>One model per station, 62–208 years each</a:t>
-            </a:r>
-          </a:p>
-        </p:txBody>
-      </p:sp>
-      <p:sp>
-        <p:nvSpPr>
-          <p:cNvPr id="12" name="Rounded Rectangle 11"/>
-          <p:cNvSpPr/>
-          <p:nvPr/>
-        </p:nvSpPr>
-        <p:spPr>
-          <a:xfrm>
-            <a:off x="8028431" y="2514600"/>
-            <a:ext cx="3429000" cy="2880360"/>
-          </a:xfrm>
-          <a:prstGeom prst="roundRect">
-            <a:avLst>
-              <a:gd name="adj" fmla="val 5000"/>
-            </a:avLst>
-          </a:prstGeom>
-          <a:noFill/>
-          <a:ln w="22225">
-            <a:solidFill>
-              <a:srgbClr val="2E6F9E"/>
-            </a:solidFill>
-            <a:prstDash val="dash"/>
-          </a:ln>
-          <a:effectLst/>
-        </p:spPr>
-        <p:style>
-          <a:lnRef idx="1">
-            <a:schemeClr val="accent1"/>
-          </a:lnRef>
-          <a:fillRef idx="3">
-            <a:schemeClr val="accent1"/>
-          </a:fillRef>
-          <a:effectRef idx="2">
-            <a:schemeClr val="accent1"/>
-          </a:effectRef>
-          <a:fontRef idx="minor">
-            <a:schemeClr val="lt1"/>
-          </a:fontRef>
-        </p:style>
-        <p:txBody>
-          <a:bodyPr rtlCol="0" anchor="ctr"/>
-          <a:lstStyle/>
-          <a:p>
-            <a:pPr algn="ctr"/>
-          </a:p>
-        </p:txBody>
-      </p:sp>
-      <p:sp>
-        <p:nvSpPr>
-          <p:cNvPr id="13" name="TextBox 12"/>
+              <a:t>NOT YET RUN</a:t>
+            </a:r>
+          </a:p>
+        </p:txBody>
+      </p:sp>
+      <p:sp>
+        <p:nvSpPr>
+          <p:cNvPr id="14" name="TextBox 13"/>
           <p:cNvSpPr txBox="1"/>
           <p:nvPr/>
         </p:nvSpPr>
         <p:spPr>
           <a:xfrm>
-            <a:off x="8348471" y="2788920"/>
-            <a:ext cx="2834640" cy="822960"/>
+            <a:off x="8074152" y="3657600"/>
+            <a:ext cx="3108960" cy="914400"/>
           </a:xfrm>
           <a:prstGeom prst="rect">
             <a:avLst/>
@@ -6886,11 +6654,11 @@
               </a:lnSpc>
             </a:pPr>
             <a:r>
-              <a:rPr sz="2400" b="1" i="0">
-                <a:solidFill>
-                  <a:srgbClr val="0B2545"/>
-                </a:solidFill>
-                <a:latin typeface="Georgia"/>
+              <a:rPr sz="2600" b="0" i="0">
+                <a:solidFill>
+                  <a:srgbClr val="5F6F78"/>
+                </a:solidFill>
+                <a:latin typeface="Athelas"/>
               </a:rPr>
               <a:t>The next record</a:t>
             </a:r>
@@ -6899,14 +6667,14 @@
       </p:sp>
       <p:sp>
         <p:nvSpPr>
-          <p:cNvPr id="14" name="TextBox 13"/>
+          <p:cNvPr id="15" name="TextBox 14"/>
           <p:cNvSpPr txBox="1"/>
           <p:nvPr/>
         </p:nvSpPr>
         <p:spPr>
           <a:xfrm>
-            <a:off x="8348471" y="3657600"/>
-            <a:ext cx="2834640" cy="365760"/>
+            <a:off x="8074152" y="4709160"/>
+            <a:ext cx="3108960" cy="1463040"/>
           </a:xfrm>
           <a:prstGeom prst="rect">
             <a:avLst/>
@@ -6919,29 +6687,79 @@
           </a:bodyPr>
           <a:lstStyle/>
           <a:p>
-            <a:pPr algn="l"/>
-            <a:r>
-              <a:rPr sz="1400" b="1" i="0">
-                <a:solidFill>
-                  <a:srgbClr val="2E6F9E"/>
-                </a:solidFill>
-                <a:latin typeface="Helvetica Neue"/>
+            <a:pPr algn="l">
+              <a:lnSpc>
+                <a:spcPct val="112000"/>
+              </a:lnSpc>
+              <a:spcAft>
+                <a:spcPts val="700"/>
+              </a:spcAft>
+            </a:pPr>
+            <a:r>
+              <a:rPr sz="1550" b="0" i="0">
+                <a:solidFill>
+                  <a:srgbClr val="5F6F78"/>
+                </a:solidFill>
+                <a:latin typeface="Frutiger"/>
               </a:rPr>
-              <a:t>NOT YET RUN</a:t>
-            </a:r>
-          </a:p>
-        </p:txBody>
-      </p:sp>
-      <p:sp>
-        <p:nvSpPr>
-          <p:cNvPr id="15" name="TextBox 14"/>
+              <a:t>Another long rainfall or river series.</a:t>
+            </a:r>
+          </a:p>
+          <a:p>
+            <a:pPr algn="l">
+              <a:lnSpc>
+                <a:spcPct val="112000"/>
+              </a:lnSpc>
+              <a:spcAft>
+                <a:spcPts val="700"/>
+              </a:spcAft>
+            </a:pPr>
+            <a:r>
+              <a:rPr sz="1550" b="0" i="0">
+                <a:solidFill>
+                  <a:srgbClr val="5F6F78"/>
+                </a:solidFill>
+                <a:latin typeface="Frutiger"/>
+              </a:rPr>
+              <a:t>Tested on two records so far.</a:t>
+            </a:r>
+          </a:p>
+        </p:txBody>
+      </p:sp>
+      <p:pic>
+        <p:nvPicPr>
+          <p:cNvPr id="16" name="Picture 15" descr="logo.png"/>
+          <p:cNvPicPr>
+            <a:picLocks noChangeAspect="1"/>
+          </p:cNvPicPr>
+          <p:nvPr/>
+        </p:nvPicPr>
+        <p:blipFill>
+          <a:blip r:embed="rId3"/>
+          <a:stretch>
+            <a:fillRect/>
+          </a:stretch>
+        </p:blipFill>
+        <p:spPr>
+          <a:xfrm>
+            <a:off x="914400" y="6236208"/>
+            <a:ext cx="2120348" cy="292608"/>
+          </a:xfrm>
+          <a:prstGeom prst="rect">
+            <a:avLst/>
+          </a:prstGeom>
+        </p:spPr>
+      </p:pic>
+      <p:sp>
+        <p:nvSpPr>
+          <p:cNvPr id="17" name="TextBox 16"/>
           <p:cNvSpPr txBox="1"/>
           <p:nvPr/>
         </p:nvSpPr>
         <p:spPr>
           <a:xfrm>
-            <a:off x="8348471" y="4160520"/>
-            <a:ext cx="2834640" cy="1463040"/>
+            <a:off x="10637215" y="6309360"/>
+            <a:ext cx="640080" cy="274320"/>
           </a:xfrm>
           <a:prstGeom prst="rect">
             <a:avLst/>
@@ -6954,109 +6772,13 @@
           </a:bodyPr>
           <a:lstStyle/>
           <a:p>
-            <a:pPr algn="l">
-              <a:lnSpc>
-                <a:spcPct val="110000"/>
-              </a:lnSpc>
-              <a:spcAft>
-                <a:spcPts val="600"/>
-              </a:spcAft>
-            </a:pPr>
-            <a:r>
-              <a:rPr sz="1600" b="0" i="0">
-                <a:solidFill>
-                  <a:srgbClr val="0B2545"/>
-                </a:solidFill>
-                <a:latin typeface="Helvetica Neue"/>
-              </a:rPr>
-              <a:t>Another long rainfall or river series.</a:t>
-            </a:r>
-          </a:p>
-          <a:p>
-            <a:pPr algn="l">
-              <a:lnSpc>
-                <a:spcPct val="110000"/>
-              </a:lnSpc>
-              <a:spcAft>
-                <a:spcPts val="600"/>
-              </a:spcAft>
-            </a:pPr>
-            <a:r>
-              <a:rPr sz="1600" b="0" i="0">
-                <a:solidFill>
-                  <a:srgbClr val="0B2545"/>
-                </a:solidFill>
-                <a:latin typeface="Helvetica Neue"/>
-              </a:rPr>
-              <a:t>Tested on two records so far.</a:t>
-            </a:r>
-          </a:p>
-        </p:txBody>
-      </p:sp>
-      <p:sp>
-        <p:nvSpPr>
-          <p:cNvPr id="16" name="TextBox 15"/>
-          <p:cNvSpPr txBox="1"/>
-          <p:nvPr/>
-        </p:nvSpPr>
-        <p:spPr>
-          <a:xfrm>
-            <a:off x="731520" y="6419088"/>
-            <a:ext cx="7315200" cy="274320"/>
-          </a:xfrm>
-          <a:prstGeom prst="rect">
-            <a:avLst/>
-          </a:prstGeom>
-          <a:noFill/>
-        </p:spPr>
-        <p:txBody>
-          <a:bodyPr wrap="square" lIns="0" rIns="0" tIns="0" bIns="0" anchor="t">
-            <a:noAutofit/>
-          </a:bodyPr>
-          <a:lstStyle/>
-          <a:p>
-            <a:pPr algn="l"/>
+            <a:pPr algn="r"/>
             <a:r>
               <a:rPr sz="1100" b="0" i="0">
                 <a:solidFill>
-                  <a:srgbClr val="5C6F7B"/>
-                </a:solidFill>
-                <a:latin typeface="Helvetica Neue"/>
-              </a:rPr>
-              <a:t>Noéa  ·  Meeting of Waters, Geneva</a:t>
-            </a:r>
-          </a:p>
-        </p:txBody>
-      </p:sp>
-      <p:sp>
-        <p:nvSpPr>
-          <p:cNvPr id="17" name="TextBox 16"/>
-          <p:cNvSpPr txBox="1"/>
-          <p:nvPr/>
-        </p:nvSpPr>
-        <p:spPr>
-          <a:xfrm>
-            <a:off x="10881360" y="6419088"/>
-            <a:ext cx="594360" cy="274320"/>
-          </a:xfrm>
-          <a:prstGeom prst="rect">
-            <a:avLst/>
-          </a:prstGeom>
-          <a:noFill/>
-        </p:spPr>
-        <p:txBody>
-          <a:bodyPr wrap="square" lIns="0" rIns="0" tIns="0" bIns="0" anchor="t">
-            <a:noAutofit/>
-          </a:bodyPr>
-          <a:lstStyle/>
-          <a:p>
-            <a:pPr algn="r"/>
-            <a:r>
-              <a:rPr sz="1100" b="0" i="0">
-                <a:solidFill>
-                  <a:srgbClr val="5C6F7B"/>
-                </a:solidFill>
-                <a:latin typeface="Helvetica Neue"/>
+                  <a:srgbClr val="5F6F78"/>
+                </a:solidFill>
+                <a:latin typeface="Frutiger"/>
               </a:rPr>
               <a:t>6</a:t>
             </a:r>
@@ -7077,7 +6799,7 @@
     <p:bg>
       <p:bgPr>
         <a:solidFill>
-          <a:srgbClr val="F6F9FB"/>
+          <a:srgbClr val="FFFFFF"/>
         </a:solidFill>
         <a:effectLst/>
       </p:bgPr>
@@ -7097,8 +6819,8 @@
         </p:nvSpPr>
         <p:spPr>
           <a:xfrm>
-            <a:off x="731520" y="640080"/>
-            <a:ext cx="10698480" cy="1463040"/>
+            <a:off x="914400" y="685800"/>
+            <a:ext cx="10362895" cy="1371600"/>
           </a:xfrm>
           <a:prstGeom prst="rect">
             <a:avLst/>
@@ -7117,13 +6839,13 @@
               </a:lnSpc>
             </a:pPr>
             <a:r>
-              <a:rPr sz="3800" b="1" i="0">
-                <a:solidFill>
-                  <a:srgbClr val="0B2545"/>
-                </a:solidFill>
-                <a:latin typeface="Georgia"/>
+              <a:rPr sz="4000" b="0" i="0">
+                <a:solidFill>
+                  <a:srgbClr val="111A20"/>
+                </a:solidFill>
+                <a:latin typeface="Athelas"/>
               </a:rPr>
-              <a:t>What it doesn't do yet</a:t>
+              <a:t>The end result is how people respond</a:t>
             </a:r>
           </a:p>
         </p:txBody>
@@ -7136,8 +6858,8 @@
         </p:nvSpPr>
         <p:spPr>
           <a:xfrm>
-            <a:off x="731520" y="1737360"/>
-            <a:ext cx="731520" cy="731520"/>
+            <a:off x="914400" y="1417320"/>
+            <a:ext cx="10362895" cy="731520"/>
           </a:xfrm>
           <a:prstGeom prst="rect">
             <a:avLst/>
@@ -7150,29 +6872,103 @@
           </a:bodyPr>
           <a:lstStyle/>
           <a:p>
+            <a:pPr algn="l">
+              <a:lnSpc>
+                <a:spcPct val="112000"/>
+              </a:lnSpc>
+            </a:pPr>
+            <a:r>
+              <a:rPr sz="1700" b="0" i="0">
+                <a:solidFill>
+                  <a:srgbClr val="5F6F78"/>
+                </a:solidFill>
+                <a:latin typeface="Frutiger"/>
+              </a:rPr>
+              <a:t>The model's output is a score, not a feeling. What a flagged year should feel like comes from people, not from the model.</a:t>
+            </a:r>
+          </a:p>
+        </p:txBody>
+      </p:sp>
+      <p:cxnSp>
+        <p:nvCxnSpPr>
+          <p:cNvPr id="4" name="Connector 3"/>
+          <p:cNvCxnSpPr/>
+          <p:nvPr/>
+        </p:nvCxnSpPr>
+        <p:spPr>
+          <a:xfrm>
+            <a:off x="914400" y="2331720"/>
+            <a:ext cx="3200400" cy="0"/>
+          </a:xfrm>
+          <a:prstGeom prst="line">
+            <a:avLst/>
+          </a:prstGeom>
+          <a:ln w="38100">
+            <a:solidFill>
+              <a:srgbClr val="00526F"/>
+            </a:solidFill>
+          </a:ln>
+        </p:spPr>
+        <p:style>
+          <a:lnRef idx="2">
+            <a:schemeClr val="accent1"/>
+          </a:lnRef>
+          <a:fillRef idx="0">
+            <a:schemeClr val="accent1"/>
+          </a:fillRef>
+          <a:effectRef idx="1">
+            <a:schemeClr val="accent1"/>
+          </a:effectRef>
+          <a:fontRef idx="minor">
+            <a:schemeClr val="tx1"/>
+          </a:fontRef>
+        </p:style>
+      </p:cxnSp>
+      <p:sp>
+        <p:nvSpPr>
+          <p:cNvPr id="5" name="TextBox 4"/>
+          <p:cNvSpPr txBox="1"/>
+          <p:nvPr/>
+        </p:nvSpPr>
+        <p:spPr>
+          <a:xfrm>
+            <a:off x="914400" y="2606039"/>
+            <a:ext cx="3200400" cy="274320"/>
+          </a:xfrm>
+          <a:prstGeom prst="rect">
+            <a:avLst/>
+          </a:prstGeom>
+          <a:noFill/>
+        </p:spPr>
+        <p:txBody>
+          <a:bodyPr wrap="square" lIns="0" rIns="0" tIns="0" bIns="0" anchor="t">
+            <a:noAutofit/>
+          </a:bodyPr>
+          <a:lstStyle/>
+          <a:p>
             <a:pPr algn="l"/>
             <a:r>
-              <a:rPr sz="4000" b="1" i="0">
-                <a:solidFill>
-                  <a:srgbClr val="2E6F9E"/>
-                </a:solidFill>
-                <a:latin typeface="Georgia"/>
+              <a:rPr sz="1200" b="1" i="0" spc="140">
+                <a:solidFill>
+                  <a:srgbClr val="00526F"/>
+                </a:solidFill>
+                <a:latin typeface="Frutiger"/>
               </a:rPr>
-              <a:t>1</a:t>
-            </a:r>
-          </a:p>
-        </p:txBody>
-      </p:sp>
-      <p:sp>
-        <p:nvSpPr>
-          <p:cNvPr id="4" name="TextBox 3"/>
+              <a:t>PERCEPTION</a:t>
+            </a:r>
+          </a:p>
+        </p:txBody>
+      </p:sp>
+      <p:sp>
+        <p:nvSpPr>
+          <p:cNvPr id="6" name="TextBox 5"/>
           <p:cNvSpPr txBox="1"/>
           <p:nvPr/>
         </p:nvSpPr>
         <p:spPr>
           <a:xfrm>
-            <a:off x="1508760" y="1783080"/>
-            <a:ext cx="9875520" cy="1005840"/>
+            <a:off x="914400" y="3063239"/>
+            <a:ext cx="3108960" cy="822960"/>
           </a:xfrm>
           <a:prstGeom prst="rect">
             <a:avLst/>
@@ -7189,20 +6985,410 @@
               <a:lnSpc>
                 <a:spcPct val="105000"/>
               </a:lnSpc>
-              <a:spcAft>
-                <a:spcPts val="300"/>
-              </a:spcAft>
             </a:pPr>
             <a:r>
-              <a:rPr sz="2200" b="1" i="0">
-                <a:solidFill>
-                  <a:srgbClr val="0B2545"/>
-                </a:solidFill>
-                <a:latin typeface="Helvetica Neue"/>
+              <a:rPr sz="2200" b="0" i="0">
+                <a:solidFill>
+                  <a:srgbClr val="111A20"/>
+                </a:solidFill>
+                <a:latin typeface="Athelas"/>
               </a:rPr>
-              <a:t>It misses droughts.</a:t>
-            </a:r>
-          </a:p>
+              <a:t>Do people feel what it intends?</a:t>
+            </a:r>
+          </a:p>
+        </p:txBody>
+      </p:sp>
+      <p:sp>
+        <p:nvSpPr>
+          <p:cNvPr id="7" name="TextBox 6"/>
+          <p:cNvSpPr txBox="1"/>
+          <p:nvPr/>
+        </p:nvSpPr>
+        <p:spPr>
+          <a:xfrm>
+            <a:off x="914400" y="3931920"/>
+            <a:ext cx="3108960" cy="1371600"/>
+          </a:xfrm>
+          <a:prstGeom prst="rect">
+            <a:avLst/>
+          </a:prstGeom>
+          <a:noFill/>
+        </p:spPr>
+        <p:txBody>
+          <a:bodyPr wrap="square" lIns="0" rIns="0" tIns="0" bIns="0" anchor="t">
+            <a:noAutofit/>
+          </a:bodyPr>
+          <a:lstStyle/>
+          <a:p>
+            <a:pPr algn="l">
+              <a:lnSpc>
+                <a:spcPct val="112000"/>
+              </a:lnSpc>
+            </a:pPr>
+            <a:r>
+              <a:rPr sz="1400" b="0" i="0">
+                <a:solidFill>
+                  <a:srgbClr val="5F6F78"/>
+                </a:solidFill>
+                <a:latin typeface="Frutiger"/>
+              </a:rPr>
+              <a:t>The step from anomaly score to emotion is designed by hand. Nobody has tested whether viewers feel it.</a:t>
+            </a:r>
+          </a:p>
+        </p:txBody>
+      </p:sp>
+      <p:cxnSp>
+        <p:nvCxnSpPr>
+          <p:cNvPr id="8" name="Connector 7"/>
+          <p:cNvCxnSpPr/>
+          <p:nvPr/>
+        </p:nvCxnSpPr>
+        <p:spPr>
+          <a:xfrm>
+            <a:off x="4494276" y="2331720"/>
+            <a:ext cx="3200399" cy="0"/>
+          </a:xfrm>
+          <a:prstGeom prst="line">
+            <a:avLst/>
+          </a:prstGeom>
+          <a:ln w="38100">
+            <a:solidFill>
+              <a:srgbClr val="00526F"/>
+            </a:solidFill>
+          </a:ln>
+        </p:spPr>
+        <p:style>
+          <a:lnRef idx="2">
+            <a:schemeClr val="accent1"/>
+          </a:lnRef>
+          <a:fillRef idx="0">
+            <a:schemeClr val="accent1"/>
+          </a:fillRef>
+          <a:effectRef idx="1">
+            <a:schemeClr val="accent1"/>
+          </a:effectRef>
+          <a:fontRef idx="minor">
+            <a:schemeClr val="tx1"/>
+          </a:fontRef>
+        </p:style>
+      </p:cxnSp>
+      <p:sp>
+        <p:nvSpPr>
+          <p:cNvPr id="9" name="TextBox 8"/>
+          <p:cNvSpPr txBox="1"/>
+          <p:nvPr/>
+        </p:nvSpPr>
+        <p:spPr>
+          <a:xfrm>
+            <a:off x="4494276" y="2606039"/>
+            <a:ext cx="3200400" cy="274320"/>
+          </a:xfrm>
+          <a:prstGeom prst="rect">
+            <a:avLst/>
+          </a:prstGeom>
+          <a:noFill/>
+        </p:spPr>
+        <p:txBody>
+          <a:bodyPr wrap="square" lIns="0" rIns="0" tIns="0" bIns="0" anchor="t">
+            <a:noAutofit/>
+          </a:bodyPr>
+          <a:lstStyle/>
+          <a:p>
+            <a:pPr algn="l"/>
+            <a:r>
+              <a:rPr sz="1200" b="1" i="0" spc="140">
+                <a:solidFill>
+                  <a:srgbClr val="00526F"/>
+                </a:solidFill>
+                <a:latin typeface="Frutiger"/>
+              </a:rPr>
+              <a:t>UNDERSTANDING AND TRUST</a:t>
+            </a:r>
+          </a:p>
+        </p:txBody>
+      </p:sp>
+      <p:sp>
+        <p:nvSpPr>
+          <p:cNvPr id="10" name="TextBox 9"/>
+          <p:cNvSpPr txBox="1"/>
+          <p:nvPr/>
+        </p:nvSpPr>
+        <p:spPr>
+          <a:xfrm>
+            <a:off x="4494276" y="3063239"/>
+            <a:ext cx="3108960" cy="822960"/>
+          </a:xfrm>
+          <a:prstGeom prst="rect">
+            <a:avLst/>
+          </a:prstGeom>
+          <a:noFill/>
+        </p:spPr>
+        <p:txBody>
+          <a:bodyPr wrap="square" lIns="0" rIns="0" tIns="0" bIns="0" anchor="t">
+            <a:noAutofit/>
+          </a:bodyPr>
+          <a:lstStyle/>
+          <a:p>
+            <a:pPr algn="l">
+              <a:lnSpc>
+                <a:spcPct val="105000"/>
+              </a:lnSpc>
+            </a:pPr>
+            <a:r>
+              <a:rPr sz="2200" b="0" i="0">
+                <a:solidFill>
+                  <a:srgbClr val="111A20"/>
+                </a:solidFill>
+                <a:latin typeface="Athelas"/>
+              </a:rPr>
+              <a:t>Do they know what a flag means?</a:t>
+            </a:r>
+          </a:p>
+        </p:txBody>
+      </p:sp>
+      <p:sp>
+        <p:nvSpPr>
+          <p:cNvPr id="11" name="TextBox 10"/>
+          <p:cNvSpPr txBox="1"/>
+          <p:nvPr/>
+        </p:nvSpPr>
+        <p:spPr>
+          <a:xfrm>
+            <a:off x="4494276" y="3931920"/>
+            <a:ext cx="3108960" cy="1371600"/>
+          </a:xfrm>
+          <a:prstGeom prst="rect">
+            <a:avLst/>
+          </a:prstGeom>
+          <a:noFill/>
+        </p:spPr>
+        <p:txBody>
+          <a:bodyPr wrap="square" lIns="0" rIns="0" tIns="0" bIns="0" anchor="t">
+            <a:noAutofit/>
+          </a:bodyPr>
+          <a:lstStyle/>
+          <a:p>
+            <a:pPr algn="l">
+              <a:lnSpc>
+                <a:spcPct val="112000"/>
+              </a:lnSpc>
+            </a:pPr>
+            <a:r>
+              <a:rPr sz="1400" b="0" i="0">
+                <a:solidFill>
+                  <a:srgbClr val="5F6F78"/>
+                </a:solidFill>
+                <a:latin typeface="Frutiger"/>
+              </a:rPr>
+              <a:t>A flag is not the whole picture: a drought looks like an ordinary dry year to the model. Do people know what a missing flag does not tell them?</a:t>
+            </a:r>
+          </a:p>
+        </p:txBody>
+      </p:sp>
+      <p:cxnSp>
+        <p:nvCxnSpPr>
+          <p:cNvPr id="12" name="Connector 11"/>
+          <p:cNvCxnSpPr/>
+          <p:nvPr/>
+        </p:nvCxnSpPr>
+        <p:spPr>
+          <a:xfrm>
+            <a:off x="8074152" y="2331720"/>
+            <a:ext cx="3200400" cy="0"/>
+          </a:xfrm>
+          <a:prstGeom prst="line">
+            <a:avLst/>
+          </a:prstGeom>
+          <a:ln w="38100">
+            <a:solidFill>
+              <a:srgbClr val="00526F"/>
+            </a:solidFill>
+          </a:ln>
+        </p:spPr>
+        <p:style>
+          <a:lnRef idx="2">
+            <a:schemeClr val="accent1"/>
+          </a:lnRef>
+          <a:fillRef idx="0">
+            <a:schemeClr val="accent1"/>
+          </a:fillRef>
+          <a:effectRef idx="1">
+            <a:schemeClr val="accent1"/>
+          </a:effectRef>
+          <a:fontRef idx="minor">
+            <a:schemeClr val="tx1"/>
+          </a:fontRef>
+        </p:style>
+      </p:cxnSp>
+      <p:sp>
+        <p:nvSpPr>
+          <p:cNvPr id="13" name="TextBox 12"/>
+          <p:cNvSpPr txBox="1"/>
+          <p:nvPr/>
+        </p:nvSpPr>
+        <p:spPr>
+          <a:xfrm>
+            <a:off x="8074152" y="2606039"/>
+            <a:ext cx="3200400" cy="274320"/>
+          </a:xfrm>
+          <a:prstGeom prst="rect">
+            <a:avLst/>
+          </a:prstGeom>
+          <a:noFill/>
+        </p:spPr>
+        <p:txBody>
+          <a:bodyPr wrap="square" lIns="0" rIns="0" tIns="0" bIns="0" anchor="t">
+            <a:noAutofit/>
+          </a:bodyPr>
+          <a:lstStyle/>
+          <a:p>
+            <a:pPr algn="l"/>
+            <a:r>
+              <a:rPr sz="1200" b="1" i="0" spc="140">
+                <a:solidFill>
+                  <a:srgbClr val="00526F"/>
+                </a:solidFill>
+                <a:latin typeface="Frutiger"/>
+              </a:rPr>
+              <a:t>DECISION</a:t>
+            </a:r>
+          </a:p>
+        </p:txBody>
+      </p:sp>
+      <p:sp>
+        <p:nvSpPr>
+          <p:cNvPr id="14" name="TextBox 13"/>
+          <p:cNvSpPr txBox="1"/>
+          <p:nvPr/>
+        </p:nvSpPr>
+        <p:spPr>
+          <a:xfrm>
+            <a:off x="8074152" y="3063239"/>
+            <a:ext cx="3108960" cy="822960"/>
+          </a:xfrm>
+          <a:prstGeom prst="rect">
+            <a:avLst/>
+          </a:prstGeom>
+          <a:noFill/>
+        </p:spPr>
+        <p:txBody>
+          <a:bodyPr wrap="square" lIns="0" rIns="0" tIns="0" bIns="0" anchor="t">
+            <a:noAutofit/>
+          </a:bodyPr>
+          <a:lstStyle/>
+          <a:p>
+            <a:pPr algn="l">
+              <a:lnSpc>
+                <a:spcPct val="105000"/>
+              </a:lnSpc>
+            </a:pPr>
+            <a:r>
+              <a:rPr sz="2200" b="0" i="0">
+                <a:solidFill>
+                  <a:srgbClr val="111A20"/>
+                </a:solidFill>
+                <a:latin typeface="Athelas"/>
+              </a:rPr>
+              <a:t>Does it help them decide?</a:t>
+            </a:r>
+          </a:p>
+        </p:txBody>
+      </p:sp>
+      <p:sp>
+        <p:nvSpPr>
+          <p:cNvPr id="15" name="TextBox 14"/>
+          <p:cNvSpPr txBox="1"/>
+          <p:nvPr/>
+        </p:nvSpPr>
+        <p:spPr>
+          <a:xfrm>
+            <a:off x="8074152" y="3931920"/>
+            <a:ext cx="3108960" cy="1371600"/>
+          </a:xfrm>
+          <a:prstGeom prst="rect">
+            <a:avLst/>
+          </a:prstGeom>
+          <a:noFill/>
+        </p:spPr>
+        <p:txBody>
+          <a:bodyPr wrap="square" lIns="0" rIns="0" tIns="0" bIns="0" anchor="t">
+            <a:noAutofit/>
+          </a:bodyPr>
+          <a:lstStyle/>
+          <a:p>
+            <a:pPr algn="l">
+              <a:lnSpc>
+                <a:spcPct val="112000"/>
+              </a:lnSpc>
+            </a:pPr>
+            <a:r>
+              <a:rPr sz="1400" b="0" i="0">
+                <a:solidFill>
+                  <a:srgbClr val="5F6F78"/>
+                </a:solidFill>
+                <a:latin typeface="Frutiger"/>
+              </a:rPr>
+              <a:t>Does an XR and sound experience change how decision-makers understand a river, compared with a standard chart?</a:t>
+            </a:r>
+          </a:p>
+        </p:txBody>
+      </p:sp>
+      <p:cxnSp>
+        <p:nvCxnSpPr>
+          <p:cNvPr id="16" name="Connector 15"/>
+          <p:cNvCxnSpPr/>
+          <p:nvPr/>
+        </p:nvCxnSpPr>
+        <p:spPr>
+          <a:xfrm>
+            <a:off x="914400" y="5230368"/>
+            <a:ext cx="10362895" cy="0"/>
+          </a:xfrm>
+          <a:prstGeom prst="line">
+            <a:avLst/>
+          </a:prstGeom>
+          <a:ln w="15875">
+            <a:solidFill>
+              <a:srgbClr val="D3DDE2"/>
+            </a:solidFill>
+          </a:ln>
+        </p:spPr>
+        <p:style>
+          <a:lnRef idx="2">
+            <a:schemeClr val="accent1"/>
+          </a:lnRef>
+          <a:fillRef idx="0">
+            <a:schemeClr val="accent1"/>
+          </a:fillRef>
+          <a:effectRef idx="1">
+            <a:schemeClr val="accent1"/>
+          </a:effectRef>
+          <a:fontRef idx="minor">
+            <a:schemeClr val="tx1"/>
+          </a:fontRef>
+        </p:style>
+      </p:cxnSp>
+      <p:sp>
+        <p:nvSpPr>
+          <p:cNvPr id="17" name="TextBox 16"/>
+          <p:cNvSpPr txBox="1"/>
+          <p:nvPr/>
+        </p:nvSpPr>
+        <p:spPr>
+          <a:xfrm>
+            <a:off x="914400" y="5376672"/>
+            <a:ext cx="10362895" cy="731520"/>
+          </a:xfrm>
+          <a:prstGeom prst="rect">
+            <a:avLst/>
+          </a:prstGeom>
+          <a:noFill/>
+        </p:spPr>
+        <p:txBody>
+          <a:bodyPr wrap="square" lIns="0" rIns="0" tIns="0" bIns="0" anchor="t">
+            <a:noAutofit/>
+          </a:bodyPr>
+          <a:lstStyle/>
           <a:p>
             <a:pPr algn="l">
               <a:lnSpc>
@@ -7210,27 +7396,36 @@
               </a:lnSpc>
             </a:pPr>
             <a:r>
-              <a:rPr sz="1700" b="0" i="0">
-                <a:solidFill>
-                  <a:srgbClr val="5C6F7B"/>
-                </a:solidFill>
-                <a:latin typeface="Helvetica Neue"/>
+              <a:rPr sz="1400" b="1" i="0" spc="100">
+                <a:solidFill>
+                  <a:srgbClr val="00526F"/>
+                </a:solidFill>
+                <a:latin typeface="Frutiger"/>
               </a:rPr>
-              <a:t>The model flags unusual combinations of features, not extremes along the wet–dry axis.</a:t>
-            </a:r>
-          </a:p>
-        </p:txBody>
-      </p:sp>
-      <p:sp>
-        <p:nvSpPr>
-          <p:cNvPr id="5" name="TextBox 4"/>
+              <a:t>Next  </a:t>
+            </a:r>
+            <a:r>
+              <a:rPr sz="1800" b="0" i="0">
+                <a:solidFill>
+                  <a:srgbClr val="111A20"/>
+                </a:solidFill>
+                <a:latin typeface="Athelas"/>
+              </a:rPr>
+              <a:t>learn the mapping from human responses, and test it with the people who make water decisions.</a:t>
+            </a:r>
+          </a:p>
+        </p:txBody>
+      </p:sp>
+      <p:sp>
+        <p:nvSpPr>
+          <p:cNvPr id="18" name="TextBox 17"/>
           <p:cNvSpPr txBox="1"/>
           <p:nvPr/>
         </p:nvSpPr>
         <p:spPr>
           <a:xfrm>
-            <a:off x="731520" y="2834639"/>
-            <a:ext cx="731520" cy="731520"/>
+            <a:off x="7162495" y="6309360"/>
+            <a:ext cx="3383280" cy="274320"/>
           </a:xfrm>
           <a:prstGeom prst="rect">
             <a:avLst/>
@@ -7243,29 +7438,53 @@
           </a:bodyPr>
           <a:lstStyle/>
           <a:p>
-            <a:pPr algn="l"/>
-            <a:r>
-              <a:rPr sz="4000" b="1" i="0">
-                <a:solidFill>
-                  <a:srgbClr val="2E6F9E"/>
-                </a:solidFill>
-                <a:latin typeface="Georgia"/>
+            <a:pPr algn="r"/>
+            <a:r>
+              <a:rPr sz="1100" b="1" i="0">
+                <a:solidFill>
+                  <a:srgbClr val="00526F"/>
+                </a:solidFill>
+                <a:latin typeface="Frutiger"/>
               </a:rPr>
-              <a:t>2</a:t>
-            </a:r>
-          </a:p>
-        </p:txBody>
-      </p:sp>
-      <p:sp>
-        <p:nvSpPr>
-          <p:cNvPr id="6" name="TextBox 5"/>
+              <a:t>github.com/qintheory/noea</a:t>
+            </a:r>
+          </a:p>
+        </p:txBody>
+      </p:sp>
+      <p:pic>
+        <p:nvPicPr>
+          <p:cNvPr id="19" name="Picture 18" descr="logo.png"/>
+          <p:cNvPicPr>
+            <a:picLocks noChangeAspect="1"/>
+          </p:cNvPicPr>
+          <p:nvPr/>
+        </p:nvPicPr>
+        <p:blipFill>
+          <a:blip r:embed="rId3"/>
+          <a:stretch>
+            <a:fillRect/>
+          </a:stretch>
+        </p:blipFill>
+        <p:spPr>
+          <a:xfrm>
+            <a:off x="914400" y="6236208"/>
+            <a:ext cx="2120348" cy="292608"/>
+          </a:xfrm>
+          <a:prstGeom prst="rect">
+            <a:avLst/>
+          </a:prstGeom>
+        </p:spPr>
+      </p:pic>
+      <p:sp>
+        <p:nvSpPr>
+          <p:cNvPr id="20" name="TextBox 19"/>
           <p:cNvSpPr txBox="1"/>
           <p:nvPr/>
         </p:nvSpPr>
         <p:spPr>
           <a:xfrm>
-            <a:off x="1508760" y="2880359"/>
-            <a:ext cx="9875520" cy="1005840"/>
+            <a:off x="10637215" y="6309360"/>
+            <a:ext cx="640080" cy="274320"/>
           </a:xfrm>
           <a:prstGeom prst="rect">
             <a:avLst/>
@@ -7278,277 +7497,13 @@
           </a:bodyPr>
           <a:lstStyle/>
           <a:p>
-            <a:pPr algn="l">
-              <a:lnSpc>
-                <a:spcPct val="105000"/>
-              </a:lnSpc>
-              <a:spcAft>
-                <a:spcPts val="300"/>
-              </a:spcAft>
-            </a:pPr>
-            <a:r>
-              <a:rPr sz="2200" b="1" i="0">
-                <a:solidFill>
-                  <a:srgbClr val="0B2545"/>
-                </a:solidFill>
-                <a:latin typeface="Helvetica Neue"/>
-              </a:rPr>
-              <a:t>The step from anomaly to emotion is designed by hand.</a:t>
-            </a:r>
-          </a:p>
-          <a:p>
-            <a:pPr algn="l">
-              <a:lnSpc>
-                <a:spcPct val="110000"/>
-              </a:lnSpc>
-            </a:pPr>
-            <a:r>
-              <a:rPr sz="1700" b="0" i="0">
-                <a:solidFill>
-                  <a:srgbClr val="5C6F7B"/>
-                </a:solidFill>
-                <a:latin typeface="Helvetica Neue"/>
-              </a:rPr>
-              <a:t>It is not yet learned from people.</a:t>
-            </a:r>
-          </a:p>
-        </p:txBody>
-      </p:sp>
-      <p:sp>
-        <p:nvSpPr>
-          <p:cNvPr id="7" name="TextBox 6"/>
-          <p:cNvSpPr txBox="1"/>
-          <p:nvPr/>
-        </p:nvSpPr>
-        <p:spPr>
-          <a:xfrm>
-            <a:off x="731520" y="3931920"/>
-            <a:ext cx="731520" cy="731520"/>
-          </a:xfrm>
-          <a:prstGeom prst="rect">
-            <a:avLst/>
-          </a:prstGeom>
-          <a:noFill/>
-        </p:spPr>
-        <p:txBody>
-          <a:bodyPr wrap="square" lIns="0" rIns="0" tIns="0" bIns="0" anchor="t">
-            <a:noAutofit/>
-          </a:bodyPr>
-          <a:lstStyle/>
-          <a:p>
-            <a:pPr algn="l"/>
-            <a:r>
-              <a:rPr sz="4000" b="1" i="0">
-                <a:solidFill>
-                  <a:srgbClr val="2E6F9E"/>
-                </a:solidFill>
-                <a:latin typeface="Georgia"/>
-              </a:rPr>
-              <a:t>3</a:t>
-            </a:r>
-          </a:p>
-        </p:txBody>
-      </p:sp>
-      <p:sp>
-        <p:nvSpPr>
-          <p:cNvPr id="8" name="TextBox 7"/>
-          <p:cNvSpPr txBox="1"/>
-          <p:nvPr/>
-        </p:nvSpPr>
-        <p:spPr>
-          <a:xfrm>
-            <a:off x="1508760" y="3977639"/>
-            <a:ext cx="9875520" cy="1005840"/>
-          </a:xfrm>
-          <a:prstGeom prst="rect">
-            <a:avLst/>
-          </a:prstGeom>
-          <a:noFill/>
-        </p:spPr>
-        <p:txBody>
-          <a:bodyPr wrap="square" lIns="0" rIns="0" tIns="0" bIns="0" anchor="t">
-            <a:noAutofit/>
-          </a:bodyPr>
-          <a:lstStyle/>
-          <a:p>
-            <a:pPr algn="l">
-              <a:lnSpc>
-                <a:spcPct val="105000"/>
-              </a:lnSpc>
-              <a:spcAft>
-                <a:spcPts val="300"/>
-              </a:spcAft>
-            </a:pPr>
-            <a:r>
-              <a:rPr sz="2200" b="1" i="0">
-                <a:solidFill>
-                  <a:srgbClr val="0B2545"/>
-                </a:solidFill>
-                <a:latin typeface="Helvetica Neue"/>
-              </a:rPr>
-              <a:t>Nobody has tested whether viewers feel what it intends.</a:t>
-            </a:r>
-          </a:p>
-        </p:txBody>
-      </p:sp>
-      <p:sp>
-        <p:nvSpPr>
-          <p:cNvPr id="9" name="Rounded Rectangle 8"/>
-          <p:cNvSpPr/>
-          <p:nvPr/>
-        </p:nvSpPr>
-        <p:spPr>
-          <a:xfrm>
-            <a:off x="731520" y="5166360"/>
-            <a:ext cx="10744200" cy="960120"/>
-          </a:xfrm>
-          <a:prstGeom prst="roundRect">
-            <a:avLst>
-              <a:gd name="adj" fmla="val 5000"/>
-            </a:avLst>
-          </a:prstGeom>
-          <a:solidFill>
-            <a:srgbClr val="0B2545"/>
-          </a:solidFill>
-          <a:ln>
-            <a:noFill/>
-          </a:ln>
-          <a:effectLst/>
-        </p:spPr>
-        <p:style>
-          <a:lnRef idx="1">
-            <a:schemeClr val="accent1"/>
-          </a:lnRef>
-          <a:fillRef idx="3">
-            <a:schemeClr val="accent1"/>
-          </a:fillRef>
-          <a:effectRef idx="2">
-            <a:schemeClr val="accent1"/>
-          </a:effectRef>
-          <a:fontRef idx="minor">
-            <a:schemeClr val="lt1"/>
-          </a:fontRef>
-        </p:style>
-        <p:txBody>
-          <a:bodyPr rtlCol="0" anchor="ctr"/>
-          <a:lstStyle/>
-          <a:p>
-            <a:pPr algn="ctr"/>
-          </a:p>
-        </p:txBody>
-      </p:sp>
-      <p:sp>
-        <p:nvSpPr>
-          <p:cNvPr id="10" name="TextBox 9"/>
-          <p:cNvSpPr txBox="1"/>
-          <p:nvPr/>
-        </p:nvSpPr>
-        <p:spPr>
-          <a:xfrm>
-            <a:off x="1097280" y="5166360"/>
-            <a:ext cx="10058400" cy="960120"/>
-          </a:xfrm>
-          <a:prstGeom prst="rect">
-            <a:avLst/>
-          </a:prstGeom>
-          <a:noFill/>
-        </p:spPr>
-        <p:txBody>
-          <a:bodyPr wrap="square" lIns="0" rIns="0" tIns="0" bIns="0" anchor="ctr">
-            <a:noAutofit/>
-          </a:bodyPr>
-          <a:lstStyle/>
-          <a:p>
-            <a:pPr algn="l">
-              <a:lnSpc>
-                <a:spcPct val="110000"/>
-              </a:lnSpc>
-            </a:pPr>
-            <a:r>
-              <a:rPr sz="2000" b="1" i="0">
-                <a:solidFill>
-                  <a:srgbClr val="C9D8E3"/>
-                </a:solidFill>
-                <a:latin typeface="Helvetica Neue"/>
-              </a:rPr>
-              <a:t>Next: </a:t>
-            </a:r>
-            <a:r>
-              <a:rPr sz="2000" b="0" i="0">
-                <a:solidFill>
-                  <a:srgbClr val="FFFFFF"/>
-                </a:solidFill>
-                <a:latin typeface="Helvetica Neue"/>
-              </a:rPr>
-              <a:t>learn the mapping from human responses, and test it with the people who make water decisions.</a:t>
-            </a:r>
-          </a:p>
-        </p:txBody>
-      </p:sp>
-      <p:sp>
-        <p:nvSpPr>
-          <p:cNvPr id="11" name="TextBox 10"/>
-          <p:cNvSpPr txBox="1"/>
-          <p:nvPr/>
-        </p:nvSpPr>
-        <p:spPr>
-          <a:xfrm>
-            <a:off x="731520" y="6355080"/>
-            <a:ext cx="7315200" cy="274320"/>
-          </a:xfrm>
-          <a:prstGeom prst="rect">
-            <a:avLst/>
-          </a:prstGeom>
-          <a:noFill/>
-        </p:spPr>
-        <p:txBody>
-          <a:bodyPr wrap="square" lIns="0" rIns="0" tIns="0" bIns="0" anchor="t">
-            <a:noAutofit/>
-          </a:bodyPr>
-          <a:lstStyle/>
-          <a:p>
-            <a:pPr algn="l"/>
-            <a:r>
-              <a:rPr sz="1200" b="1" i="0">
-                <a:solidFill>
-                  <a:srgbClr val="2E6F9E"/>
-                </a:solidFill>
-                <a:latin typeface="Helvetica Neue"/>
-              </a:rPr>
-              <a:t>github.com/qintheory/noea</a:t>
-            </a:r>
-          </a:p>
-        </p:txBody>
-      </p:sp>
-      <p:sp>
-        <p:nvSpPr>
-          <p:cNvPr id="12" name="TextBox 11"/>
-          <p:cNvSpPr txBox="1"/>
-          <p:nvPr/>
-        </p:nvSpPr>
-        <p:spPr>
-          <a:xfrm>
-            <a:off x="10881360" y="6419088"/>
-            <a:ext cx="594360" cy="274320"/>
-          </a:xfrm>
-          <a:prstGeom prst="rect">
-            <a:avLst/>
-          </a:prstGeom>
-          <a:noFill/>
-        </p:spPr>
-        <p:txBody>
-          <a:bodyPr wrap="square" lIns="0" rIns="0" tIns="0" bIns="0" anchor="t">
-            <a:noAutofit/>
-          </a:bodyPr>
-          <a:lstStyle/>
-          <a:p>
             <a:pPr algn="r"/>
             <a:r>
               <a:rPr sz="1100" b="0" i="0">
                 <a:solidFill>
-                  <a:srgbClr val="5C6F7B"/>
-                </a:solidFill>
-                <a:latin typeface="Helvetica Neue"/>
+                  <a:srgbClr val="5F6F78"/>
+                </a:solidFill>
+                <a:latin typeface="Frutiger"/>
               </a:rPr>
               <a:t>7</a:t>
             </a:r>

</xml_diff>

<commit_message>
Deck: lighter type, one-line subtitles, and the Hong Kong Heartbeat ECG on the cover
All type scaled down 16% for more white space; the three subtitles that wrapped (slides 5-7) are shortened and each is checked against the measured Frutiger width so it stays on one line.

The cover now draws the Hong Kong ECG in the published hkheartbeat style (the same Gaussian R-peaks, RR spacing and sinusoidal baseline as ecg-ui.js, from its own CSV), in three rows. Like the published code it draws no S dips, since that code reads a column the CSV doesn't have. An animated variant wipes the three rows in one after another; a GIF of the same drawing is included for video use. The GIF initially came out corrupt because every frame had its own palette; it now shares one.

Co-Authored-By: Claude Sonnet 5.5 <noreply@anthropic.com>
</commit_message>
<xml_diff>
--- a/docs/noea-introduction.pptx
+++ b/docs/noea-introduction.pptx
@@ -508,7 +508,7 @@
           <a:lstStyle/>
           <a:p>
             <a:r>
-              <a:t>Noéa translates long hydrological records into something people can experience. The pulse below is real data: Hong Kong's annual peak daily rainfall, 1884 to 2025.</a:t>
+              <a:t>Noéa translates long hydrological records into something people can experience. The ECG below is real data: Hong Kong's annual peak daily rainfall, 1884 to 2025, one beat per year.</a:t>
             </a:r>
           </a:p>
         </p:txBody>
@@ -3950,8 +3950,8 @@
         </p:nvSpPr>
         <p:spPr>
           <a:xfrm>
-            <a:off x="914400" y="594360"/>
-            <a:ext cx="8229600" cy="1828800"/>
+            <a:off x="914400" y="548640"/>
+            <a:ext cx="8229600" cy="1737360"/>
           </a:xfrm>
           <a:prstGeom prst="rect">
             <a:avLst/>
@@ -3966,7 +3966,7 @@
           <a:p>
             <a:pPr algn="l"/>
             <a:r>
-              <a:rPr sz="11200" b="0" i="0">
+              <a:rPr sz="9410" b="0" i="0">
                 <a:solidFill>
                   <a:srgbClr val="111A20"/>
                 </a:solidFill>
@@ -3985,7 +3985,7 @@
         </p:nvSpPr>
         <p:spPr>
           <a:xfrm>
-            <a:off x="914400" y="2377440"/>
+            <a:off x="914400" y="2194560"/>
             <a:ext cx="10362895" cy="640080"/>
           </a:xfrm>
           <a:prstGeom prst="rect">
@@ -4001,7 +4001,7 @@
           <a:p>
             <a:pPr algn="l"/>
             <a:r>
-              <a:rPr sz="3000" b="0" i="1">
+              <a:rPr sz="2520" b="0" i="1">
                 <a:solidFill>
                   <a:srgbClr val="00526F"/>
                 </a:solidFill>
@@ -4020,7 +4020,7 @@
         </p:nvSpPr>
         <p:spPr>
           <a:xfrm>
-            <a:off x="914400" y="3017520"/>
+            <a:off x="914400" y="2788920"/>
             <a:ext cx="10362895" cy="365760"/>
           </a:xfrm>
           <a:prstGeom prst="rect">
@@ -4036,7 +4036,7 @@
           <a:p>
             <a:pPr algn="l"/>
             <a:r>
-              <a:rPr sz="1600" b="0" i="0">
+              <a:rPr sz="1340" b="0" i="0">
                 <a:solidFill>
                   <a:srgbClr val="5F6F78"/>
                 </a:solidFill>
@@ -4049,7 +4049,7 @@
       </p:sp>
       <p:pic>
         <p:nvPicPr>
-          <p:cNvPr id="5" name="Picture 4" descr="cover_pulse2.png"/>
+          <p:cNvPr id="5" name="Picture 4" descr="ecg_row1.png"/>
           <p:cNvPicPr>
             <a:picLocks noChangeAspect="1"/>
           </p:cNvPicPr>
@@ -4063,24 +4063,72 @@
         </p:blipFill>
         <p:spPr>
           <a:xfrm>
-            <a:off x="914400" y="3520440"/>
-            <a:ext cx="10362895" cy="2012697"/>
+            <a:off x="914400" y="3383280"/>
+            <a:ext cx="10362895" cy="922808"/>
           </a:xfrm>
           <a:prstGeom prst="rect">
             <a:avLst/>
           </a:prstGeom>
         </p:spPr>
       </p:pic>
-      <p:sp>
-        <p:nvSpPr>
-          <p:cNvPr id="6" name="TextBox 5"/>
+      <p:pic>
+        <p:nvPicPr>
+          <p:cNvPr id="6" name="Picture 5" descr="ecg_row2.png"/>
+          <p:cNvPicPr>
+            <a:picLocks noChangeAspect="1"/>
+          </p:cNvPicPr>
+          <p:nvPr/>
+        </p:nvPicPr>
+        <p:blipFill>
+          <a:blip r:embed="rId4"/>
+          <a:stretch>
+            <a:fillRect/>
+          </a:stretch>
+        </p:blipFill>
+        <p:spPr>
+          <a:xfrm>
+            <a:off x="914400" y="4121527"/>
+            <a:ext cx="10362895" cy="922808"/>
+          </a:xfrm>
+          <a:prstGeom prst="rect">
+            <a:avLst/>
+          </a:prstGeom>
+        </p:spPr>
+      </p:pic>
+      <p:pic>
+        <p:nvPicPr>
+          <p:cNvPr id="7" name="Picture 6" descr="ecg_row3.png"/>
+          <p:cNvPicPr>
+            <a:picLocks noChangeAspect="1"/>
+          </p:cNvPicPr>
+          <p:nvPr/>
+        </p:nvPicPr>
+        <p:blipFill>
+          <a:blip r:embed="rId5"/>
+          <a:stretch>
+            <a:fillRect/>
+          </a:stretch>
+        </p:blipFill>
+        <p:spPr>
+          <a:xfrm>
+            <a:off x="914400" y="4859774"/>
+            <a:ext cx="10362895" cy="922808"/>
+          </a:xfrm>
+          <a:prstGeom prst="rect">
+            <a:avLst/>
+          </a:prstGeom>
+        </p:spPr>
+      </p:pic>
+      <p:sp>
+        <p:nvSpPr>
+          <p:cNvPr id="8" name="TextBox 7"/>
           <p:cNvSpPr txBox="1"/>
           <p:nvPr/>
         </p:nvSpPr>
         <p:spPr>
           <a:xfrm>
-            <a:off x="914400" y="5577840"/>
-            <a:ext cx="10362895" cy="365760"/>
+            <a:off x="914400" y="5897880"/>
+            <a:ext cx="10362895" cy="274320"/>
           </a:xfrm>
           <a:prstGeom prst="rect">
             <a:avLst/>
@@ -4095,27 +4143,27 @@
           <a:p>
             <a:pPr algn="l"/>
             <a:r>
-              <a:rPr sz="1100" b="0" i="0">
+              <a:rPr sz="1000" b="0" i="0">
                 <a:solidFill>
                   <a:srgbClr val="5F6F78"/>
                 </a:solidFill>
                 <a:latin typeface="Frutiger"/>
               </a:rPr>
-              <a:t>Annual peak daily rainfall, Hong Kong, 1884–2025, drawn as a pulse. The flat stretch is 1940–46, missing from the record.</a:t>
+              <a:t>Hong Kong, 1884–2025: one beat per year. Height is the year's peak daily rainfall; spacing is the time since the previous peak.</a:t>
             </a:r>
           </a:p>
         </p:txBody>
       </p:sp>
       <p:pic>
         <p:nvPicPr>
-          <p:cNvPr id="7" name="Picture 6" descr="logo.png"/>
+          <p:cNvPr id="9" name="Picture 8" descr="logo.png"/>
           <p:cNvPicPr>
             <a:picLocks noChangeAspect="1"/>
           </p:cNvPicPr>
           <p:nvPr/>
         </p:nvPicPr>
         <p:blipFill>
-          <a:blip r:embed="rId4"/>
+          <a:blip r:embed="rId6"/>
           <a:stretch>
             <a:fillRect/>
           </a:stretch>
@@ -4184,7 +4232,7 @@
               </a:lnSpc>
             </a:pPr>
             <a:r>
-              <a:rPr sz="4000" b="0" i="0">
+              <a:rPr sz="3360" b="0" i="0">
                 <a:solidFill>
                   <a:srgbClr val="111A20"/>
                 </a:solidFill>
@@ -4254,7 +4302,7 @@
           <a:p>
             <a:pPr algn="l"/>
             <a:r>
-              <a:rPr sz="1200" b="1" i="0" spc="140">
+              <a:rPr sz="1010" b="1" i="0" spc="140">
                 <a:solidFill>
                   <a:srgbClr val="5F6F78"/>
                 </a:solidFill>
@@ -4293,7 +4341,7 @@
               </a:lnSpc>
             </a:pPr>
             <a:r>
-              <a:rPr sz="2400" b="0" i="0">
+              <a:rPr sz="2020" b="0" i="0">
                 <a:solidFill>
                   <a:srgbClr val="111A20"/>
                 </a:solidFill>
@@ -4363,7 +4411,7 @@
           <a:p>
             <a:pPr algn="l"/>
             <a:r>
-              <a:rPr sz="1200" b="1" i="0" spc="140">
+              <a:rPr sz="1010" b="1" i="0" spc="140">
                 <a:solidFill>
                   <a:srgbClr val="00526F"/>
                 </a:solidFill>
@@ -4402,7 +4450,7 @@
               </a:lnSpc>
             </a:pPr>
             <a:r>
-              <a:rPr sz="2400" b="0" i="0">
+              <a:rPr sz="2020" b="0" i="0">
                 <a:solidFill>
                   <a:srgbClr val="111A20"/>
                 </a:solidFill>
@@ -4472,7 +4520,7 @@
           <a:p>
             <a:pPr algn="l"/>
             <a:r>
-              <a:rPr sz="1200" b="1" i="0" spc="140">
+              <a:rPr sz="1010" b="1" i="0" spc="140">
                 <a:solidFill>
                   <a:srgbClr val="5F6F78"/>
                 </a:solidFill>
@@ -4511,7 +4559,7 @@
               </a:lnSpc>
             </a:pPr>
             <a:r>
-              <a:rPr sz="2400" b="0" i="0">
+              <a:rPr sz="2020" b="0" i="0">
                 <a:solidFill>
                   <a:srgbClr val="111A20"/>
                 </a:solidFill>
@@ -4546,7 +4594,7 @@
           <a:p>
             <a:pPr algn="l"/>
             <a:r>
-              <a:rPr sz="1600" b="1" i="0">
+              <a:rPr sz="1340" b="1" i="0">
                 <a:solidFill>
                   <a:srgbClr val="00526F"/>
                 </a:solidFill>
@@ -4605,7 +4653,7 @@
           <a:p>
             <a:pPr algn="r"/>
             <a:r>
-              <a:rPr sz="1100" b="0" i="0">
+              <a:rPr sz="1000" b="0" i="0">
                 <a:solidFill>
                   <a:srgbClr val="5F6F78"/>
                 </a:solidFill>
@@ -4670,7 +4718,7 @@
               </a:lnSpc>
             </a:pPr>
             <a:r>
-              <a:rPr sz="3600" b="0" i="0">
+              <a:rPr sz="3020" b="0" i="0">
                 <a:solidFill>
                   <a:srgbClr val="111A20"/>
                 </a:solidFill>
@@ -4740,7 +4788,7 @@
           <a:p>
             <a:pPr algn="l"/>
             <a:r>
-              <a:rPr sz="1300" b="1" i="0" spc="100">
+              <a:rPr sz="1090" b="1" i="0" spc="100">
                 <a:solidFill>
                   <a:srgbClr val="5390A2"/>
                 </a:solidFill>
@@ -4779,7 +4827,7 @@
               </a:lnSpc>
             </a:pPr>
             <a:r>
-              <a:rPr sz="2300" b="0" i="0">
+              <a:rPr sz="1930" b="0" i="0">
                 <a:solidFill>
                   <a:srgbClr val="111A20"/>
                 </a:solidFill>
@@ -4821,7 +4869,7 @@
               </a:spcAft>
             </a:pPr>
             <a:r>
-              <a:rPr sz="1450" b="0" i="0">
+              <a:rPr sz="1220" b="0" i="0">
                 <a:solidFill>
                   <a:srgbClr val="5F6F78"/>
                 </a:solidFill>
@@ -4891,7 +4939,7 @@
           <a:p>
             <a:pPr algn="l"/>
             <a:r>
-              <a:rPr sz="1300" b="1" i="0" spc="100">
+              <a:rPr sz="1090" b="1" i="0" spc="100">
                 <a:solidFill>
                   <a:srgbClr val="5390A2"/>
                 </a:solidFill>
@@ -4930,7 +4978,7 @@
               </a:lnSpc>
             </a:pPr>
             <a:r>
-              <a:rPr sz="2300" b="0" i="0">
+              <a:rPr sz="1930" b="0" i="0">
                 <a:solidFill>
                   <a:srgbClr val="111A20"/>
                 </a:solidFill>
@@ -4972,7 +5020,7 @@
               </a:spcAft>
             </a:pPr>
             <a:r>
-              <a:rPr sz="1450" b="0" i="0">
+              <a:rPr sz="1220" b="0" i="0">
                 <a:solidFill>
                   <a:srgbClr val="5F6F78"/>
                 </a:solidFill>
@@ -5042,7 +5090,7 @@
           <a:p>
             <a:pPr algn="l"/>
             <a:r>
-              <a:rPr sz="1300" b="1" i="0" spc="100">
+              <a:rPr sz="1090" b="1" i="0" spc="100">
                 <a:solidFill>
                   <a:srgbClr val="00526F"/>
                 </a:solidFill>
@@ -5081,7 +5129,7 @@
               </a:lnSpc>
             </a:pPr>
             <a:r>
-              <a:rPr sz="2300" b="0" i="0">
+              <a:rPr sz="1930" b="0" i="0">
                 <a:solidFill>
                   <a:srgbClr val="111A20"/>
                 </a:solidFill>
@@ -5123,7 +5171,7 @@
               </a:spcAft>
             </a:pPr>
             <a:r>
-              <a:rPr sz="1450" b="0" i="0">
+              <a:rPr sz="1220" b="0" i="0">
                 <a:solidFill>
                   <a:srgbClr val="111A20"/>
                 </a:solidFill>
@@ -5142,7 +5190,7 @@
               </a:spcAft>
             </a:pPr>
             <a:r>
-              <a:rPr sz="1450" b="0" i="0">
+              <a:rPr sz="1220" b="0" i="0">
                 <a:solidFill>
                   <a:srgbClr val="111A20"/>
                 </a:solidFill>
@@ -5161,7 +5209,7 @@
               </a:spcAft>
             </a:pPr>
             <a:r>
-              <a:rPr sz="1450" b="0" i="0">
+              <a:rPr sz="1220" b="0" i="0">
                 <a:solidFill>
                   <a:srgbClr val="111A20"/>
                 </a:solidFill>
@@ -5231,7 +5279,7 @@
           <a:p>
             <a:pPr algn="l"/>
             <a:r>
-              <a:rPr sz="1300" b="1" i="0" spc="100">
+              <a:rPr sz="1090" b="1" i="0" spc="100">
                 <a:solidFill>
                   <a:srgbClr val="5390A2"/>
                 </a:solidFill>
@@ -5270,7 +5318,7 @@
               </a:lnSpc>
             </a:pPr>
             <a:r>
-              <a:rPr sz="2300" b="0" i="0">
+              <a:rPr sz="1930" b="0" i="0">
                 <a:solidFill>
                   <a:srgbClr val="111A20"/>
                 </a:solidFill>
@@ -5312,7 +5360,7 @@
               </a:spcAft>
             </a:pPr>
             <a:r>
-              <a:rPr sz="1450" b="0" i="0">
+              <a:rPr sz="1220" b="0" i="0">
                 <a:solidFill>
                   <a:srgbClr val="5F6F78"/>
                 </a:solidFill>
@@ -5371,7 +5419,7 @@
           <a:p>
             <a:pPr algn="r"/>
             <a:r>
-              <a:rPr sz="1100" b="0" i="0">
+              <a:rPr sz="1000" b="0" i="0">
                 <a:solidFill>
                   <a:srgbClr val="5F6F78"/>
                 </a:solidFill>
@@ -5436,7 +5484,7 @@
               </a:lnSpc>
             </a:pPr>
             <a:r>
-              <a:rPr sz="4000" b="0" i="0">
+              <a:rPr sz="3360" b="0" i="0">
                 <a:solidFill>
                   <a:srgbClr val="111A20"/>
                 </a:solidFill>
@@ -5471,7 +5519,7 @@
           <a:p>
             <a:pPr algn="l"/>
             <a:r>
-              <a:rPr sz="3200" b="0" i="0">
+              <a:rPr sz="2690" b="0" i="0">
                 <a:solidFill>
                   <a:srgbClr val="111A20"/>
                 </a:solidFill>
@@ -5506,7 +5554,7 @@
           <a:p>
             <a:pPr algn="l"/>
             <a:r>
-              <a:rPr sz="1200" b="1" i="0" spc="140">
+              <a:rPr sz="1010" b="1" i="0" spc="140">
                 <a:solidFill>
                   <a:srgbClr val="5F6F78"/>
                 </a:solidFill>
@@ -5548,7 +5596,7 @@
               </a:spcAft>
             </a:pPr>
             <a:r>
-              <a:rPr sz="1650" b="0" i="0">
+              <a:rPr sz="1390" b="0" i="0">
                 <a:solidFill>
                   <a:srgbClr val="111A20"/>
                 </a:solidFill>
@@ -5567,7 +5615,7 @@
               </a:spcAft>
             </a:pPr>
             <a:r>
-              <a:rPr sz="1650" b="0" i="0">
+              <a:rPr sz="1390" b="0" i="0">
                 <a:solidFill>
                   <a:srgbClr val="111A20"/>
                 </a:solidFill>
@@ -5586,7 +5634,7 @@
               </a:spcAft>
             </a:pPr>
             <a:r>
-              <a:rPr sz="1650" b="0" i="0">
+              <a:rPr sz="1390" b="0" i="0">
                 <a:solidFill>
                   <a:srgbClr val="111A20"/>
                 </a:solidFill>
@@ -5656,7 +5704,7 @@
           <a:p>
             <a:pPr algn="l"/>
             <a:r>
-              <a:rPr sz="3200" b="0" i="0">
+              <a:rPr sz="2690" b="0" i="0">
                 <a:solidFill>
                   <a:srgbClr val="111A20"/>
                 </a:solidFill>
@@ -5691,7 +5739,7 @@
           <a:p>
             <a:pPr algn="l"/>
             <a:r>
-              <a:rPr sz="1200" b="1" i="0" spc="140">
+              <a:rPr sz="1010" b="1" i="0" spc="140">
                 <a:solidFill>
                   <a:srgbClr val="00526F"/>
                 </a:solidFill>
@@ -5733,7 +5781,7 @@
               </a:spcAft>
             </a:pPr>
             <a:r>
-              <a:rPr sz="1650" b="0" i="0">
+              <a:rPr sz="1390" b="0" i="0">
                 <a:solidFill>
                   <a:srgbClr val="111A20"/>
                 </a:solidFill>
@@ -5752,7 +5800,7 @@
               </a:spcAft>
             </a:pPr>
             <a:r>
-              <a:rPr sz="1650" b="0" i="0">
+              <a:rPr sz="1390" b="0" i="0">
                 <a:solidFill>
                   <a:srgbClr val="111A20"/>
                 </a:solidFill>
@@ -5771,7 +5819,7 @@
               </a:spcAft>
             </a:pPr>
             <a:r>
-              <a:rPr sz="1650" b="0" i="0">
+              <a:rPr sz="1390" b="0" i="0">
                 <a:solidFill>
                   <a:srgbClr val="111A20"/>
                 </a:solidFill>
@@ -5830,7 +5878,7 @@
           <a:p>
             <a:pPr algn="r"/>
             <a:r>
-              <a:rPr sz="1100" b="0" i="0">
+              <a:rPr sz="1000" b="0" i="0">
                 <a:solidFill>
                   <a:srgbClr val="5F6F78"/>
                 </a:solidFill>
@@ -5895,7 +5943,7 @@
               </a:lnSpc>
             </a:pPr>
             <a:r>
-              <a:rPr sz="4000" b="0" i="0">
+              <a:rPr sz="3360" b="0" i="0">
                 <a:solidFill>
                   <a:srgbClr val="111A20"/>
                 </a:solidFill>
@@ -5914,8 +5962,8 @@
         </p:nvSpPr>
         <p:spPr>
           <a:xfrm>
-            <a:off x="914400" y="1417320"/>
-            <a:ext cx="10362895" cy="731520"/>
+            <a:off x="914400" y="1463040"/>
+            <a:ext cx="10362895" cy="365760"/>
           </a:xfrm>
           <a:prstGeom prst="rect">
             <a:avLst/>
@@ -5928,19 +5976,15 @@
           </a:bodyPr>
           <a:lstStyle/>
           <a:p>
-            <a:pPr algn="l">
-              <a:lnSpc>
-                <a:spcPct val="112000"/>
-              </a:lnSpc>
-            </a:pPr>
-            <a:r>
-              <a:rPr sz="1600" b="0" i="0">
+            <a:pPr algn="l"/>
+            <a:r>
+              <a:rPr sz="1340" b="0" i="0">
                 <a:solidFill>
                   <a:srgbClr val="5F6F78"/>
                 </a:solidFill>
                 <a:latin typeface="Frutiger"/>
               </a:rPr>
-              <a:t>Its one job so far: for each record, an unsupervised model learns what a typical year looks like, then scores how badly each year fails to fit.</a:t>
+              <a:t>Its one job so far, unsupervised: learn what a typical year looks like, then score how badly each year fits.</a:t>
             </a:r>
           </a:p>
         </p:txBody>
@@ -5993,7 +6037,7 @@
           <a:p>
             <a:pPr algn="l"/>
             <a:r>
-              <a:rPr sz="1500" b="1" i="0">
+              <a:rPr sz="1260" b="1" i="0">
                 <a:solidFill>
                   <a:srgbClr val="111A20"/>
                 </a:solidFill>
@@ -6002,7 +6046,7 @@
               <a:t>The highlighted bar is each station's highest-scoring year. </a:t>
             </a:r>
             <a:r>
-              <a:rPr sz="1500" b="0" i="0">
+              <a:rPr sz="1260" b="0" i="0">
                 <a:solidFill>
                   <a:srgbClr val="111A20"/>
                 </a:solidFill>
@@ -6100,7 +6144,7 @@
           <a:p>
             <a:pPr algn="r"/>
             <a:r>
-              <a:rPr sz="1100" b="0" i="0">
+              <a:rPr sz="1000" b="0" i="0">
                 <a:solidFill>
                   <a:srgbClr val="5F6F78"/>
                 </a:solidFill>
@@ -6165,7 +6209,7 @@
               </a:lnSpc>
             </a:pPr>
             <a:r>
-              <a:rPr sz="4000" b="0" i="0">
+              <a:rPr sz="3360" b="0" i="0">
                 <a:solidFill>
                   <a:srgbClr val="111A20"/>
                 </a:solidFill>
@@ -6184,8 +6228,8 @@
         </p:nvSpPr>
         <p:spPr>
           <a:xfrm>
-            <a:off x="914400" y="1417320"/>
-            <a:ext cx="10362895" cy="731520"/>
+            <a:off x="914400" y="1463040"/>
+            <a:ext cx="10362895" cy="365760"/>
           </a:xfrm>
           <a:prstGeom prst="rect">
             <a:avLst/>
@@ -6198,13 +6242,9 @@
           </a:bodyPr>
           <a:lstStyle/>
           <a:p>
-            <a:pPr algn="l">
-              <a:lnSpc>
-                <a:spcPct val="112000"/>
-              </a:lnSpc>
-            </a:pPr>
-            <a:r>
-              <a:rPr sz="1700" b="0" i="0">
+            <a:pPr algn="l"/>
+            <a:r>
+              <a:rPr sz="1340" b="0" i="0">
                 <a:solidFill>
                   <a:srgbClr val="5F6F78"/>
                 </a:solidFill>
@@ -6274,7 +6314,7 @@
           <a:p>
             <a:pPr algn="l"/>
             <a:r>
-              <a:rPr sz="1200" b="1" i="0" spc="140">
+              <a:rPr sz="1010" b="1" i="0" spc="140">
                 <a:solidFill>
                   <a:srgbClr val="00526F"/>
                 </a:solidFill>
@@ -6313,7 +6353,7 @@
               </a:lnSpc>
             </a:pPr>
             <a:r>
-              <a:rPr sz="2600" b="0" i="0">
+              <a:rPr sz="2180" b="0" i="0">
                 <a:solidFill>
                   <a:srgbClr val="111A20"/>
                 </a:solidFill>
@@ -6355,7 +6395,7 @@
               </a:spcAft>
             </a:pPr>
             <a:r>
-              <a:rPr sz="1550" b="0" i="0">
+              <a:rPr sz="1300" b="0" i="0">
                 <a:solidFill>
                   <a:srgbClr val="111A20"/>
                 </a:solidFill>
@@ -6374,7 +6414,7 @@
               </a:spcAft>
             </a:pPr>
             <a:r>
-              <a:rPr sz="1550" b="0" i="0">
+              <a:rPr sz="1300" b="0" i="0">
                 <a:solidFill>
                   <a:srgbClr val="111A20"/>
                 </a:solidFill>
@@ -6444,7 +6484,7 @@
           <a:p>
             <a:pPr algn="l"/>
             <a:r>
-              <a:rPr sz="1200" b="1" i="0" spc="140">
+              <a:rPr sz="1010" b="1" i="0" spc="140">
                 <a:solidFill>
                   <a:srgbClr val="00526F"/>
                 </a:solidFill>
@@ -6483,7 +6523,7 @@
               </a:lnSpc>
             </a:pPr>
             <a:r>
-              <a:rPr sz="2600" b="0" i="0">
+              <a:rPr sz="2180" b="0" i="0">
                 <a:solidFill>
                   <a:srgbClr val="111A20"/>
                 </a:solidFill>
@@ -6525,7 +6565,7 @@
               </a:spcAft>
             </a:pPr>
             <a:r>
-              <a:rPr sz="1550" b="0" i="0">
+              <a:rPr sz="1300" b="0" i="0">
                 <a:solidFill>
                   <a:srgbClr val="111A20"/>
                 </a:solidFill>
@@ -6544,7 +6584,7 @@
               </a:spcAft>
             </a:pPr>
             <a:r>
-              <a:rPr sz="1550" b="0" i="0">
+              <a:rPr sz="1300" b="0" i="0">
                 <a:solidFill>
                   <a:srgbClr val="111A20"/>
                 </a:solidFill>
@@ -6615,7 +6655,7 @@
           <a:p>
             <a:pPr algn="l"/>
             <a:r>
-              <a:rPr sz="1200" b="1" i="0" spc="140">
+              <a:rPr sz="1010" b="1" i="0" spc="140">
                 <a:solidFill>
                   <a:srgbClr val="5F6F78"/>
                 </a:solidFill>
@@ -6654,7 +6694,7 @@
               </a:lnSpc>
             </a:pPr>
             <a:r>
-              <a:rPr sz="2600" b="0" i="0">
+              <a:rPr sz="2180" b="0" i="0">
                 <a:solidFill>
                   <a:srgbClr val="5F6F78"/>
                 </a:solidFill>
@@ -6696,7 +6736,7 @@
               </a:spcAft>
             </a:pPr>
             <a:r>
-              <a:rPr sz="1550" b="0" i="0">
+              <a:rPr sz="1300" b="0" i="0">
                 <a:solidFill>
                   <a:srgbClr val="5F6F78"/>
                 </a:solidFill>
@@ -6715,7 +6755,7 @@
               </a:spcAft>
             </a:pPr>
             <a:r>
-              <a:rPr sz="1550" b="0" i="0">
+              <a:rPr sz="1300" b="0" i="0">
                 <a:solidFill>
                   <a:srgbClr val="5F6F78"/>
                 </a:solidFill>
@@ -6774,7 +6814,7 @@
           <a:p>
             <a:pPr algn="r"/>
             <a:r>
-              <a:rPr sz="1100" b="0" i="0">
+              <a:rPr sz="1000" b="0" i="0">
                 <a:solidFill>
                   <a:srgbClr val="5F6F78"/>
                 </a:solidFill>
@@ -6839,7 +6879,7 @@
               </a:lnSpc>
             </a:pPr>
             <a:r>
-              <a:rPr sz="4000" b="0" i="0">
+              <a:rPr sz="3360" b="0" i="0">
                 <a:solidFill>
                   <a:srgbClr val="111A20"/>
                 </a:solidFill>
@@ -6858,8 +6898,8 @@
         </p:nvSpPr>
         <p:spPr>
           <a:xfrm>
-            <a:off x="914400" y="1417320"/>
-            <a:ext cx="10362895" cy="731520"/>
+            <a:off x="914400" y="1463040"/>
+            <a:ext cx="10362895" cy="365760"/>
           </a:xfrm>
           <a:prstGeom prst="rect">
             <a:avLst/>
@@ -6872,13 +6912,9 @@
           </a:bodyPr>
           <a:lstStyle/>
           <a:p>
-            <a:pPr algn="l">
-              <a:lnSpc>
-                <a:spcPct val="112000"/>
-              </a:lnSpc>
-            </a:pPr>
-            <a:r>
-              <a:rPr sz="1700" b="0" i="0">
+            <a:pPr algn="l"/>
+            <a:r>
+              <a:rPr sz="1340" b="0" i="0">
                 <a:solidFill>
                   <a:srgbClr val="5F6F78"/>
                 </a:solidFill>
@@ -6948,7 +6984,7 @@
           <a:p>
             <a:pPr algn="l"/>
             <a:r>
-              <a:rPr sz="1200" b="1" i="0" spc="140">
+              <a:rPr sz="1010" b="1" i="0" spc="140">
                 <a:solidFill>
                   <a:srgbClr val="00526F"/>
                 </a:solidFill>
@@ -6987,7 +7023,7 @@
               </a:lnSpc>
             </a:pPr>
             <a:r>
-              <a:rPr sz="2200" b="0" i="0">
+              <a:rPr sz="1850" b="0" i="0">
                 <a:solidFill>
                   <a:srgbClr val="111A20"/>
                 </a:solidFill>
@@ -7026,7 +7062,7 @@
               </a:lnSpc>
             </a:pPr>
             <a:r>
-              <a:rPr sz="1400" b="0" i="0">
+              <a:rPr sz="1180" b="0" i="0">
                 <a:solidFill>
                   <a:srgbClr val="5F6F78"/>
                 </a:solidFill>
@@ -7096,7 +7132,7 @@
           <a:p>
             <a:pPr algn="l"/>
             <a:r>
-              <a:rPr sz="1200" b="1" i="0" spc="140">
+              <a:rPr sz="1010" b="1" i="0" spc="140">
                 <a:solidFill>
                   <a:srgbClr val="00526F"/>
                 </a:solidFill>
@@ -7135,7 +7171,7 @@
               </a:lnSpc>
             </a:pPr>
             <a:r>
-              <a:rPr sz="2200" b="0" i="0">
+              <a:rPr sz="1850" b="0" i="0">
                 <a:solidFill>
                   <a:srgbClr val="111A20"/>
                 </a:solidFill>
@@ -7174,7 +7210,7 @@
               </a:lnSpc>
             </a:pPr>
             <a:r>
-              <a:rPr sz="1400" b="0" i="0">
+              <a:rPr sz="1180" b="0" i="0">
                 <a:solidFill>
                   <a:srgbClr val="5F6F78"/>
                 </a:solidFill>
@@ -7244,7 +7280,7 @@
           <a:p>
             <a:pPr algn="l"/>
             <a:r>
-              <a:rPr sz="1200" b="1" i="0" spc="140">
+              <a:rPr sz="1010" b="1" i="0" spc="140">
                 <a:solidFill>
                   <a:srgbClr val="00526F"/>
                 </a:solidFill>
@@ -7283,7 +7319,7 @@
               </a:lnSpc>
             </a:pPr>
             <a:r>
-              <a:rPr sz="2200" b="0" i="0">
+              <a:rPr sz="1850" b="0" i="0">
                 <a:solidFill>
                   <a:srgbClr val="111A20"/>
                 </a:solidFill>
@@ -7322,7 +7358,7 @@
               </a:lnSpc>
             </a:pPr>
             <a:r>
-              <a:rPr sz="1400" b="0" i="0">
+              <a:rPr sz="1180" b="0" i="0">
                 <a:solidFill>
                   <a:srgbClr val="5F6F78"/>
                 </a:solidFill>
@@ -7396,7 +7432,7 @@
               </a:lnSpc>
             </a:pPr>
             <a:r>
-              <a:rPr sz="1400" b="1" i="0" spc="100">
+              <a:rPr sz="1180" b="1" i="0" spc="100">
                 <a:solidFill>
                   <a:srgbClr val="00526F"/>
                 </a:solidFill>
@@ -7405,7 +7441,7 @@
               <a:t>Next  </a:t>
             </a:r>
             <a:r>
-              <a:rPr sz="1800" b="0" i="0">
+              <a:rPr sz="1510" b="0" i="0">
                 <a:solidFill>
                   <a:srgbClr val="111A20"/>
                 </a:solidFill>
@@ -7440,7 +7476,7 @@
           <a:p>
             <a:pPr algn="r"/>
             <a:r>
-              <a:rPr sz="1100" b="1" i="0">
+              <a:rPr sz="1000" b="1" i="0">
                 <a:solidFill>
                   <a:srgbClr val="00526F"/>
                 </a:solidFill>
@@ -7499,7 +7535,7 @@
           <a:p>
             <a:pPr algn="r"/>
             <a:r>
-              <a:rPr sz="1100" b="0" i="0">
+              <a:rPr sz="1000" b="0" i="0">
                 <a:solidFill>
                   <a:srgbClr val="5F6F78"/>
                 </a:solidFill>

</xml_diff>